<commit_message>
Deck: neutral author metadata
Co-Authored-By: Claude Sonnet 5.5 <noreply@anthropic.com>
Claude-Session: https://claude.ai/code/session_01MpvnYWzvWhixwcFeFULcu6
</commit_message>
<xml_diff>
--- a/docs/presentation/SwiftServe_Presentation.pptx
+++ b/docs/presentation/SwiftServe_Presentation.pptx
@@ -119,14 +119,14 @@
   <p:extLst>
     <p:ext uri="{521415D9-36F7-43E2-AB2F-B90AF26B5E84}">
       <p14:sectionLst xmlns:p14="http://schemas.microsoft.com/office/powerpoint/2010/main">
-        <p14:section name="Context" id="{5ceec09d-f05d-59ec-07b3-46821b39272b}">
+        <p14:section name="Context" id="{c539bc58-b576-c4e8-691c-a65f60ba4970}">
           <p14:sldIdLst>
             <p14:sldId id="256"/>
             <p14:sldId id="257"/>
             <p14:sldId id="258"/>
           </p14:sldIdLst>
         </p14:section>
-        <p14:section name="Approach" id="{93e677ed-be3a-5918-30e2-45f154ba9e0b}">
+        <p14:section name="Approach" id="{231248a7-a401-9724-f437-67100ae3fc62}">
           <p14:sldIdLst>
             <p14:sldId id="259"/>
             <p14:sldId id="260"/>
@@ -134,7 +134,7 @@
             <p14:sldId id="262"/>
           </p14:sldIdLst>
         </p14:section>
-        <p14:section name="Evidence" id="{ff1fb448-2d6a-8eee-a7b4-76c3d75fdfec}">
+        <p14:section name="Evidence" id="{89166efa-3671-1b49-87ea-85854a37e707}">
           <p14:sldIdLst>
             <p14:sldId id="263"/>
             <p14:sldId id="264"/>
@@ -142,7 +142,7 @@
             <p14:sldId id="266"/>
           </p14:sldIdLst>
         </p14:section>
-        <p14:section name="Close" id="{96deeedc-daa1-fb5f-25d0-d9e8cc2ccf75}">
+        <p14:section name="Close" id="{1f3e8ba1-22f0-ab92-dab9-b000bc733957}">
           <p14:sldIdLst>
             <p14:sldId id="267"/>
             <p14:sldId id="268"/>

</xml_diff>

<commit_message>
Add Compare tab and guarded runtime policy switch for side-by-side policy comparison
POST /api/policy (off by default; dev.py enables it on loopback) swaps in a fresh policy.
The Compare tab runs one seeded multi-tenant workload through every policy, each in its own
prompt namespace, and tabulates router-measured TTFT, cache reuse and load balance.

Co-Authored-By: Claude Sonnet 5.5 <noreply@anthropic.com>
Claude-Session: https://claude.ai/code/session_01MpvnYWzvWhixwcFeFULcu6
</commit_message>
<xml_diff>
--- a/docs/presentation/SwiftServe_Presentation.pptx
+++ b/docs/presentation/SwiftServe_Presentation.pptx
@@ -123,14 +123,14 @@
   <p:extLst>
     <p:ext uri="{521415D9-36F7-43E2-AB2F-B90AF26B5E84}">
       <p14:sectionLst xmlns:p14="http://schemas.microsoft.com/office/powerpoint/2010/main">
-        <p14:section name="Context" id="{8605029b-5542-4297-c1c1-0ed952273bc1}">
+        <p14:section name="Context" id="{e2e9c3cb-c537-70a0-7010-d07e247e05cc}">
           <p14:sldIdLst>
             <p14:sldId id="256"/>
             <p14:sldId id="257"/>
             <p14:sldId id="258"/>
           </p14:sldIdLst>
         </p14:section>
-        <p14:section name="Approach" id="{fc537839-626f-c0a7-b02e-58499e6189a3}">
+        <p14:section name="Approach" id="{7a4b4efd-8244-45c7-24a3-610265ee5604}">
           <p14:sldIdLst>
             <p14:sldId id="259"/>
             <p14:sldId id="260"/>
@@ -141,7 +141,7 @@
             <p14:sldId id="265"/>
           </p14:sldIdLst>
         </p14:section>
-        <p14:section name="Evidence" id="{a454a722-92db-0608-2893-f5b24a928b25}">
+        <p14:section name="Evidence" id="{53a8e9e7-e111-228e-cb58-b23185a49b55}">
           <p14:sldIdLst>
             <p14:sldId id="266"/>
             <p14:sldId id="267"/>
@@ -150,7 +150,7 @@
             <p14:sldId id="270"/>
           </p14:sldIdLst>
         </p14:section>
-        <p14:section name="Close" id="{a5446f82-0ba0-37e1-1bcb-7c2059a8b040}">
+        <p14:section name="Close" id="{f47a2ffd-0faf-dd0a-2a0c-780ea15a1444}">
           <p14:sldIdLst>
             <p14:sldId id="271"/>
             <p14:sldId id="272"/>
@@ -1364,7 +1364,7 @@
           <a:p>
             <a:r>
               <a:rPr lang="en-US" dirty="0"/>
-              <a:t>Run the demonstration in this order. Start on the dashboard to show the real GPUs and their memory and temperature. Then use the playground to send the same long system prompt twice and point at the cached token count and the time to first token. Finish with the load test and the live routing view to show concurrent requests being spread across replicas.</a:t>
+              <a:t>Run the demonstration in this order. Start on the dashboard to show the real GPUs and their memory and temperature. Then use the playground to send the same long system prompt twice and point at the cached token count and the time to first token. Open the Compare tab and run all four policies on the same workload; the table shows the difference side by side. Keep the live routing view open while it runs to show requests spreading across replicas.</a:t>
             </a:r>
             <a:endParaRPr lang="en-US" dirty="0"/>
           </a:p>
@@ -7515,7 +7515,7 @@
                           <a:ea typeface="Calibri" pitchFamily="34" charset="-122"/>
                           <a:cs typeface="Calibri" pitchFamily="34" charset="-120"/>
                         </a:rPr>
-                        <a:t>One command runs round_robin, least_connections, swiftserve and prefix_aware in turn</a:t>
+                        <a:t>The console's Compare tab (or scripts/demo.py) runs round_robin, least_connections, swiftserve and prefix_aware in turn</a:t>
                       </a:r>
                       <a:endParaRPr lang="en-US" sz="1200" dirty="0">
                         <a:latin typeface="Calibri" charset="0"/>
@@ -8174,11 +8174,11 @@
         <p:spPr>
           <a:xfrm>
             <a:off x="457200" y="1143000"/>
-            <a:ext cx="2560320" cy="1325880"/>
+            <a:ext cx="1920240" cy="1463040"/>
           </a:xfrm>
           <a:prstGeom prst="roundRect">
             <a:avLst>
-              <a:gd name="adj" fmla="val 5517"/>
+              <a:gd name="adj" fmla="val 5000"/>
             </a:avLst>
           </a:prstGeom>
           <a:solidFill>
@@ -8207,7 +8207,7 @@
         </p:nvSpPr>
         <p:spPr>
           <a:xfrm>
-            <a:off x="594360" y="1252728"/>
+            <a:off x="566928" y="1252728"/>
             <a:ext cx="365760" cy="365760"/>
           </a:xfrm>
           <a:prstGeom prst="ellipse">
@@ -8232,7 +8232,7 @@
         </p:nvSpPr>
         <p:spPr>
           <a:xfrm>
-            <a:off x="594360" y="1252728"/>
+            <a:off x="566928" y="1252728"/>
             <a:ext cx="365760" cy="365760"/>
           </a:xfrm>
           <a:prstGeom prst="rect">
@@ -8271,8 +8271,8 @@
         </p:nvSpPr>
         <p:spPr>
           <a:xfrm>
-            <a:off x="1097280" y="1252728"/>
-            <a:ext cx="1828800" cy="365760"/>
+            <a:off x="1005840" y="1252728"/>
+            <a:ext cx="1325880" cy="365760"/>
           </a:xfrm>
           <a:prstGeom prst="rect">
             <a:avLst/>
@@ -8288,7 +8288,7 @@
               <a:buNone/>
             </a:pPr>
             <a:r>
-              <a:rPr lang="en-US" sz="1600" b="1" dirty="0">
+              <a:rPr lang="en-US" sz="1500" b="1" dirty="0">
                 <a:solidFill>
                   <a:schemeClr val="tx1"/>
                 </a:solidFill>
@@ -8298,7 +8298,7 @@
               </a:rPr>
               <a:t>Dashboard</a:t>
             </a:r>
-            <a:endParaRPr lang="en-US" sz="1600" dirty="0"/>
+            <a:endParaRPr lang="en-US" sz="1500" dirty="0"/>
           </a:p>
         </p:txBody>
       </p:sp>
@@ -8310,8 +8310,8 @@
         </p:nvSpPr>
         <p:spPr>
           <a:xfrm>
-            <a:off x="594360" y="1719072"/>
-            <a:ext cx="2286000" cy="685800"/>
+            <a:off x="566928" y="1709928"/>
+            <a:ext cx="1737360" cy="868680"/>
           </a:xfrm>
           <a:prstGeom prst="rect">
             <a:avLst/>
@@ -8327,7 +8327,7 @@
               <a:buNone/>
             </a:pPr>
             <a:r>
-              <a:rPr lang="en-US" sz="1400" dirty="0">
+              <a:rPr lang="en-US" sz="1300" dirty="0">
                 <a:solidFill>
                   <a:schemeClr val="tx2"/>
                 </a:solidFill>
@@ -8337,7 +8337,7 @@
               </a:rPr>
               <a:t>four GPUs with memory and temperature reported by each node</a:t>
             </a:r>
-            <a:endParaRPr lang="en-US" sz="1400" dirty="0"/>
+            <a:endParaRPr lang="en-US" sz="1300" dirty="0"/>
           </a:p>
         </p:txBody>
       </p:sp>
@@ -8349,12 +8349,12 @@
         </p:nvSpPr>
         <p:spPr>
           <a:xfrm>
-            <a:off x="3291840" y="1143000"/>
-            <a:ext cx="2560320" cy="1325880"/>
+            <a:off x="2542032" y="1143000"/>
+            <a:ext cx="1920240" cy="1463040"/>
           </a:xfrm>
           <a:prstGeom prst="roundRect">
             <a:avLst>
-              <a:gd name="adj" fmla="val 5517"/>
+              <a:gd name="adj" fmla="val 5000"/>
             </a:avLst>
           </a:prstGeom>
           <a:solidFill>
@@ -8383,7 +8383,7 @@
         </p:nvSpPr>
         <p:spPr>
           <a:xfrm>
-            <a:off x="3429000" y="1252728"/>
+            <a:off x="2651760" y="1252728"/>
             <a:ext cx="365760" cy="365760"/>
           </a:xfrm>
           <a:prstGeom prst="ellipse">
@@ -8408,7 +8408,7 @@
         </p:nvSpPr>
         <p:spPr>
           <a:xfrm>
-            <a:off x="3429000" y="1252728"/>
+            <a:off x="2651760" y="1252728"/>
             <a:ext cx="365760" cy="365760"/>
           </a:xfrm>
           <a:prstGeom prst="rect">
@@ -8447,8 +8447,8 @@
         </p:nvSpPr>
         <p:spPr>
           <a:xfrm>
-            <a:off x="3931920" y="1252728"/>
-            <a:ext cx="1828800" cy="365760"/>
+            <a:off x="3090672" y="1252728"/>
+            <a:ext cx="1325880" cy="365760"/>
           </a:xfrm>
           <a:prstGeom prst="rect">
             <a:avLst/>
@@ -8464,7 +8464,7 @@
               <a:buNone/>
             </a:pPr>
             <a:r>
-              <a:rPr lang="en-US" sz="1600" b="1" dirty="0">
+              <a:rPr lang="en-US" sz="1500" b="1" dirty="0">
                 <a:solidFill>
                   <a:schemeClr val="tx1"/>
                 </a:solidFill>
@@ -8474,7 +8474,7 @@
               </a:rPr>
               <a:t>Playground</a:t>
             </a:r>
-            <a:endParaRPr lang="en-US" sz="1600" dirty="0"/>
+            <a:endParaRPr lang="en-US" sz="1500" dirty="0"/>
           </a:p>
         </p:txBody>
       </p:sp>
@@ -8486,8 +8486,8 @@
         </p:nvSpPr>
         <p:spPr>
           <a:xfrm>
-            <a:off x="3429000" y="1719072"/>
-            <a:ext cx="2286000" cy="685800"/>
+            <a:off x="2651760" y="1709928"/>
+            <a:ext cx="1737360" cy="868680"/>
           </a:xfrm>
           <a:prstGeom prst="rect">
             <a:avLst/>
@@ -8503,7 +8503,7 @@
               <a:buNone/>
             </a:pPr>
             <a:r>
-              <a:rPr lang="en-US" sz="1400" dirty="0">
+              <a:rPr lang="en-US" sz="1300" dirty="0">
                 <a:solidFill>
                   <a:schemeClr val="tx2"/>
                 </a:solidFill>
@@ -8513,7 +8513,7 @@
               </a:rPr>
               <a:t>one request twice: cold, then with the prefix cached</a:t>
             </a:r>
-            <a:endParaRPr lang="en-US" sz="1400" dirty="0"/>
+            <a:endParaRPr lang="en-US" sz="1300" dirty="0"/>
           </a:p>
         </p:txBody>
       </p:sp>
@@ -8525,12 +8525,12 @@
         </p:nvSpPr>
         <p:spPr>
           <a:xfrm>
-            <a:off x="6126480" y="1143000"/>
-            <a:ext cx="2560320" cy="1325880"/>
+            <a:off x="4626864" y="1143000"/>
+            <a:ext cx="1920240" cy="1463040"/>
           </a:xfrm>
           <a:prstGeom prst="roundRect">
             <a:avLst>
-              <a:gd name="adj" fmla="val 5517"/>
+              <a:gd name="adj" fmla="val 5000"/>
             </a:avLst>
           </a:prstGeom>
           <a:solidFill>
@@ -8559,7 +8559,7 @@
         </p:nvSpPr>
         <p:spPr>
           <a:xfrm>
-            <a:off x="6263640" y="1252728"/>
+            <a:off x="4736592" y="1252728"/>
             <a:ext cx="365760" cy="365760"/>
           </a:xfrm>
           <a:prstGeom prst="ellipse">
@@ -8584,7 +8584,7 @@
         </p:nvSpPr>
         <p:spPr>
           <a:xfrm>
-            <a:off x="6263640" y="1252728"/>
+            <a:off x="4736592" y="1252728"/>
             <a:ext cx="365760" cy="365760"/>
           </a:xfrm>
           <a:prstGeom prst="rect">
@@ -8623,8 +8623,8 @@
         </p:nvSpPr>
         <p:spPr>
           <a:xfrm>
-            <a:off x="6766560" y="1252728"/>
-            <a:ext cx="1828800" cy="365760"/>
+            <a:off x="5175504" y="1252728"/>
+            <a:ext cx="1325880" cy="365760"/>
           </a:xfrm>
           <a:prstGeom prst="rect">
             <a:avLst/>
@@ -8640,7 +8640,7 @@
               <a:buNone/>
             </a:pPr>
             <a:r>
-              <a:rPr lang="en-US" sz="1600" b="1" dirty="0">
+              <a:rPr lang="en-US" sz="1500" b="1" dirty="0">
                 <a:solidFill>
                   <a:schemeClr val="tx1"/>
                 </a:solidFill>
@@ -8648,9 +8648,9 @@
                 <a:ea typeface="Calibri" pitchFamily="34" charset="-122"/>
                 <a:cs typeface="Calibri" pitchFamily="34" charset="-120"/>
               </a:rPr>
-              <a:t>Load test</a:t>
-            </a:r>
-            <a:endParaRPr lang="en-US" sz="1600" dirty="0"/>
+              <a:t>Compare</a:t>
+            </a:r>
+            <a:endParaRPr lang="en-US" sz="1500" dirty="0"/>
           </a:p>
         </p:txBody>
       </p:sp>
@@ -8662,8 +8662,8 @@
         </p:nvSpPr>
         <p:spPr>
           <a:xfrm>
-            <a:off x="6263640" y="1719072"/>
-            <a:ext cx="2286000" cy="685800"/>
+            <a:off x="4736592" y="1709928"/>
+            <a:ext cx="1737360" cy="868680"/>
           </a:xfrm>
           <a:prstGeom prst="rect">
             <a:avLst/>
@@ -8679,7 +8679,7 @@
               <a:buNone/>
             </a:pPr>
             <a:r>
-              <a:rPr lang="en-US" sz="1400" dirty="0">
+              <a:rPr lang="en-US" sz="1300" dirty="0">
                 <a:solidFill>
                   <a:schemeClr val="tx2"/>
                 </a:solidFill>
@@ -8687,15 +8687,191 @@
                 <a:ea typeface="Calibri" pitchFamily="34" charset="-122"/>
                 <a:cs typeface="Calibri" pitchFamily="34" charset="-120"/>
               </a:rPr>
-              <a:t>sixty concurrent requests spread across the replicas</a:t>
+              <a:t>the same multi-tenant workload through all four policies</a:t>
+            </a:r>
+            <a:endParaRPr lang="en-US" sz="1300" dirty="0"/>
+          </a:p>
+        </p:txBody>
+      </p:sp>
+      <p:sp>
+        <p:nvSpPr>
+          <p:cNvPr id="18" name="Demo step 4"/>
+          <p:cNvSpPr/>
+          <p:nvPr/>
+        </p:nvSpPr>
+        <p:spPr>
+          <a:xfrm>
+            <a:off x="6711696" y="1143000"/>
+            <a:ext cx="1920240" cy="1463040"/>
+          </a:xfrm>
+          <a:prstGeom prst="roundRect">
+            <a:avLst>
+              <a:gd name="adj" fmla="val 5000"/>
+            </a:avLst>
+          </a:prstGeom>
+          <a:solidFill>
+            <a:schemeClr val="bg2"/>
+          </a:solidFill>
+          <a:ln w="12700">
+            <a:solidFill>
+              <a:schemeClr val="bg2"/>
+            </a:solidFill>
+            <a:prstDash val="solid"/>
+          </a:ln>
+          <a:effectLst>
+            <a:outerShdw sx="100000" sy="100000" kx="0" ky="0" algn="bl" rotWithShape="0" blurRad="101600" dist="25400" dir="5400000">
+              <a:srgbClr val="000000">
+                <a:alpha val="12000"/>
+              </a:srgbClr>
+            </a:outerShdw>
+          </a:effectLst>
+        </p:spPr>
+      </p:sp>
+      <p:sp>
+        <p:nvSpPr>
+          <p:cNvPr id="19" name="Demo step 4 number"/>
+          <p:cNvSpPr/>
+          <p:nvPr/>
+        </p:nvSpPr>
+        <p:spPr>
+          <a:xfrm>
+            <a:off x="6821424" y="1252728"/>
+            <a:ext cx="365760" cy="365760"/>
+          </a:xfrm>
+          <a:prstGeom prst="ellipse">
+            <a:avLst/>
+          </a:prstGeom>
+          <a:solidFill>
+            <a:schemeClr val="accent1"/>
+          </a:solidFill>
+          <a:ln w="12700">
+            <a:solidFill>
+              <a:schemeClr val="accent1"/>
+            </a:solidFill>
+            <a:prstDash val="solid"/>
+          </a:ln>
+        </p:spPr>
+      </p:sp>
+      <p:sp>
+        <p:nvSpPr>
+          <p:cNvPr id="20" name="Text 18"/>
+          <p:cNvSpPr txBox="1"/>
+          <p:nvPr/>
+        </p:nvSpPr>
+        <p:spPr>
+          <a:xfrm>
+            <a:off x="6821424" y="1252728"/>
+            <a:ext cx="365760" cy="365760"/>
+          </a:xfrm>
+          <a:prstGeom prst="rect">
+            <a:avLst/>
+          </a:prstGeom>
+          <a:noFill/>
+          <a:ln/>
+        </p:spPr>
+        <p:txBody>
+          <a:bodyPr wrap="square" lIns="0" tIns="0" rIns="0" bIns="0" rtlCol="0" anchor="ctr"/>
+          <a:lstStyle/>
+          <a:p>
+            <a:pPr algn="ctr" indent="0" marL="0">
+              <a:buNone/>
+            </a:pPr>
+            <a:r>
+              <a:rPr lang="en-US" sz="1400" b="1" dirty="0">
+                <a:solidFill>
+                  <a:schemeClr val="bg1"/>
+                </a:solidFill>
+                <a:latin typeface="Calibri" pitchFamily="34" charset="0"/>
+                <a:ea typeface="Calibri" pitchFamily="34" charset="-122"/>
+                <a:cs typeface="Calibri" pitchFamily="34" charset="-120"/>
+              </a:rPr>
+              <a:t>4</a:t>
             </a:r>
             <a:endParaRPr lang="en-US" sz="1400" dirty="0"/>
+          </a:p>
+        </p:txBody>
+      </p:sp>
+      <p:sp>
+        <p:nvSpPr>
+          <p:cNvPr id="21" name="Text 19"/>
+          <p:cNvSpPr txBox="1"/>
+          <p:nvPr/>
+        </p:nvSpPr>
+        <p:spPr>
+          <a:xfrm>
+            <a:off x="7260336" y="1252728"/>
+            <a:ext cx="1325880" cy="365760"/>
+          </a:xfrm>
+          <a:prstGeom prst="rect">
+            <a:avLst/>
+          </a:prstGeom>
+          <a:noFill/>
+          <a:ln/>
+        </p:spPr>
+        <p:txBody>
+          <a:bodyPr wrap="square" lIns="0" tIns="0" rIns="0" bIns="0" rtlCol="0" anchor="ctr"/>
+          <a:lstStyle/>
+          <a:p>
+            <a:pPr indent="0" marL="0">
+              <a:buNone/>
+            </a:pPr>
+            <a:r>
+              <a:rPr lang="en-US" sz="1500" b="1" dirty="0">
+                <a:solidFill>
+                  <a:schemeClr val="tx1"/>
+                </a:solidFill>
+                <a:latin typeface="Calibri" pitchFamily="34" charset="0"/>
+                <a:ea typeface="Calibri" pitchFamily="34" charset="-122"/>
+                <a:cs typeface="Calibri" pitchFamily="34" charset="-120"/>
+              </a:rPr>
+              <a:t>Live routing</a:t>
+            </a:r>
+            <a:endParaRPr lang="en-US" sz="1500" dirty="0"/>
+          </a:p>
+        </p:txBody>
+      </p:sp>
+      <p:sp>
+        <p:nvSpPr>
+          <p:cNvPr id="22" name="Text 20"/>
+          <p:cNvSpPr txBox="1"/>
+          <p:nvPr/>
+        </p:nvSpPr>
+        <p:spPr>
+          <a:xfrm>
+            <a:off x="6821424" y="1709928"/>
+            <a:ext cx="1737360" cy="868680"/>
+          </a:xfrm>
+          <a:prstGeom prst="rect">
+            <a:avLst/>
+          </a:prstGeom>
+          <a:noFill/>
+          <a:ln/>
+        </p:spPr>
+        <p:txBody>
+          <a:bodyPr wrap="square" lIns="0" tIns="0" rIns="0" bIns="0" rtlCol="0" anchor="t"/>
+          <a:lstStyle/>
+          <a:p>
+            <a:pPr indent="0" marL="0">
+              <a:buNone/>
+            </a:pPr>
+            <a:r>
+              <a:rPr lang="en-US" sz="1300" dirty="0">
+                <a:solidFill>
+                  <a:schemeClr val="tx2"/>
+                </a:solidFill>
+                <a:latin typeface="Calibri" pitchFamily="34" charset="0"/>
+                <a:ea typeface="Calibri" pitchFamily="34" charset="-122"/>
+                <a:cs typeface="Calibri" pitchFamily="34" charset="-120"/>
+              </a:rPr>
+              <a:t>requests spreading across the replicas as they run</a:t>
+            </a:r>
+            <a:endParaRPr lang="en-US" sz="1300" dirty="0"/>
           </a:p>
         </p:txBody>
       </p:sp>
       <p:pic>
         <p:nvPicPr>
-          <p:cNvPr id="18" name="Dashboard screenshot" descr="Dashboard screenshot">    </p:cNvPr>
+          <p:cNvPr id="23" name="Dashboard screenshot" descr="Dashboard screenshot">    </p:cNvPr>
           <p:cNvPicPr>
             <a:picLocks noChangeAspect="1"/>
           </p:cNvPicPr>
@@ -8709,7 +8885,7 @@
         </p:blipFill>
         <p:spPr>
           <a:xfrm>
-            <a:off x="457200" y="2803998"/>
+            <a:off x="457200" y="2895438"/>
             <a:ext cx="8229600" cy="1707204"/>
           </a:xfrm>
           <a:prstGeom prst="rect">

</xml_diff>

<commit_message>
Compare export includes per-request rows; record first real four-policy comparison in docs and deck
Co-Authored-By: Claude Sonnet 5.5 <noreply@anthropic.com>
Claude-Session: https://claude.ai/code/session_01MpvnYWzvWhixwcFeFULcu6
</commit_message>
<xml_diff>
--- a/docs/presentation/SwiftServe_Presentation.pptx
+++ b/docs/presentation/SwiftServe_Presentation.pptx
@@ -22,9 +22,10 @@
     <p:sldId id="270" r:id="rId16"/>
     <p:sldId id="271" r:id="rId17"/>
     <p:sldId id="272" r:id="rId18"/>
+    <p:sldId id="273" r:id="rId19"/>
   </p:sldIdLst>
   <p:notesMasterIdLst>
-    <p:notesMasterId r:id="rId19"/>
+    <p:notesMasterId r:id="rId20"/>
   </p:notesMasterIdLst>
   <p:sldSz cx="9144000" cy="5143500"/>
   <p:notesSz cx="5143500" cy="9144000"/>
@@ -123,14 +124,14 @@
   <p:extLst>
     <p:ext uri="{521415D9-36F7-43E2-AB2F-B90AF26B5E84}">
       <p14:sectionLst xmlns:p14="http://schemas.microsoft.com/office/powerpoint/2010/main">
-        <p14:section name="Context" id="{e2e9c3cb-c537-70a0-7010-d07e247e05cc}">
+        <p14:section name="Context" id="{f15dc4b4-2cd2-5a49-9c3f-dbbbcef8eb52}">
           <p14:sldIdLst>
             <p14:sldId id="256"/>
             <p14:sldId id="257"/>
             <p14:sldId id="258"/>
           </p14:sldIdLst>
         </p14:section>
-        <p14:section name="Approach" id="{7a4b4efd-8244-45c7-24a3-610265ee5604}">
+        <p14:section name="Approach" id="{d9ac31fb-8c7d-b11a-7984-4f979a278d38}">
           <p14:sldIdLst>
             <p14:sldId id="259"/>
             <p14:sldId id="260"/>
@@ -141,19 +142,20 @@
             <p14:sldId id="265"/>
           </p14:sldIdLst>
         </p14:section>
-        <p14:section name="Evidence" id="{53a8e9e7-e111-228e-cb58-b23185a49b55}">
+        <p14:section name="Evidence" id="{2501a7d5-2567-18fe-d5a6-95622064186f}">
           <p14:sldIdLst>
             <p14:sldId id="266"/>
             <p14:sldId id="267"/>
             <p14:sldId id="268"/>
             <p14:sldId id="269"/>
             <p14:sldId id="270"/>
+            <p14:sldId id="271"/>
           </p14:sldIdLst>
         </p14:section>
-        <p14:section name="Close" id="{f47a2ffd-0faf-dd0a-2a0c-780ea15a1444}">
+        <p14:section name="Close" id="{3ccbea69-4e26-bbca-5c1d-78b5924e6cf9}">
           <p14:sldIdLst>
-            <p14:sldId id="271"/>
             <p14:sldId id="272"/>
+            <p14:sldId id="273"/>
           </p14:sldIdLst>
         </p14:section>
       </p14:sectionLst>
@@ -441,6 +443,362 @@
 </c:chartSpace>
 </file>
 
+<file path=ppt/charts/chart2.xml><?xml version="1.0" encoding="utf-8"?>
+<c:chartSpace xmlns:c="http://schemas.openxmlformats.org/drawingml/2006/chart" xmlns:a="http://schemas.openxmlformats.org/drawingml/2006/main" xmlns:r="http://schemas.openxmlformats.org/officeDocument/2006/relationships">
+  <c:date1904 val="0"/>
+  <c:roundedCorners val="1"/>
+  <c:chart>
+    <c:autoTitleDeleted val="1"/>
+    <c:plotArea>
+      <c:layout/>
+      <c:barChart>
+        <c:barDir val="col"/>
+        <c:grouping val="clustered"/>
+        <c:varyColors val="0"/>
+        <c:ser>
+          <c:idx val="0"/>
+          <c:order val="0"/>
+          <c:tx>
+            <c:strRef>
+              <c:f>Sheet1!$B$1</c:f>
+              <c:strCache>
+                <c:ptCount val="1"/>
+                <c:pt idx="0">
+                  <c:v>TTFT median (ms)</c:v>
+                </c:pt>
+              </c:strCache>
+            </c:strRef>
+          </c:tx>
+          <c:spPr>
+            <a:solidFill>
+              <a:srgbClr val="0E8F7E"/>
+            </a:solidFill>
+            <a:effectLst/>
+          </c:spPr>
+          <c:invertIfNegative val="0"/>
+          <c:dLbls>
+            <c:numFmt formatCode="#,##0" sourceLinked="0"/>
+            <c:txPr>
+              <a:bodyPr/>
+              <a:lstStyle/>
+              <a:p>
+                <a:pPr>
+                  <a:defRPr b="0" i="0" strike="noStrike" sz="1100" u="none">
+                    <a:solidFill>
+                      <a:srgbClr val="1B1F2A"/>
+                    </a:solidFill>
+                    <a:latin typeface="+mn-lt"/>
+                  </a:defRPr>
+                </a:pPr>
+              </a:p>
+            </c:txPr>
+            <c:showLegendKey val="0"/>
+            <c:showVal val="1"/>
+            <c:showCatName val="0"/>
+            <c:showSerName val="0"/>
+            <c:showPercent val="0"/>
+            <c:showBubbleSize val="0"/>
+            <c:showLeaderLines val="0"/>
+          </c:dLbls>
+          <c:cat>
+            <c:multiLvlStrRef>
+              <c:f>Sheet1!$A$2:$A$5</c:f>
+              <c:multiLvlStrCache>
+                <c:ptCount val="4"/>
+                <c:lvl>
+                  <c:pt idx="0">
+                    <c:v>round_robin</c:v>
+                  </c:pt>
+                  <c:pt idx="1">
+                    <c:v>least_connections</c:v>
+                  </c:pt>
+                  <c:pt idx="2">
+                    <c:v>swiftserve</c:v>
+                  </c:pt>
+                  <c:pt idx="3">
+                    <c:v>prefix_aware</c:v>
+                  </c:pt>
+                </c:lvl>
+              </c:multiLvlStrCache>
+            </c:multiLvlStrRef>
+          </c:cat>
+          <c:val>
+            <c:numRef>
+              <c:f>Sheet1!$B$2:$B$5</c:f>
+              <c:numCache>
+                <c:formatCode>General</c:formatCode>
+                <c:ptCount val="4"/>
+                <c:pt idx="0">
+                  <c:v>1033</c:v>
+                </c:pt>
+                <c:pt idx="1">
+                  <c:v>1063</c:v>
+                </c:pt>
+                <c:pt idx="2">
+                  <c:v>537</c:v>
+                </c:pt>
+                <c:pt idx="3">
+                  <c:v>464</c:v>
+                </c:pt>
+              </c:numCache>
+            </c:numRef>
+          </c:val>
+        </c:ser>
+        <c:ser>
+          <c:idx val="1"/>
+          <c:order val="1"/>
+          <c:tx>
+            <c:strRef>
+              <c:f>Sheet1!$C$1</c:f>
+              <c:strCache>
+                <c:ptCount val="1"/>
+                <c:pt idx="0">
+                  <c:v>TTFT 95th percentile (ms)</c:v>
+                </c:pt>
+              </c:strCache>
+            </c:strRef>
+          </c:tx>
+          <c:spPr>
+            <a:solidFill>
+              <a:srgbClr val="E8A23B"/>
+            </a:solidFill>
+            <a:effectLst/>
+          </c:spPr>
+          <c:invertIfNegative val="0"/>
+          <c:dLbls>
+            <c:numFmt formatCode="#,##0" sourceLinked="0"/>
+            <c:txPr>
+              <a:bodyPr/>
+              <a:lstStyle/>
+              <a:p>
+                <a:pPr>
+                  <a:defRPr b="0" i="0" strike="noStrike" sz="1100" u="none">
+                    <a:solidFill>
+                      <a:srgbClr val="1B1F2A"/>
+                    </a:solidFill>
+                    <a:latin typeface="+mn-lt"/>
+                  </a:defRPr>
+                </a:pPr>
+              </a:p>
+            </c:txPr>
+            <c:showLegendKey val="0"/>
+            <c:showVal val="1"/>
+            <c:showCatName val="0"/>
+            <c:showSerName val="0"/>
+            <c:showPercent val="0"/>
+            <c:showBubbleSize val="0"/>
+            <c:showLeaderLines val="0"/>
+          </c:dLbls>
+          <c:cat>
+            <c:multiLvlStrRef>
+              <c:f>Sheet1!$A$2:$A$5</c:f>
+              <c:multiLvlStrCache>
+                <c:ptCount val="4"/>
+                <c:lvl>
+                  <c:pt idx="0">
+                    <c:v>round_robin</c:v>
+                  </c:pt>
+                  <c:pt idx="1">
+                    <c:v>least_connections</c:v>
+                  </c:pt>
+                  <c:pt idx="2">
+                    <c:v>swiftserve</c:v>
+                  </c:pt>
+                  <c:pt idx="3">
+                    <c:v>prefix_aware</c:v>
+                  </c:pt>
+                </c:lvl>
+              </c:multiLvlStrCache>
+            </c:multiLvlStrRef>
+          </c:cat>
+          <c:val>
+            <c:numRef>
+              <c:f>Sheet1!$C$2:$C$5</c:f>
+              <c:numCache>
+                <c:formatCode>General</c:formatCode>
+                <c:ptCount val="4"/>
+                <c:pt idx="0">
+                  <c:v>1887</c:v>
+                </c:pt>
+                <c:pt idx="1">
+                  <c:v>1921</c:v>
+                </c:pt>
+                <c:pt idx="2">
+                  <c:v>1690</c:v>
+                </c:pt>
+                <c:pt idx="3">
+                  <c:v>2671</c:v>
+                </c:pt>
+              </c:numCache>
+            </c:numRef>
+          </c:val>
+        </c:ser>
+        <c:dLbls>
+          <c:numFmt formatCode="#,##0" sourceLinked="0"/>
+          <c:txPr>
+            <a:bodyPr/>
+            <a:lstStyle/>
+            <a:p>
+              <a:pPr>
+                <a:defRPr b="0" i="0" strike="noStrike" sz="1100" u="none">
+                  <a:solidFill>
+                    <a:srgbClr val="1B1F2A"/>
+                  </a:solidFill>
+                  <a:latin typeface="+mn-lt"/>
+                </a:defRPr>
+              </a:pPr>
+            </a:p>
+          </c:txPr>
+          <c:showLegendKey val="0"/>
+          <c:showVal val="1"/>
+          <c:showCatName val="0"/>
+          <c:showSerName val="0"/>
+          <c:showPercent val="0"/>
+          <c:showBubbleSize val="0"/>
+          <c:showLeaderLines val="0"/>
+        </c:dLbls>
+        <c:gapWidth val="150"/>
+        <c:overlap val="0"/>
+        <c:axId val="2094734554"/>
+        <c:axId val="2094734552"/>
+        <c:axId val="2094734556"/>
+      </c:barChart>
+      <c:catAx>
+        <c:axId val="2094734554"/>
+        <c:scaling>
+          <c:orientation val="minMax"/>
+        </c:scaling>
+        <c:delete val="0"/>
+        <c:axPos val="b"/>
+        <c:numFmt formatCode="General" sourceLinked="1"/>
+        <c:majorTickMark val="out"/>
+        <c:minorTickMark val="none"/>
+        <c:tickLblPos val="low"/>
+        <c:spPr>
+          <a:ln w="12700" cap="flat">
+            <a:solidFill>
+              <a:srgbClr val="888888"/>
+            </a:solidFill>
+            <a:prstDash val="solid"/>
+            <a:round/>
+          </a:ln>
+        </c:spPr>
+        <c:txPr>
+          <a:bodyPr/>
+          <a:lstStyle/>
+          <a:p>
+            <a:pPr>
+              <a:defRPr sz="1100" b="0" i="0" u="none" strike="noStrike">
+                <a:solidFill>
+                  <a:srgbClr val="3A4457"/>
+                </a:solidFill>
+                <a:latin typeface="+mn-lt"/>
+              </a:defRPr>
+            </a:pPr>
+            <a:endParaRPr lang="en-US"/>
+          </a:p>
+        </c:txPr>
+        <c:crossAx val="2094734552"/>
+        <c:crosses val="autoZero"/>
+        <c:auto val="1"/>
+        <c:lblAlgn val="ctr"/>
+        <c:noMultiLvlLbl val="1"/>
+      </c:catAx>
+      <c:valAx>
+        <c:axId val="2094734552"/>
+        <c:scaling>
+          <c:orientation val="minMax"/>
+          <c:min val="0"/>
+        </c:scaling>
+        <c:delete val="0"/>
+        <c:axPos val="l"/>
+        <c:majorGridlines>
+          <c:spPr>
+            <a:ln w="6350" cap="flat">
+              <a:solidFill>
+                <a:srgbClr val="E1E4EA"/>
+              </a:solidFill>
+              <a:prstDash val="solid"/>
+              <a:round/>
+            </a:ln>
+          </c:spPr>
+        </c:majorGridlines>
+        <c:numFmt formatCode="General" sourceLinked="0"/>
+        <c:majorTickMark val="out"/>
+        <c:minorTickMark val="none"/>
+        <c:tickLblPos val="nextTo"/>
+        <c:spPr>
+          <a:ln w="12700" cap="flat">
+            <a:solidFill>
+              <a:srgbClr val="888888"/>
+            </a:solidFill>
+            <a:prstDash val="solid"/>
+            <a:round/>
+          </a:ln>
+        </c:spPr>
+        <c:txPr>
+          <a:bodyPr/>
+          <a:lstStyle/>
+          <a:p>
+            <a:pPr>
+              <a:defRPr sz="1100" b="0" i="0" u="none" strike="noStrike">
+                <a:solidFill>
+                  <a:srgbClr val="3A4457"/>
+                </a:solidFill>
+                <a:latin typeface="+mn-lt"/>
+              </a:defRPr>
+            </a:pPr>
+            <a:endParaRPr lang="en-US"/>
+          </a:p>
+        </c:txPr>
+        <c:crossAx val="2094734554"/>
+        <c:crosses val="autoZero"/>
+        <c:crossBetween val="between"/>
+      </c:valAx>
+      <c:spPr>
+        <a:noFill/>
+        <a:ln>
+          <a:noFill/>
+        </a:ln>
+        <a:effectLst/>
+      </c:spPr>
+    </c:plotArea>
+    <c:legend>
+      <c:legendPos val="b"/>
+      <c:overlay val="0"/>
+      <c:txPr>
+        <a:bodyPr/>
+        <a:lstStyle/>
+        <a:p>
+          <a:pPr>
+            <a:defRPr sz="1200">
+              <a:solidFill>
+                <a:srgbClr val="3A4457"/>
+              </a:solidFill>
+              <a:latin typeface="+mn-lt"/>
+              <a:cs typeface="+mn-lt"/>
+            </a:defRPr>
+          </a:pPr>
+          <a:endParaRPr lang="en-US"/>
+        </a:p>
+      </c:txPr>
+    </c:legend>
+    <c:plotVisOnly val="1"/>
+    <c:dispBlanksAs val="span"/>
+  </c:chart>
+  <c:spPr>
+    <a:noFill/>
+    <a:ln>
+      <a:noFill/>
+    </a:ln>
+    <a:effectLst/>
+  </c:spPr>
+  <c:externalData r:id="rId1">
+    <c:autoUpdate val="0"/>
+  </c:externalData>
+</c:chartSpace>
+</file>
+
 <file path=ppt/notesMasters/notesMaster1.xml><?xml version="1.0" encoding="utf-8"?>
 <p:notesMaster xmlns:a="http://schemas.openxmlformats.org/drawingml/2006/main" xmlns:r="http://schemas.openxmlformats.org/officeDocument/2006/relationships" xmlns:p="http://schemas.openxmlformats.org/presentationml/2006/main">
   <p:cSld>
@@ -1364,7 +1722,7 @@
           <a:p>
             <a:r>
               <a:rPr lang="en-US" dirty="0"/>
-              <a:t>Run the demonstration in this order. Start on the dashboard to show the real GPUs and their memory and temperature. Then use the playground to send the same long system prompt twice and point at the cached token count and the time to first token. Open the Compare tab and run all four policies on the same workload; the table shows the difference side by side. Keep the live routing view open while it runs to show requests spreading across replicas.</a:t>
+              <a:t>All policies ran the same workload on the same replicas, one after another, each in its own prompt namespace so that none benefited from a cache warmed by an earlier run. Read time to first token first, because that is where prefill savings show up. Cache reuse is the share of prompt tokens the engines reported as cached. Goodput is the share of requests that met both the time-to-first-token and per-token targets. Max-to-mean load shows how evenly requests spread: 1.0 is perfectly even, higher means one replica took more than its share. Compare the median and the 95th percentile separately: a policy can have the best median and a worse tail, because concentrating requests on the replicas that hold a cache can also concentrate queueing. The policies ran one after another in a single run, so this is a controlled demonstration; repeating it with another seed and the order reversed checks that the ranking holds.</a:t>
             </a:r>
             <a:endParaRPr lang="en-US" dirty="0"/>
           </a:p>
@@ -1452,7 +1810,7 @@
           <a:p>
             <a:r>
               <a:rPr lang="en-US" dirty="0"/>
-              <a:t>Be direct about the limitations. The index is a belief about what each replica holds, and it can drift after evictions or failed requests. Retries stay on the same replica. The comparison runs policies one after another, so it is a controlled demonstration rather than a publishable benchmark. The next steps address each of these.</a:t>
+              <a:t>Run the demonstration in this order. Start on the dashboard to show the real GPUs and their memory and temperature. Then use the playground to send the same long system prompt twice and point at the cached token count and the time to first token. Open the Compare tab and run all four policies on the same workload; the table shows the difference side by side. Keep the live routing view open while it runs to show requests spreading across replicas.</a:t>
             </a:r>
             <a:endParaRPr lang="en-US" dirty="0"/>
           </a:p>
@@ -1540,7 +1898,7 @@
           <a:p>
             <a:r>
               <a:rPr lang="en-US" dirty="0"/>
-              <a:t>Close with the three points. Caches are per replica. Routing by prefix and protecting with a latency check lets the router reuse cached work without overloading a replica. And every request is measured, so the claims in this presentation can be checked against recorded data.</a:t>
+              <a:t>Be direct about the limitations. The index is a belief about what each replica holds, and it can drift after evictions or failed requests. Retries stay on the same replica. The comparison runs policies one after another, so it is a controlled demonstration rather than a publishable benchmark. The next steps address each of these.</a:t>
             </a:r>
             <a:endParaRPr lang="en-US" dirty="0"/>
           </a:p>
@@ -1564,6 +1922,94 @@
             <a:fld id="{F7021451-1387-4CA6-816F-3879F97B5CBC}" type="slidenum">
               <a:rPr lang="en-US"/>
               <a:t>17</a:t>
+            </a:fld>
+            <a:endParaRPr lang="en-US"/>
+          </a:p>
+        </p:txBody>
+      </p:sp>
+    </p:spTree>
+    <p:extLst>
+      <p:ext uri="{BB962C8B-B14F-4D97-AF65-F5344CB8AC3E}">
+        <p14:creationId xmlns:p14="http://schemas.microsoft.com/office/powerpoint/2010/main" val="1024086991"/>
+      </p:ext>
+    </p:extLst>
+  </p:cSld>
+  <p:clrMapOvr>
+    <a:masterClrMapping/>
+  </p:clrMapOvr>
+</p:notes>
+</file>
+
+<file path=ppt/notesSlides/notesSlide18.xml><?xml version="1.0" encoding="utf-8"?>
+<p:notes xmlns:a="http://schemas.openxmlformats.org/drawingml/2006/main" xmlns:r="http://schemas.openxmlformats.org/officeDocument/2006/relationships" xmlns:p="http://schemas.openxmlformats.org/presentationml/2006/main">
+  <p:cSld>
+    <p:spTree>
+      <p:nvGrpSpPr>
+        <p:cNvPr id="1" name=""/>
+        <p:cNvGrpSpPr/>
+        <p:nvPr/>
+      </p:nvGrpSpPr>
+      <p:grpSpPr>
+        <a:xfrm>
+          <a:off x="0" y="0"/>
+          <a:ext cx="0" cy="0"/>
+          <a:chOff x="0" y="0"/>
+          <a:chExt cx="0" cy="0"/>
+        </a:xfrm>
+      </p:grpSpPr>
+      <p:sp>
+        <p:nvSpPr>
+          <p:cNvPr id="2" name="Slide Image Placeholder 1"/>
+          <p:cNvSpPr>
+            <a:spLocks noGrp="1" noRot="1" noChangeAspect="1"/>
+          </p:cNvSpPr>
+          <p:nvPr>
+            <p:ph type="sldImg"/>
+          </p:nvPr>
+        </p:nvSpPr>
+        <p:spPr/>
+      </p:sp>
+      <p:sp>
+        <p:nvSpPr>
+          <p:cNvPr id="3" name="Notes Placeholder 2"/>
+          <p:cNvSpPr>
+            <a:spLocks noGrp="1"/>
+          </p:cNvSpPr>
+          <p:nvPr>
+            <p:ph type="body" idx="1"/>
+          </p:nvPr>
+        </p:nvSpPr>
+        <p:spPr/>
+        <p:txBody>
+          <a:bodyPr/>
+          <a:lstStyle/>
+          <a:p>
+            <a:r>
+              <a:rPr lang="en-US" dirty="0"/>
+              <a:t>Close with the three points. Caches are per replica. Routing by prefix and protecting with a latency check lets the router reuse cached work without overloading a replica. And every request is measured, so the claims in this presentation can be checked against recorded data.</a:t>
+            </a:r>
+            <a:endParaRPr lang="en-US" dirty="0"/>
+          </a:p>
+        </p:txBody>
+      </p:sp>
+      <p:sp>
+        <p:nvSpPr>
+          <p:cNvPr id="4" name="Slide Number Placeholder 3"/>
+          <p:cNvSpPr>
+            <a:spLocks noGrp="1"/>
+          </p:cNvSpPr>
+          <p:nvPr>
+            <p:ph type="sldNum" sz="quarter" idx="10"/>
+          </p:nvPr>
+        </p:nvSpPr>
+        <p:spPr/>
+        <p:txBody>
+          <a:bodyPr/>
+          <a:lstStyle/>
+          <a:p>
+            <a:fld id="{F7021451-1387-4CA6-816F-3879F97B5CBC}" type="slidenum">
+              <a:rPr lang="en-US"/>
+              <a:t>18</a:t>
             </a:fld>
             <a:endParaRPr lang="en-US"/>
           </a:p>
@@ -8159,81 +8605,1099 @@
                 <a:ea typeface="Cambria" pitchFamily="34" charset="-122"/>
                 <a:cs typeface="Cambria" pitchFamily="34" charset="-120"/>
               </a:rPr>
-              <a:t>Live demonstration</a:t>
+              <a:t>Measured policy comparison</a:t>
             </a:r>
             <a:endParaRPr lang="en-US" sz="3200" dirty="0"/>
           </a:p>
         </p:txBody>
       </p:sp>
-      <p:sp>
-        <p:nvSpPr>
-          <p:cNvPr id="3" name="Demo step 1"/>
-          <p:cNvSpPr/>
-          <p:nvPr/>
-        </p:nvSpPr>
-        <p:spPr>
-          <a:xfrm>
-            <a:off x="457200" y="1143000"/>
-            <a:ext cx="1920240" cy="1463040"/>
-          </a:xfrm>
-          <a:prstGeom prst="roundRect">
-            <a:avLst>
-              <a:gd name="adj" fmla="val 5000"/>
-            </a:avLst>
-          </a:prstGeom>
-          <a:solidFill>
-            <a:schemeClr val="bg2"/>
-          </a:solidFill>
-          <a:ln w="12700">
-            <a:solidFill>
-              <a:schemeClr val="bg2"/>
-            </a:solidFill>
-            <a:prstDash val="solid"/>
-          </a:ln>
-          <a:effectLst>
-            <a:outerShdw sx="100000" sy="100000" kx="0" ky="0" algn="bl" rotWithShape="0" blurRad="101600" dist="25400" dir="5400000">
-              <a:srgbClr val="000000">
-                <a:alpha val="12000"/>
-              </a:srgbClr>
-            </a:outerShdw>
-          </a:effectLst>
-        </p:spPr>
-      </p:sp>
-      <p:sp>
-        <p:nvSpPr>
-          <p:cNvPr id="4" name="Demo step 1 number"/>
-          <p:cNvSpPr/>
-          <p:nvPr/>
-        </p:nvSpPr>
-        <p:spPr>
-          <a:xfrm>
-            <a:off x="566928" y="1252728"/>
-            <a:ext cx="365760" cy="365760"/>
-          </a:xfrm>
-          <a:prstGeom prst="ellipse">
-            <a:avLst/>
-          </a:prstGeom>
-          <a:solidFill>
-            <a:schemeClr val="accent1"/>
-          </a:solidFill>
-          <a:ln w="12700">
-            <a:solidFill>
-              <a:schemeClr val="accent1"/>
-            </a:solidFill>
-            <a:prstDash val="solid"/>
-          </a:ln>
-        </p:spPr>
-      </p:sp>
-      <p:sp>
-        <p:nvSpPr>
-          <p:cNvPr id="5" name="Text 3"/>
+      <p:graphicFrame>
+        <p:nvGraphicFramePr>
+          <p:cNvPr id="3" name="Chart 0" descr=""/>
+          <p:cNvGraphicFramePr/>
+          <p:nvPr/>
+        </p:nvGraphicFramePr>
+        <p:xfrm>
+          <a:off x="457200" y="1097280"/>
+          <a:ext cx="4572000" cy="2926080"/>
+        </p:xfrm>
+        <a:graphic xmlns:a="http://schemas.openxmlformats.org/drawingml/2006/main">
+          <a:graphicData uri="http://schemas.openxmlformats.org/drawingml/2006/chart">
+            <c:chart xmlns:c="http://schemas.openxmlformats.org/drawingml/2006/chart" r:id="rId1"/>
+          </a:graphicData>
+        </a:graphic>
+      </p:graphicFrame>
+      <p:graphicFrame>
+        <p:nvGraphicFramePr>
+          <p:cNvPr id="16" name="Comparison table"/>
+          <p:cNvGraphicFramePr>
+            <a:graphicFrameLocks noGrp="1"/>
+          </p:cNvGraphicFramePr>
+          <p:nvPr>
+            <p:extLst>
+              <p:ext uri="{D42A27DB-BD31-4B8C-83A1-F6EECF244321}">
+                <p14:modId xmlns:p14="http://schemas.microsoft.com/office/powerpoint/2010/main" val="1579011935"/>
+              </p:ext>
+            </p:extLst>
+          </p:nvPr>
+        </p:nvGraphicFramePr>
+        <p:xfrm>
+          <a:off x="5212080" y="1188720"/>
+          <a:ext cx="3474720" cy="914400"/>
+        </p:xfrm>
+        <a:graphic>
+          <a:graphicData uri="http://schemas.openxmlformats.org/drawingml/2006/table">
+            <a:tbl>
+              <a:tblPr/>
+              <a:tblGrid>
+                <a:gridCol w="1645920"/>
+                <a:gridCol w="914400"/>
+                <a:gridCol w="914400"/>
+              </a:tblGrid>
+              <a:tr h="0">
+                <a:tc>
+                  <a:txBody>
+                    <a:bodyPr/>
+                    <a:lstStyle/>
+                    <a:p>
+                      <a:pPr indent="0" marL="0">
+                        <a:buNone/>
+                      </a:pPr>
+                      <a:r>
+                        <a:rPr lang="en-US" sz="1200" b="1" dirty="0">
+                          <a:solidFill>
+                            <a:schemeClr val="bg1"/>
+                          </a:solidFill>
+                          <a:latin typeface="Calibri" pitchFamily="34" charset="0"/>
+                          <a:ea typeface="Calibri" pitchFamily="34" charset="-122"/>
+                          <a:cs typeface="Calibri" pitchFamily="34" charset="-120"/>
+                        </a:rPr>
+                        <a:t>Policy</a:t>
+                      </a:r>
+                      <a:endParaRPr lang="en-US" sz="1200" dirty="0">
+                        <a:latin typeface="Calibri" charset="0"/>
+                        <a:ea typeface="Calibri" charset="0"/>
+                        <a:cs typeface="Calibri" charset="0"/>
+                      </a:endParaRPr>
+                    </a:p>
+                  </a:txBody>
+                  <a:tcPr marL="54864" marR="54864" marT="45720" marB="45720">
+                    <a:lnL w="6350" cap="flat" cmpd="sng" algn="ctr">
+                      <a:solidFill>
+                        <a:schemeClr val="accent4"/>
+                      </a:solidFill>
+                      <a:prstDash val="solid"/>
+                      <a:round/>
+                      <a:headEnd type="none" w="med" len="med"/>
+                      <a:tailEnd type="none" w="med" len="med"/>
+                    </a:lnL>
+                    <a:lnR w="6350" cap="flat" cmpd="sng" algn="ctr">
+                      <a:solidFill>
+                        <a:schemeClr val="accent4"/>
+                      </a:solidFill>
+                      <a:prstDash val="solid"/>
+                      <a:round/>
+                      <a:headEnd type="none" w="med" len="med"/>
+                      <a:tailEnd type="none" w="med" len="med"/>
+                    </a:lnR>
+                    <a:lnT w="6350" cap="flat" cmpd="sng" algn="ctr">
+                      <a:solidFill>
+                        <a:schemeClr val="accent4"/>
+                      </a:solidFill>
+                      <a:prstDash val="solid"/>
+                      <a:round/>
+                      <a:headEnd type="none" w="med" len="med"/>
+                      <a:tailEnd type="none" w="med" len="med"/>
+                    </a:lnT>
+                    <a:lnB w="6350" cap="flat" cmpd="sng" algn="ctr">
+                      <a:solidFill>
+                        <a:schemeClr val="accent4"/>
+                      </a:solidFill>
+                      <a:prstDash val="solid"/>
+                      <a:round/>
+                      <a:headEnd type="none" w="med" len="med"/>
+                      <a:tailEnd type="none" w="med" len="med"/>
+                    </a:lnB>
+                    <a:solidFill>
+                      <a:schemeClr val="tx1"/>
+                    </a:solidFill>
+                  </a:tcPr>
+                </a:tc>
+                <a:tc>
+                  <a:txBody>
+                    <a:bodyPr/>
+                    <a:lstStyle/>
+                    <a:p>
+                      <a:pPr indent="0" marL="0">
+                        <a:buNone/>
+                      </a:pPr>
+                      <a:r>
+                        <a:rPr lang="en-US" sz="1200" b="1" dirty="0">
+                          <a:solidFill>
+                            <a:schemeClr val="bg1"/>
+                          </a:solidFill>
+                          <a:latin typeface="Calibri" pitchFamily="34" charset="0"/>
+                          <a:ea typeface="Calibri" pitchFamily="34" charset="-122"/>
+                          <a:cs typeface="Calibri" pitchFamily="34" charset="-120"/>
+                        </a:rPr>
+                        <a:t>Cache reuse</a:t>
+                      </a:r>
+                      <a:endParaRPr lang="en-US" sz="1200" dirty="0">
+                        <a:latin typeface="Calibri" charset="0"/>
+                        <a:ea typeface="Calibri" charset="0"/>
+                        <a:cs typeface="Calibri" charset="0"/>
+                      </a:endParaRPr>
+                    </a:p>
+                  </a:txBody>
+                  <a:tcPr marL="54864" marR="54864" marT="45720" marB="45720">
+                    <a:lnL w="6350" cap="flat" cmpd="sng" algn="ctr">
+                      <a:solidFill>
+                        <a:schemeClr val="accent4"/>
+                      </a:solidFill>
+                      <a:prstDash val="solid"/>
+                      <a:round/>
+                      <a:headEnd type="none" w="med" len="med"/>
+                      <a:tailEnd type="none" w="med" len="med"/>
+                    </a:lnL>
+                    <a:lnR w="6350" cap="flat" cmpd="sng" algn="ctr">
+                      <a:solidFill>
+                        <a:schemeClr val="accent4"/>
+                      </a:solidFill>
+                      <a:prstDash val="solid"/>
+                      <a:round/>
+                      <a:headEnd type="none" w="med" len="med"/>
+                      <a:tailEnd type="none" w="med" len="med"/>
+                    </a:lnR>
+                    <a:lnT w="6350" cap="flat" cmpd="sng" algn="ctr">
+                      <a:solidFill>
+                        <a:schemeClr val="accent4"/>
+                      </a:solidFill>
+                      <a:prstDash val="solid"/>
+                      <a:round/>
+                      <a:headEnd type="none" w="med" len="med"/>
+                      <a:tailEnd type="none" w="med" len="med"/>
+                    </a:lnT>
+                    <a:lnB w="6350" cap="flat" cmpd="sng" algn="ctr">
+                      <a:solidFill>
+                        <a:schemeClr val="accent4"/>
+                      </a:solidFill>
+                      <a:prstDash val="solid"/>
+                      <a:round/>
+                      <a:headEnd type="none" w="med" len="med"/>
+                      <a:tailEnd type="none" w="med" len="med"/>
+                    </a:lnB>
+                    <a:solidFill>
+                      <a:schemeClr val="tx1"/>
+                    </a:solidFill>
+                  </a:tcPr>
+                </a:tc>
+                <a:tc>
+                  <a:txBody>
+                    <a:bodyPr/>
+                    <a:lstStyle/>
+                    <a:p>
+                      <a:pPr indent="0" marL="0">
+                        <a:buNone/>
+                      </a:pPr>
+                      <a:r>
+                        <a:rPr lang="en-US" sz="1200" b="1" dirty="0">
+                          <a:solidFill>
+                            <a:schemeClr val="bg1"/>
+                          </a:solidFill>
+                          <a:latin typeface="Calibri" pitchFamily="34" charset="0"/>
+                          <a:ea typeface="Calibri" pitchFamily="34" charset="-122"/>
+                          <a:cs typeface="Calibri" pitchFamily="34" charset="-120"/>
+                        </a:rPr>
+                        <a:t>Max : mean load</a:t>
+                      </a:r>
+                      <a:endParaRPr lang="en-US" sz="1200" dirty="0">
+                        <a:latin typeface="Calibri" charset="0"/>
+                        <a:ea typeface="Calibri" charset="0"/>
+                        <a:cs typeface="Calibri" charset="0"/>
+                      </a:endParaRPr>
+                    </a:p>
+                  </a:txBody>
+                  <a:tcPr marL="54864" marR="54864" marT="45720" marB="45720">
+                    <a:lnL w="6350" cap="flat" cmpd="sng" algn="ctr">
+                      <a:solidFill>
+                        <a:schemeClr val="accent4"/>
+                      </a:solidFill>
+                      <a:prstDash val="solid"/>
+                      <a:round/>
+                      <a:headEnd type="none" w="med" len="med"/>
+                      <a:tailEnd type="none" w="med" len="med"/>
+                    </a:lnL>
+                    <a:lnR w="6350" cap="flat" cmpd="sng" algn="ctr">
+                      <a:solidFill>
+                        <a:schemeClr val="accent4"/>
+                      </a:solidFill>
+                      <a:prstDash val="solid"/>
+                      <a:round/>
+                      <a:headEnd type="none" w="med" len="med"/>
+                      <a:tailEnd type="none" w="med" len="med"/>
+                    </a:lnR>
+                    <a:lnT w="6350" cap="flat" cmpd="sng" algn="ctr">
+                      <a:solidFill>
+                        <a:schemeClr val="accent4"/>
+                      </a:solidFill>
+                      <a:prstDash val="solid"/>
+                      <a:round/>
+                      <a:headEnd type="none" w="med" len="med"/>
+                      <a:tailEnd type="none" w="med" len="med"/>
+                    </a:lnT>
+                    <a:lnB w="6350" cap="flat" cmpd="sng" algn="ctr">
+                      <a:solidFill>
+                        <a:schemeClr val="accent4"/>
+                      </a:solidFill>
+                      <a:prstDash val="solid"/>
+                      <a:round/>
+                      <a:headEnd type="none" w="med" len="med"/>
+                      <a:tailEnd type="none" w="med" len="med"/>
+                    </a:lnB>
+                    <a:solidFill>
+                      <a:schemeClr val="tx1"/>
+                    </a:solidFill>
+                  </a:tcPr>
+                </a:tc>
+              </a:tr>
+              <a:tr h="0">
+                <a:tc>
+                  <a:txBody>
+                    <a:bodyPr/>
+                    <a:lstStyle/>
+                    <a:p>
+                      <a:pPr indent="0" marL="0">
+                        <a:buNone/>
+                      </a:pPr>
+                      <a:r>
+                        <a:rPr lang="en-US" sz="1200" b="1" dirty="0">
+                          <a:solidFill>
+                            <a:schemeClr val="tx1"/>
+                          </a:solidFill>
+                          <a:latin typeface="Calibri" pitchFamily="34" charset="0"/>
+                          <a:ea typeface="Calibri" pitchFamily="34" charset="-122"/>
+                          <a:cs typeface="Calibri" pitchFamily="34" charset="-120"/>
+                        </a:rPr>
+                        <a:t>round_robin</a:t>
+                      </a:r>
+                      <a:endParaRPr lang="en-US" sz="1200" dirty="0">
+                        <a:latin typeface="Calibri" charset="0"/>
+                        <a:ea typeface="Calibri" charset="0"/>
+                        <a:cs typeface="Calibri" charset="0"/>
+                      </a:endParaRPr>
+                    </a:p>
+                  </a:txBody>
+                  <a:tcPr marL="54864" marR="54864" marT="45720" marB="45720">
+                    <a:lnL w="6350" cap="flat" cmpd="sng" algn="ctr">
+                      <a:solidFill>
+                        <a:schemeClr val="accent4"/>
+                      </a:solidFill>
+                      <a:prstDash val="solid"/>
+                      <a:round/>
+                      <a:headEnd type="none" w="med" len="med"/>
+                      <a:tailEnd type="none" w="med" len="med"/>
+                    </a:lnL>
+                    <a:lnR w="6350" cap="flat" cmpd="sng" algn="ctr">
+                      <a:solidFill>
+                        <a:schemeClr val="accent4"/>
+                      </a:solidFill>
+                      <a:prstDash val="solid"/>
+                      <a:round/>
+                      <a:headEnd type="none" w="med" len="med"/>
+                      <a:tailEnd type="none" w="med" len="med"/>
+                    </a:lnR>
+                    <a:lnT w="6350" cap="flat" cmpd="sng" algn="ctr">
+                      <a:solidFill>
+                        <a:schemeClr val="accent4"/>
+                      </a:solidFill>
+                      <a:prstDash val="solid"/>
+                      <a:round/>
+                      <a:headEnd type="none" w="med" len="med"/>
+                      <a:tailEnd type="none" w="med" len="med"/>
+                    </a:lnT>
+                    <a:lnB w="6350" cap="flat" cmpd="sng" algn="ctr">
+                      <a:solidFill>
+                        <a:schemeClr val="accent4"/>
+                      </a:solidFill>
+                      <a:prstDash val="solid"/>
+                      <a:round/>
+                      <a:headEnd type="none" w="med" len="med"/>
+                      <a:tailEnd type="none" w="med" len="med"/>
+                    </a:lnB>
+                    <a:solidFill>
+                      <a:schemeClr val="bg2"/>
+                    </a:solidFill>
+                  </a:tcPr>
+                </a:tc>
+                <a:tc>
+                  <a:txBody>
+                    <a:bodyPr/>
+                    <a:lstStyle/>
+                    <a:p>
+                      <a:pPr indent="0" marL="0">
+                        <a:buNone/>
+                      </a:pPr>
+                      <a:r>
+                        <a:rPr lang="en-US" sz="1200" dirty="0">
+                          <a:solidFill>
+                            <a:schemeClr val="tx1"/>
+                          </a:solidFill>
+                          <a:latin typeface="Calibri" pitchFamily="34" charset="0"/>
+                          <a:ea typeface="Calibri" pitchFamily="34" charset="-122"/>
+                          <a:cs typeface="Calibri" pitchFamily="34" charset="-120"/>
+                        </a:rPr>
+                        <a:t>55 %</a:t>
+                      </a:r>
+                      <a:endParaRPr lang="en-US" sz="1200" dirty="0">
+                        <a:latin typeface="Calibri" charset="0"/>
+                        <a:ea typeface="Calibri" charset="0"/>
+                        <a:cs typeface="Calibri" charset="0"/>
+                      </a:endParaRPr>
+                    </a:p>
+                  </a:txBody>
+                  <a:tcPr marL="54864" marR="54864" marT="45720" marB="45720">
+                    <a:lnL w="6350" cap="flat" cmpd="sng" algn="ctr">
+                      <a:solidFill>
+                        <a:schemeClr val="accent4"/>
+                      </a:solidFill>
+                      <a:prstDash val="solid"/>
+                      <a:round/>
+                      <a:headEnd type="none" w="med" len="med"/>
+                      <a:tailEnd type="none" w="med" len="med"/>
+                    </a:lnL>
+                    <a:lnR w="6350" cap="flat" cmpd="sng" algn="ctr">
+                      <a:solidFill>
+                        <a:schemeClr val="accent4"/>
+                      </a:solidFill>
+                      <a:prstDash val="solid"/>
+                      <a:round/>
+                      <a:headEnd type="none" w="med" len="med"/>
+                      <a:tailEnd type="none" w="med" len="med"/>
+                    </a:lnR>
+                    <a:lnT w="6350" cap="flat" cmpd="sng" algn="ctr">
+                      <a:solidFill>
+                        <a:schemeClr val="accent4"/>
+                      </a:solidFill>
+                      <a:prstDash val="solid"/>
+                      <a:round/>
+                      <a:headEnd type="none" w="med" len="med"/>
+                      <a:tailEnd type="none" w="med" len="med"/>
+                    </a:lnT>
+                    <a:lnB w="6350" cap="flat" cmpd="sng" algn="ctr">
+                      <a:solidFill>
+                        <a:schemeClr val="accent4"/>
+                      </a:solidFill>
+                      <a:prstDash val="solid"/>
+                      <a:round/>
+                      <a:headEnd type="none" w="med" len="med"/>
+                      <a:tailEnd type="none" w="med" len="med"/>
+                    </a:lnB>
+                    <a:solidFill>
+                      <a:schemeClr val="bg2"/>
+                    </a:solidFill>
+                  </a:tcPr>
+                </a:tc>
+                <a:tc>
+                  <a:txBody>
+                    <a:bodyPr/>
+                    <a:lstStyle/>
+                    <a:p>
+                      <a:pPr indent="0" marL="0">
+                        <a:buNone/>
+                      </a:pPr>
+                      <a:r>
+                        <a:rPr lang="en-US" sz="1200" dirty="0">
+                          <a:solidFill>
+                            <a:schemeClr val="tx1"/>
+                          </a:solidFill>
+                          <a:latin typeface="Calibri" pitchFamily="34" charset="0"/>
+                          <a:ea typeface="Calibri" pitchFamily="34" charset="-122"/>
+                          <a:cs typeface="Calibri" pitchFamily="34" charset="-120"/>
+                        </a:rPr>
+                        <a:t>1.00</a:t>
+                      </a:r>
+                      <a:endParaRPr lang="en-US" sz="1200" dirty="0">
+                        <a:latin typeface="Calibri" charset="0"/>
+                        <a:ea typeface="Calibri" charset="0"/>
+                        <a:cs typeface="Calibri" charset="0"/>
+                      </a:endParaRPr>
+                    </a:p>
+                  </a:txBody>
+                  <a:tcPr marL="54864" marR="54864" marT="45720" marB="45720">
+                    <a:lnL w="6350" cap="flat" cmpd="sng" algn="ctr">
+                      <a:solidFill>
+                        <a:schemeClr val="accent4"/>
+                      </a:solidFill>
+                      <a:prstDash val="solid"/>
+                      <a:round/>
+                      <a:headEnd type="none" w="med" len="med"/>
+                      <a:tailEnd type="none" w="med" len="med"/>
+                    </a:lnL>
+                    <a:lnR w="6350" cap="flat" cmpd="sng" algn="ctr">
+                      <a:solidFill>
+                        <a:schemeClr val="accent4"/>
+                      </a:solidFill>
+                      <a:prstDash val="solid"/>
+                      <a:round/>
+                      <a:headEnd type="none" w="med" len="med"/>
+                      <a:tailEnd type="none" w="med" len="med"/>
+                    </a:lnR>
+                    <a:lnT w="6350" cap="flat" cmpd="sng" algn="ctr">
+                      <a:solidFill>
+                        <a:schemeClr val="accent4"/>
+                      </a:solidFill>
+                      <a:prstDash val="solid"/>
+                      <a:round/>
+                      <a:headEnd type="none" w="med" len="med"/>
+                      <a:tailEnd type="none" w="med" len="med"/>
+                    </a:lnT>
+                    <a:lnB w="6350" cap="flat" cmpd="sng" algn="ctr">
+                      <a:solidFill>
+                        <a:schemeClr val="accent4"/>
+                      </a:solidFill>
+                      <a:prstDash val="solid"/>
+                      <a:round/>
+                      <a:headEnd type="none" w="med" len="med"/>
+                      <a:tailEnd type="none" w="med" len="med"/>
+                    </a:lnB>
+                    <a:solidFill>
+                      <a:schemeClr val="bg2"/>
+                    </a:solidFill>
+                  </a:tcPr>
+                </a:tc>
+              </a:tr>
+              <a:tr h="0">
+                <a:tc>
+                  <a:txBody>
+                    <a:bodyPr/>
+                    <a:lstStyle/>
+                    <a:p>
+                      <a:pPr indent="0" marL="0">
+                        <a:buNone/>
+                      </a:pPr>
+                      <a:r>
+                        <a:rPr lang="en-US" sz="1200" b="1" dirty="0">
+                          <a:solidFill>
+                            <a:schemeClr val="tx1"/>
+                          </a:solidFill>
+                          <a:latin typeface="Calibri" pitchFamily="34" charset="0"/>
+                          <a:ea typeface="Calibri" pitchFamily="34" charset="-122"/>
+                          <a:cs typeface="Calibri" pitchFamily="34" charset="-120"/>
+                        </a:rPr>
+                        <a:t>least_connections</a:t>
+                      </a:r>
+                      <a:endParaRPr lang="en-US" sz="1200" dirty="0">
+                        <a:latin typeface="Calibri" charset="0"/>
+                        <a:ea typeface="Calibri" charset="0"/>
+                        <a:cs typeface="Calibri" charset="0"/>
+                      </a:endParaRPr>
+                    </a:p>
+                  </a:txBody>
+                  <a:tcPr marL="54864" marR="54864" marT="45720" marB="45720">
+                    <a:lnL w="6350" cap="flat" cmpd="sng" algn="ctr">
+                      <a:solidFill>
+                        <a:schemeClr val="accent4"/>
+                      </a:solidFill>
+                      <a:prstDash val="solid"/>
+                      <a:round/>
+                      <a:headEnd type="none" w="med" len="med"/>
+                      <a:tailEnd type="none" w="med" len="med"/>
+                    </a:lnL>
+                    <a:lnR w="6350" cap="flat" cmpd="sng" algn="ctr">
+                      <a:solidFill>
+                        <a:schemeClr val="accent4"/>
+                      </a:solidFill>
+                      <a:prstDash val="solid"/>
+                      <a:round/>
+                      <a:headEnd type="none" w="med" len="med"/>
+                      <a:tailEnd type="none" w="med" len="med"/>
+                    </a:lnR>
+                    <a:lnT w="6350" cap="flat" cmpd="sng" algn="ctr">
+                      <a:solidFill>
+                        <a:schemeClr val="accent4"/>
+                      </a:solidFill>
+                      <a:prstDash val="solid"/>
+                      <a:round/>
+                      <a:headEnd type="none" w="med" len="med"/>
+                      <a:tailEnd type="none" w="med" len="med"/>
+                    </a:lnT>
+                    <a:lnB w="6350" cap="flat" cmpd="sng" algn="ctr">
+                      <a:solidFill>
+                        <a:schemeClr val="accent4"/>
+                      </a:solidFill>
+                      <a:prstDash val="solid"/>
+                      <a:round/>
+                      <a:headEnd type="none" w="med" len="med"/>
+                      <a:tailEnd type="none" w="med" len="med"/>
+                    </a:lnB>
+                    <a:solidFill>
+                      <a:schemeClr val="bg1"/>
+                    </a:solidFill>
+                  </a:tcPr>
+                </a:tc>
+                <a:tc>
+                  <a:txBody>
+                    <a:bodyPr/>
+                    <a:lstStyle/>
+                    <a:p>
+                      <a:pPr indent="0" marL="0">
+                        <a:buNone/>
+                      </a:pPr>
+                      <a:r>
+                        <a:rPr lang="en-US" sz="1200" dirty="0">
+                          <a:solidFill>
+                            <a:schemeClr val="tx1"/>
+                          </a:solidFill>
+                          <a:latin typeface="Calibri" pitchFamily="34" charset="0"/>
+                          <a:ea typeface="Calibri" pitchFamily="34" charset="-122"/>
+                          <a:cs typeface="Calibri" pitchFamily="34" charset="-120"/>
+                        </a:rPr>
+                        <a:t>48 %</a:t>
+                      </a:r>
+                      <a:endParaRPr lang="en-US" sz="1200" dirty="0">
+                        <a:latin typeface="Calibri" charset="0"/>
+                        <a:ea typeface="Calibri" charset="0"/>
+                        <a:cs typeface="Calibri" charset="0"/>
+                      </a:endParaRPr>
+                    </a:p>
+                  </a:txBody>
+                  <a:tcPr marL="54864" marR="54864" marT="45720" marB="45720">
+                    <a:lnL w="6350" cap="flat" cmpd="sng" algn="ctr">
+                      <a:solidFill>
+                        <a:schemeClr val="accent4"/>
+                      </a:solidFill>
+                      <a:prstDash val="solid"/>
+                      <a:round/>
+                      <a:headEnd type="none" w="med" len="med"/>
+                      <a:tailEnd type="none" w="med" len="med"/>
+                    </a:lnL>
+                    <a:lnR w="6350" cap="flat" cmpd="sng" algn="ctr">
+                      <a:solidFill>
+                        <a:schemeClr val="accent4"/>
+                      </a:solidFill>
+                      <a:prstDash val="solid"/>
+                      <a:round/>
+                      <a:headEnd type="none" w="med" len="med"/>
+                      <a:tailEnd type="none" w="med" len="med"/>
+                    </a:lnR>
+                    <a:lnT w="6350" cap="flat" cmpd="sng" algn="ctr">
+                      <a:solidFill>
+                        <a:schemeClr val="accent4"/>
+                      </a:solidFill>
+                      <a:prstDash val="solid"/>
+                      <a:round/>
+                      <a:headEnd type="none" w="med" len="med"/>
+                      <a:tailEnd type="none" w="med" len="med"/>
+                    </a:lnT>
+                    <a:lnB w="6350" cap="flat" cmpd="sng" algn="ctr">
+                      <a:solidFill>
+                        <a:schemeClr val="accent4"/>
+                      </a:solidFill>
+                      <a:prstDash val="solid"/>
+                      <a:round/>
+                      <a:headEnd type="none" w="med" len="med"/>
+                      <a:tailEnd type="none" w="med" len="med"/>
+                    </a:lnB>
+                    <a:solidFill>
+                      <a:schemeClr val="bg1"/>
+                    </a:solidFill>
+                  </a:tcPr>
+                </a:tc>
+                <a:tc>
+                  <a:txBody>
+                    <a:bodyPr/>
+                    <a:lstStyle/>
+                    <a:p>
+                      <a:pPr indent="0" marL="0">
+                        <a:buNone/>
+                      </a:pPr>
+                      <a:r>
+                        <a:rPr lang="en-US" sz="1200" dirty="0">
+                          <a:solidFill>
+                            <a:schemeClr val="tx1"/>
+                          </a:solidFill>
+                          <a:latin typeface="Calibri" pitchFamily="34" charset="0"/>
+                          <a:ea typeface="Calibri" pitchFamily="34" charset="-122"/>
+                          <a:cs typeface="Calibri" pitchFamily="34" charset="-120"/>
+                        </a:rPr>
+                        <a:t>1.53</a:t>
+                      </a:r>
+                      <a:endParaRPr lang="en-US" sz="1200" dirty="0">
+                        <a:latin typeface="Calibri" charset="0"/>
+                        <a:ea typeface="Calibri" charset="0"/>
+                        <a:cs typeface="Calibri" charset="0"/>
+                      </a:endParaRPr>
+                    </a:p>
+                  </a:txBody>
+                  <a:tcPr marL="54864" marR="54864" marT="45720" marB="45720">
+                    <a:lnL w="6350" cap="flat" cmpd="sng" algn="ctr">
+                      <a:solidFill>
+                        <a:schemeClr val="accent4"/>
+                      </a:solidFill>
+                      <a:prstDash val="solid"/>
+                      <a:round/>
+                      <a:headEnd type="none" w="med" len="med"/>
+                      <a:tailEnd type="none" w="med" len="med"/>
+                    </a:lnL>
+                    <a:lnR w="6350" cap="flat" cmpd="sng" algn="ctr">
+                      <a:solidFill>
+                        <a:schemeClr val="accent4"/>
+                      </a:solidFill>
+                      <a:prstDash val="solid"/>
+                      <a:round/>
+                      <a:headEnd type="none" w="med" len="med"/>
+                      <a:tailEnd type="none" w="med" len="med"/>
+                    </a:lnR>
+                    <a:lnT w="6350" cap="flat" cmpd="sng" algn="ctr">
+                      <a:solidFill>
+                        <a:schemeClr val="accent4"/>
+                      </a:solidFill>
+                      <a:prstDash val="solid"/>
+                      <a:round/>
+                      <a:headEnd type="none" w="med" len="med"/>
+                      <a:tailEnd type="none" w="med" len="med"/>
+                    </a:lnT>
+                    <a:lnB w="6350" cap="flat" cmpd="sng" algn="ctr">
+                      <a:solidFill>
+                        <a:schemeClr val="accent4"/>
+                      </a:solidFill>
+                      <a:prstDash val="solid"/>
+                      <a:round/>
+                      <a:headEnd type="none" w="med" len="med"/>
+                      <a:tailEnd type="none" w="med" len="med"/>
+                    </a:lnB>
+                    <a:solidFill>
+                      <a:schemeClr val="bg1"/>
+                    </a:solidFill>
+                  </a:tcPr>
+                </a:tc>
+              </a:tr>
+              <a:tr h="0">
+                <a:tc>
+                  <a:txBody>
+                    <a:bodyPr/>
+                    <a:lstStyle/>
+                    <a:p>
+                      <a:pPr indent="0" marL="0">
+                        <a:buNone/>
+                      </a:pPr>
+                      <a:r>
+                        <a:rPr lang="en-US" sz="1200" b="1" dirty="0">
+                          <a:solidFill>
+                            <a:schemeClr val="tx1"/>
+                          </a:solidFill>
+                          <a:latin typeface="Calibri" pitchFamily="34" charset="0"/>
+                          <a:ea typeface="Calibri" pitchFamily="34" charset="-122"/>
+                          <a:cs typeface="Calibri" pitchFamily="34" charset="-120"/>
+                        </a:rPr>
+                        <a:t>swiftserve</a:t>
+                      </a:r>
+                      <a:endParaRPr lang="en-US" sz="1200" dirty="0">
+                        <a:latin typeface="Calibri" charset="0"/>
+                        <a:ea typeface="Calibri" charset="0"/>
+                        <a:cs typeface="Calibri" charset="0"/>
+                      </a:endParaRPr>
+                    </a:p>
+                  </a:txBody>
+                  <a:tcPr marL="54864" marR="54864" marT="45720" marB="45720">
+                    <a:lnL w="6350" cap="flat" cmpd="sng" algn="ctr">
+                      <a:solidFill>
+                        <a:schemeClr val="accent4"/>
+                      </a:solidFill>
+                      <a:prstDash val="solid"/>
+                      <a:round/>
+                      <a:headEnd type="none" w="med" len="med"/>
+                      <a:tailEnd type="none" w="med" len="med"/>
+                    </a:lnL>
+                    <a:lnR w="6350" cap="flat" cmpd="sng" algn="ctr">
+                      <a:solidFill>
+                        <a:schemeClr val="accent4"/>
+                      </a:solidFill>
+                      <a:prstDash val="solid"/>
+                      <a:round/>
+                      <a:headEnd type="none" w="med" len="med"/>
+                      <a:tailEnd type="none" w="med" len="med"/>
+                    </a:lnR>
+                    <a:lnT w="6350" cap="flat" cmpd="sng" algn="ctr">
+                      <a:solidFill>
+                        <a:schemeClr val="accent4"/>
+                      </a:solidFill>
+                      <a:prstDash val="solid"/>
+                      <a:round/>
+                      <a:headEnd type="none" w="med" len="med"/>
+                      <a:tailEnd type="none" w="med" len="med"/>
+                    </a:lnT>
+                    <a:lnB w="6350" cap="flat" cmpd="sng" algn="ctr">
+                      <a:solidFill>
+                        <a:schemeClr val="accent4"/>
+                      </a:solidFill>
+                      <a:prstDash val="solid"/>
+                      <a:round/>
+                      <a:headEnd type="none" w="med" len="med"/>
+                      <a:tailEnd type="none" w="med" len="med"/>
+                    </a:lnB>
+                    <a:solidFill>
+                      <a:schemeClr val="bg2"/>
+                    </a:solidFill>
+                  </a:tcPr>
+                </a:tc>
+                <a:tc>
+                  <a:txBody>
+                    <a:bodyPr/>
+                    <a:lstStyle/>
+                    <a:p>
+                      <a:pPr indent="0" marL="0">
+                        <a:buNone/>
+                      </a:pPr>
+                      <a:r>
+                        <a:rPr lang="en-US" sz="1200" dirty="0">
+                          <a:solidFill>
+                            <a:schemeClr val="tx1"/>
+                          </a:solidFill>
+                          <a:latin typeface="Calibri" pitchFamily="34" charset="0"/>
+                          <a:ea typeface="Calibri" pitchFamily="34" charset="-122"/>
+                          <a:cs typeface="Calibri" pitchFamily="34" charset="-120"/>
+                        </a:rPr>
+                        <a:t>69 %</a:t>
+                      </a:r>
+                      <a:endParaRPr lang="en-US" sz="1200" dirty="0">
+                        <a:latin typeface="Calibri" charset="0"/>
+                        <a:ea typeface="Calibri" charset="0"/>
+                        <a:cs typeface="Calibri" charset="0"/>
+                      </a:endParaRPr>
+                    </a:p>
+                  </a:txBody>
+                  <a:tcPr marL="54864" marR="54864" marT="45720" marB="45720">
+                    <a:lnL w="6350" cap="flat" cmpd="sng" algn="ctr">
+                      <a:solidFill>
+                        <a:schemeClr val="accent4"/>
+                      </a:solidFill>
+                      <a:prstDash val="solid"/>
+                      <a:round/>
+                      <a:headEnd type="none" w="med" len="med"/>
+                      <a:tailEnd type="none" w="med" len="med"/>
+                    </a:lnL>
+                    <a:lnR w="6350" cap="flat" cmpd="sng" algn="ctr">
+                      <a:solidFill>
+                        <a:schemeClr val="accent4"/>
+                      </a:solidFill>
+                      <a:prstDash val="solid"/>
+                      <a:round/>
+                      <a:headEnd type="none" w="med" len="med"/>
+                      <a:tailEnd type="none" w="med" len="med"/>
+                    </a:lnR>
+                    <a:lnT w="6350" cap="flat" cmpd="sng" algn="ctr">
+                      <a:solidFill>
+                        <a:schemeClr val="accent4"/>
+                      </a:solidFill>
+                      <a:prstDash val="solid"/>
+                      <a:round/>
+                      <a:headEnd type="none" w="med" len="med"/>
+                      <a:tailEnd type="none" w="med" len="med"/>
+                    </a:lnT>
+                    <a:lnB w="6350" cap="flat" cmpd="sng" algn="ctr">
+                      <a:solidFill>
+                        <a:schemeClr val="accent4"/>
+                      </a:solidFill>
+                      <a:prstDash val="solid"/>
+                      <a:round/>
+                      <a:headEnd type="none" w="med" len="med"/>
+                      <a:tailEnd type="none" w="med" len="med"/>
+                    </a:lnB>
+                    <a:solidFill>
+                      <a:schemeClr val="bg2"/>
+                    </a:solidFill>
+                  </a:tcPr>
+                </a:tc>
+                <a:tc>
+                  <a:txBody>
+                    <a:bodyPr/>
+                    <a:lstStyle/>
+                    <a:p>
+                      <a:pPr indent="0" marL="0">
+                        <a:buNone/>
+                      </a:pPr>
+                      <a:r>
+                        <a:rPr lang="en-US" sz="1200" dirty="0">
+                          <a:solidFill>
+                            <a:schemeClr val="tx1"/>
+                          </a:solidFill>
+                          <a:latin typeface="Calibri" pitchFamily="34" charset="0"/>
+                          <a:ea typeface="Calibri" pitchFamily="34" charset="-122"/>
+                          <a:cs typeface="Calibri" pitchFamily="34" charset="-120"/>
+                        </a:rPr>
+                        <a:t>1.33</a:t>
+                      </a:r>
+                      <a:endParaRPr lang="en-US" sz="1200" dirty="0">
+                        <a:latin typeface="Calibri" charset="0"/>
+                        <a:ea typeface="Calibri" charset="0"/>
+                        <a:cs typeface="Calibri" charset="0"/>
+                      </a:endParaRPr>
+                    </a:p>
+                  </a:txBody>
+                  <a:tcPr marL="54864" marR="54864" marT="45720" marB="45720">
+                    <a:lnL w="6350" cap="flat" cmpd="sng" algn="ctr">
+                      <a:solidFill>
+                        <a:schemeClr val="accent4"/>
+                      </a:solidFill>
+                      <a:prstDash val="solid"/>
+                      <a:round/>
+                      <a:headEnd type="none" w="med" len="med"/>
+                      <a:tailEnd type="none" w="med" len="med"/>
+                    </a:lnL>
+                    <a:lnR w="6350" cap="flat" cmpd="sng" algn="ctr">
+                      <a:solidFill>
+                        <a:schemeClr val="accent4"/>
+                      </a:solidFill>
+                      <a:prstDash val="solid"/>
+                      <a:round/>
+                      <a:headEnd type="none" w="med" len="med"/>
+                      <a:tailEnd type="none" w="med" len="med"/>
+                    </a:lnR>
+                    <a:lnT w="6350" cap="flat" cmpd="sng" algn="ctr">
+                      <a:solidFill>
+                        <a:schemeClr val="accent4"/>
+                      </a:solidFill>
+                      <a:prstDash val="solid"/>
+                      <a:round/>
+                      <a:headEnd type="none" w="med" len="med"/>
+                      <a:tailEnd type="none" w="med" len="med"/>
+                    </a:lnT>
+                    <a:lnB w="6350" cap="flat" cmpd="sng" algn="ctr">
+                      <a:solidFill>
+                        <a:schemeClr val="accent4"/>
+                      </a:solidFill>
+                      <a:prstDash val="solid"/>
+                      <a:round/>
+                      <a:headEnd type="none" w="med" len="med"/>
+                      <a:tailEnd type="none" w="med" len="med"/>
+                    </a:lnB>
+                    <a:solidFill>
+                      <a:schemeClr val="bg2"/>
+                    </a:solidFill>
+                  </a:tcPr>
+                </a:tc>
+              </a:tr>
+              <a:tr h="0">
+                <a:tc>
+                  <a:txBody>
+                    <a:bodyPr/>
+                    <a:lstStyle/>
+                    <a:p>
+                      <a:pPr indent="0" marL="0">
+                        <a:buNone/>
+                      </a:pPr>
+                      <a:r>
+                        <a:rPr lang="en-US" sz="1200" b="1" dirty="0">
+                          <a:solidFill>
+                            <a:schemeClr val="tx1"/>
+                          </a:solidFill>
+                          <a:latin typeface="Calibri" pitchFamily="34" charset="0"/>
+                          <a:ea typeface="Calibri" pitchFamily="34" charset="-122"/>
+                          <a:cs typeface="Calibri" pitchFamily="34" charset="-120"/>
+                        </a:rPr>
+                        <a:t>prefix_aware</a:t>
+                      </a:r>
+                      <a:endParaRPr lang="en-US" sz="1200" dirty="0">
+                        <a:latin typeface="Calibri" charset="0"/>
+                        <a:ea typeface="Calibri" charset="0"/>
+                        <a:cs typeface="Calibri" charset="0"/>
+                      </a:endParaRPr>
+                    </a:p>
+                  </a:txBody>
+                  <a:tcPr marL="54864" marR="54864" marT="45720" marB="45720">
+                    <a:lnL w="6350" cap="flat" cmpd="sng" algn="ctr">
+                      <a:solidFill>
+                        <a:schemeClr val="accent4"/>
+                      </a:solidFill>
+                      <a:prstDash val="solid"/>
+                      <a:round/>
+                      <a:headEnd type="none" w="med" len="med"/>
+                      <a:tailEnd type="none" w="med" len="med"/>
+                    </a:lnL>
+                    <a:lnR w="6350" cap="flat" cmpd="sng" algn="ctr">
+                      <a:solidFill>
+                        <a:schemeClr val="accent4"/>
+                      </a:solidFill>
+                      <a:prstDash val="solid"/>
+                      <a:round/>
+                      <a:headEnd type="none" w="med" len="med"/>
+                      <a:tailEnd type="none" w="med" len="med"/>
+                    </a:lnR>
+                    <a:lnT w="6350" cap="flat" cmpd="sng" algn="ctr">
+                      <a:solidFill>
+                        <a:schemeClr val="accent4"/>
+                      </a:solidFill>
+                      <a:prstDash val="solid"/>
+                      <a:round/>
+                      <a:headEnd type="none" w="med" len="med"/>
+                      <a:tailEnd type="none" w="med" len="med"/>
+                    </a:lnT>
+                    <a:lnB w="6350" cap="flat" cmpd="sng" algn="ctr">
+                      <a:solidFill>
+                        <a:schemeClr val="accent4"/>
+                      </a:solidFill>
+                      <a:prstDash val="solid"/>
+                      <a:round/>
+                      <a:headEnd type="none" w="med" len="med"/>
+                      <a:tailEnd type="none" w="med" len="med"/>
+                    </a:lnB>
+                    <a:solidFill>
+                      <a:schemeClr val="bg1"/>
+                    </a:solidFill>
+                  </a:tcPr>
+                </a:tc>
+                <a:tc>
+                  <a:txBody>
+                    <a:bodyPr/>
+                    <a:lstStyle/>
+                    <a:p>
+                      <a:pPr indent="0" marL="0">
+                        <a:buNone/>
+                      </a:pPr>
+                      <a:r>
+                        <a:rPr lang="en-US" sz="1200" dirty="0">
+                          <a:solidFill>
+                            <a:schemeClr val="tx1"/>
+                          </a:solidFill>
+                          <a:latin typeface="Calibri" pitchFamily="34" charset="0"/>
+                          <a:ea typeface="Calibri" pitchFamily="34" charset="-122"/>
+                          <a:cs typeface="Calibri" pitchFamily="34" charset="-120"/>
+                        </a:rPr>
+                        <a:t>87 %</a:t>
+                      </a:r>
+                      <a:endParaRPr lang="en-US" sz="1200" dirty="0">
+                        <a:latin typeface="Calibri" charset="0"/>
+                        <a:ea typeface="Calibri" charset="0"/>
+                        <a:cs typeface="Calibri" charset="0"/>
+                      </a:endParaRPr>
+                    </a:p>
+                  </a:txBody>
+                  <a:tcPr marL="54864" marR="54864" marT="45720" marB="45720">
+                    <a:lnL w="6350" cap="flat" cmpd="sng" algn="ctr">
+                      <a:solidFill>
+                        <a:schemeClr val="accent4"/>
+                      </a:solidFill>
+                      <a:prstDash val="solid"/>
+                      <a:round/>
+                      <a:headEnd type="none" w="med" len="med"/>
+                      <a:tailEnd type="none" w="med" len="med"/>
+                    </a:lnL>
+                    <a:lnR w="6350" cap="flat" cmpd="sng" algn="ctr">
+                      <a:solidFill>
+                        <a:schemeClr val="accent4"/>
+                      </a:solidFill>
+                      <a:prstDash val="solid"/>
+                      <a:round/>
+                      <a:headEnd type="none" w="med" len="med"/>
+                      <a:tailEnd type="none" w="med" len="med"/>
+                    </a:lnR>
+                    <a:lnT w="6350" cap="flat" cmpd="sng" algn="ctr">
+                      <a:solidFill>
+                        <a:schemeClr val="accent4"/>
+                      </a:solidFill>
+                      <a:prstDash val="solid"/>
+                      <a:round/>
+                      <a:headEnd type="none" w="med" len="med"/>
+                      <a:tailEnd type="none" w="med" len="med"/>
+                    </a:lnT>
+                    <a:lnB w="6350" cap="flat" cmpd="sng" algn="ctr">
+                      <a:solidFill>
+                        <a:schemeClr val="accent4"/>
+                      </a:solidFill>
+                      <a:prstDash val="solid"/>
+                      <a:round/>
+                      <a:headEnd type="none" w="med" len="med"/>
+                      <a:tailEnd type="none" w="med" len="med"/>
+                    </a:lnB>
+                    <a:solidFill>
+                      <a:schemeClr val="bg1"/>
+                    </a:solidFill>
+                  </a:tcPr>
+                </a:tc>
+                <a:tc>
+                  <a:txBody>
+                    <a:bodyPr/>
+                    <a:lstStyle/>
+                    <a:p>
+                      <a:pPr indent="0" marL="0">
+                        <a:buNone/>
+                      </a:pPr>
+                      <a:r>
+                        <a:rPr lang="en-US" sz="1200" dirty="0">
+                          <a:solidFill>
+                            <a:schemeClr val="tx1"/>
+                          </a:solidFill>
+                          <a:latin typeface="Calibri" pitchFamily="34" charset="0"/>
+                          <a:ea typeface="Calibri" pitchFamily="34" charset="-122"/>
+                          <a:cs typeface="Calibri" pitchFamily="34" charset="-120"/>
+                        </a:rPr>
+                        <a:t>1.47</a:t>
+                      </a:r>
+                      <a:endParaRPr lang="en-US" sz="1200" dirty="0">
+                        <a:latin typeface="Calibri" charset="0"/>
+                        <a:ea typeface="Calibri" charset="0"/>
+                        <a:cs typeface="Calibri" charset="0"/>
+                      </a:endParaRPr>
+                    </a:p>
+                  </a:txBody>
+                  <a:tcPr marL="54864" marR="54864" marT="45720" marB="45720">
+                    <a:lnL w="6350" cap="flat" cmpd="sng" algn="ctr">
+                      <a:solidFill>
+                        <a:schemeClr val="accent4"/>
+                      </a:solidFill>
+                      <a:prstDash val="solid"/>
+                      <a:round/>
+                      <a:headEnd type="none" w="med" len="med"/>
+                      <a:tailEnd type="none" w="med" len="med"/>
+                    </a:lnL>
+                    <a:lnR w="6350" cap="flat" cmpd="sng" algn="ctr">
+                      <a:solidFill>
+                        <a:schemeClr val="accent4"/>
+                      </a:solidFill>
+                      <a:prstDash val="solid"/>
+                      <a:round/>
+                      <a:headEnd type="none" w="med" len="med"/>
+                      <a:tailEnd type="none" w="med" len="med"/>
+                    </a:lnR>
+                    <a:lnT w="6350" cap="flat" cmpd="sng" algn="ctr">
+                      <a:solidFill>
+                        <a:schemeClr val="accent4"/>
+                      </a:solidFill>
+                      <a:prstDash val="solid"/>
+                      <a:round/>
+                      <a:headEnd type="none" w="med" len="med"/>
+                      <a:tailEnd type="none" w="med" len="med"/>
+                    </a:lnT>
+                    <a:lnB w="6350" cap="flat" cmpd="sng" algn="ctr">
+                      <a:solidFill>
+                        <a:schemeClr val="accent4"/>
+                      </a:solidFill>
+                      <a:prstDash val="solid"/>
+                      <a:round/>
+                      <a:headEnd type="none" w="med" len="med"/>
+                      <a:tailEnd type="none" w="med" len="med"/>
+                    </a:lnB>
+                    <a:solidFill>
+                      <a:schemeClr val="bg1"/>
+                    </a:solidFill>
+                  </a:tcPr>
+                </a:tc>
+              </a:tr>
+            </a:tbl>
+          </a:graphicData>
+        </a:graphic>
+      </p:graphicFrame>
+      <p:sp>
+        <p:nvSpPr>
+          <p:cNvPr id="5" name="Text 1"/>
           <p:cNvSpPr txBox="1"/>
           <p:nvPr/>
         </p:nvSpPr>
         <p:spPr>
           <a:xfrm>
-            <a:off x="566928" y="1252728"/>
-            <a:ext cx="365760" cy="365760"/>
+            <a:off x="457200" y="4160520"/>
+            <a:ext cx="8229600" cy="640080"/>
           </a:xfrm>
           <a:prstGeom prst="rect">
             <a:avLst/>
@@ -8242,664 +9706,27 @@
           <a:ln/>
         </p:spPr>
         <p:txBody>
-          <a:bodyPr wrap="square" lIns="0" tIns="0" rIns="0" bIns="0" rtlCol="0" anchor="ctr"/>
+          <a:bodyPr wrap="square" lIns="0" tIns="0" rIns="0" bIns="0" rtlCol="0" anchor="t"/>
           <a:lstStyle/>
           <a:p>
-            <a:pPr algn="ctr" indent="0" marL="0">
+            <a:pPr indent="0" marL="0">
               <a:buNone/>
             </a:pPr>
             <a:r>
-              <a:rPr lang="en-US" sz="1400" b="1" dirty="0">
-                <a:solidFill>
-                  <a:schemeClr val="bg1"/>
+              <a:rPr lang="en-US" sz="1300" dirty="0">
+                <a:solidFill>
+                  <a:schemeClr val="tx2"/>
                 </a:solidFill>
                 <a:latin typeface="Calibri" pitchFamily="34" charset="0"/>
                 <a:ea typeface="Calibri" pitchFamily="34" charset="-122"/>
                 <a:cs typeface="Calibri" pitchFamily="34" charset="-120"/>
               </a:rPr>
-              <a:t>1</a:t>
-            </a:r>
-            <a:endParaRPr lang="en-US" sz="1400" dirty="0"/>
-          </a:p>
-        </p:txBody>
-      </p:sp>
-      <p:sp>
-        <p:nvSpPr>
-          <p:cNvPr id="6" name="Text 4"/>
-          <p:cNvSpPr txBox="1"/>
-          <p:nvPr/>
-        </p:nvSpPr>
-        <p:spPr>
-          <a:xfrm>
-            <a:off x="1005840" y="1252728"/>
-            <a:ext cx="1325880" cy="365760"/>
-          </a:xfrm>
-          <a:prstGeom prst="rect">
-            <a:avLst/>
-          </a:prstGeom>
-          <a:noFill/>
-          <a:ln/>
-        </p:spPr>
-        <p:txBody>
-          <a:bodyPr wrap="square" lIns="0" tIns="0" rIns="0" bIns="0" rtlCol="0" anchor="ctr"/>
-          <a:lstStyle/>
-          <a:p>
-            <a:pPr indent="0" marL="0">
-              <a:buNone/>
-            </a:pPr>
-            <a:r>
-              <a:rPr lang="en-US" sz="1500" b="1" dirty="0">
-                <a:solidFill>
-                  <a:schemeClr val="tx1"/>
-                </a:solidFill>
-                <a:latin typeface="Calibri" pitchFamily="34" charset="0"/>
-                <a:ea typeface="Calibri" pitchFamily="34" charset="-122"/>
-                <a:cs typeface="Calibri" pitchFamily="34" charset="-120"/>
-              </a:rPr>
-              <a:t>Dashboard</a:t>
-            </a:r>
-            <a:endParaRPr lang="en-US" sz="1500" dirty="0"/>
-          </a:p>
-        </p:txBody>
-      </p:sp>
-      <p:sp>
-        <p:nvSpPr>
-          <p:cNvPr id="7" name="Text 5"/>
-          <p:cNvSpPr txBox="1"/>
-          <p:nvPr/>
-        </p:nvSpPr>
-        <p:spPr>
-          <a:xfrm>
-            <a:off x="566928" y="1709928"/>
-            <a:ext cx="1737360" cy="868680"/>
-          </a:xfrm>
-          <a:prstGeom prst="rect">
-            <a:avLst/>
-          </a:prstGeom>
-          <a:noFill/>
-          <a:ln/>
-        </p:spPr>
-        <p:txBody>
-          <a:bodyPr wrap="square" lIns="0" tIns="0" rIns="0" bIns="0" rtlCol="0" anchor="t"/>
-          <a:lstStyle/>
-          <a:p>
-            <a:pPr indent="0" marL="0">
-              <a:buNone/>
-            </a:pPr>
-            <a:r>
-              <a:rPr lang="en-US" sz="1300" dirty="0">
-                <a:solidFill>
-                  <a:schemeClr val="tx2"/>
-                </a:solidFill>
-                <a:latin typeface="Calibri" pitchFamily="34" charset="0"/>
-                <a:ea typeface="Calibri" pitchFamily="34" charset="-122"/>
-                <a:cs typeface="Calibri" pitchFamily="34" charset="-120"/>
-              </a:rPr>
-              <a:t>four GPUs with memory and temperature reported by each node</a:t>
+              <a:t>prefix_aware had the lowest median TTFT, 2.3x lower than least_connections. Its 95th percentile was 2671 ms, against 1690 ms for swiftserve. Single run: 60 requests per policy, 6 tenants with system prompts of about 1500 tokens, concurrency 8, 4 replicas, policies run one after another.</a:t>
             </a:r>
             <a:endParaRPr lang="en-US" sz="1300" dirty="0"/>
           </a:p>
         </p:txBody>
       </p:sp>
-      <p:sp>
-        <p:nvSpPr>
-          <p:cNvPr id="8" name="Demo step 2"/>
-          <p:cNvSpPr/>
-          <p:nvPr/>
-        </p:nvSpPr>
-        <p:spPr>
-          <a:xfrm>
-            <a:off x="2542032" y="1143000"/>
-            <a:ext cx="1920240" cy="1463040"/>
-          </a:xfrm>
-          <a:prstGeom prst="roundRect">
-            <a:avLst>
-              <a:gd name="adj" fmla="val 5000"/>
-            </a:avLst>
-          </a:prstGeom>
-          <a:solidFill>
-            <a:schemeClr val="bg2"/>
-          </a:solidFill>
-          <a:ln w="12700">
-            <a:solidFill>
-              <a:schemeClr val="bg2"/>
-            </a:solidFill>
-            <a:prstDash val="solid"/>
-          </a:ln>
-          <a:effectLst>
-            <a:outerShdw sx="100000" sy="100000" kx="0" ky="0" algn="bl" rotWithShape="0" blurRad="101600" dist="25400" dir="5400000">
-              <a:srgbClr val="000000">
-                <a:alpha val="12000"/>
-              </a:srgbClr>
-            </a:outerShdw>
-          </a:effectLst>
-        </p:spPr>
-      </p:sp>
-      <p:sp>
-        <p:nvSpPr>
-          <p:cNvPr id="9" name="Demo step 2 number"/>
-          <p:cNvSpPr/>
-          <p:nvPr/>
-        </p:nvSpPr>
-        <p:spPr>
-          <a:xfrm>
-            <a:off x="2651760" y="1252728"/>
-            <a:ext cx="365760" cy="365760"/>
-          </a:xfrm>
-          <a:prstGeom prst="ellipse">
-            <a:avLst/>
-          </a:prstGeom>
-          <a:solidFill>
-            <a:schemeClr val="accent1"/>
-          </a:solidFill>
-          <a:ln w="12700">
-            <a:solidFill>
-              <a:schemeClr val="accent1"/>
-            </a:solidFill>
-            <a:prstDash val="solid"/>
-          </a:ln>
-        </p:spPr>
-      </p:sp>
-      <p:sp>
-        <p:nvSpPr>
-          <p:cNvPr id="10" name="Text 8"/>
-          <p:cNvSpPr txBox="1"/>
-          <p:nvPr/>
-        </p:nvSpPr>
-        <p:spPr>
-          <a:xfrm>
-            <a:off x="2651760" y="1252728"/>
-            <a:ext cx="365760" cy="365760"/>
-          </a:xfrm>
-          <a:prstGeom prst="rect">
-            <a:avLst/>
-          </a:prstGeom>
-          <a:noFill/>
-          <a:ln/>
-        </p:spPr>
-        <p:txBody>
-          <a:bodyPr wrap="square" lIns="0" tIns="0" rIns="0" bIns="0" rtlCol="0" anchor="ctr"/>
-          <a:lstStyle/>
-          <a:p>
-            <a:pPr algn="ctr" indent="0" marL="0">
-              <a:buNone/>
-            </a:pPr>
-            <a:r>
-              <a:rPr lang="en-US" sz="1400" b="1" dirty="0">
-                <a:solidFill>
-                  <a:schemeClr val="bg1"/>
-                </a:solidFill>
-                <a:latin typeface="Calibri" pitchFamily="34" charset="0"/>
-                <a:ea typeface="Calibri" pitchFamily="34" charset="-122"/>
-                <a:cs typeface="Calibri" pitchFamily="34" charset="-120"/>
-              </a:rPr>
-              <a:t>2</a:t>
-            </a:r>
-            <a:endParaRPr lang="en-US" sz="1400" dirty="0"/>
-          </a:p>
-        </p:txBody>
-      </p:sp>
-      <p:sp>
-        <p:nvSpPr>
-          <p:cNvPr id="11" name="Text 9"/>
-          <p:cNvSpPr txBox="1"/>
-          <p:nvPr/>
-        </p:nvSpPr>
-        <p:spPr>
-          <a:xfrm>
-            <a:off x="3090672" y="1252728"/>
-            <a:ext cx="1325880" cy="365760"/>
-          </a:xfrm>
-          <a:prstGeom prst="rect">
-            <a:avLst/>
-          </a:prstGeom>
-          <a:noFill/>
-          <a:ln/>
-        </p:spPr>
-        <p:txBody>
-          <a:bodyPr wrap="square" lIns="0" tIns="0" rIns="0" bIns="0" rtlCol="0" anchor="ctr"/>
-          <a:lstStyle/>
-          <a:p>
-            <a:pPr indent="0" marL="0">
-              <a:buNone/>
-            </a:pPr>
-            <a:r>
-              <a:rPr lang="en-US" sz="1500" b="1" dirty="0">
-                <a:solidFill>
-                  <a:schemeClr val="tx1"/>
-                </a:solidFill>
-                <a:latin typeface="Calibri" pitchFamily="34" charset="0"/>
-                <a:ea typeface="Calibri" pitchFamily="34" charset="-122"/>
-                <a:cs typeface="Calibri" pitchFamily="34" charset="-120"/>
-              </a:rPr>
-              <a:t>Playground</a:t>
-            </a:r>
-            <a:endParaRPr lang="en-US" sz="1500" dirty="0"/>
-          </a:p>
-        </p:txBody>
-      </p:sp>
-      <p:sp>
-        <p:nvSpPr>
-          <p:cNvPr id="12" name="Text 10"/>
-          <p:cNvSpPr txBox="1"/>
-          <p:nvPr/>
-        </p:nvSpPr>
-        <p:spPr>
-          <a:xfrm>
-            <a:off x="2651760" y="1709928"/>
-            <a:ext cx="1737360" cy="868680"/>
-          </a:xfrm>
-          <a:prstGeom prst="rect">
-            <a:avLst/>
-          </a:prstGeom>
-          <a:noFill/>
-          <a:ln/>
-        </p:spPr>
-        <p:txBody>
-          <a:bodyPr wrap="square" lIns="0" tIns="0" rIns="0" bIns="0" rtlCol="0" anchor="t"/>
-          <a:lstStyle/>
-          <a:p>
-            <a:pPr indent="0" marL="0">
-              <a:buNone/>
-            </a:pPr>
-            <a:r>
-              <a:rPr lang="en-US" sz="1300" dirty="0">
-                <a:solidFill>
-                  <a:schemeClr val="tx2"/>
-                </a:solidFill>
-                <a:latin typeface="Calibri" pitchFamily="34" charset="0"/>
-                <a:ea typeface="Calibri" pitchFamily="34" charset="-122"/>
-                <a:cs typeface="Calibri" pitchFamily="34" charset="-120"/>
-              </a:rPr>
-              <a:t>one request twice: cold, then with the prefix cached</a:t>
-            </a:r>
-            <a:endParaRPr lang="en-US" sz="1300" dirty="0"/>
-          </a:p>
-        </p:txBody>
-      </p:sp>
-      <p:sp>
-        <p:nvSpPr>
-          <p:cNvPr id="13" name="Demo step 3"/>
-          <p:cNvSpPr/>
-          <p:nvPr/>
-        </p:nvSpPr>
-        <p:spPr>
-          <a:xfrm>
-            <a:off x="4626864" y="1143000"/>
-            <a:ext cx="1920240" cy="1463040"/>
-          </a:xfrm>
-          <a:prstGeom prst="roundRect">
-            <a:avLst>
-              <a:gd name="adj" fmla="val 5000"/>
-            </a:avLst>
-          </a:prstGeom>
-          <a:solidFill>
-            <a:schemeClr val="bg2"/>
-          </a:solidFill>
-          <a:ln w="12700">
-            <a:solidFill>
-              <a:schemeClr val="bg2"/>
-            </a:solidFill>
-            <a:prstDash val="solid"/>
-          </a:ln>
-          <a:effectLst>
-            <a:outerShdw sx="100000" sy="100000" kx="0" ky="0" algn="bl" rotWithShape="0" blurRad="101600" dist="25400" dir="5400000">
-              <a:srgbClr val="000000">
-                <a:alpha val="12000"/>
-              </a:srgbClr>
-            </a:outerShdw>
-          </a:effectLst>
-        </p:spPr>
-      </p:sp>
-      <p:sp>
-        <p:nvSpPr>
-          <p:cNvPr id="14" name="Demo step 3 number"/>
-          <p:cNvSpPr/>
-          <p:nvPr/>
-        </p:nvSpPr>
-        <p:spPr>
-          <a:xfrm>
-            <a:off x="4736592" y="1252728"/>
-            <a:ext cx="365760" cy="365760"/>
-          </a:xfrm>
-          <a:prstGeom prst="ellipse">
-            <a:avLst/>
-          </a:prstGeom>
-          <a:solidFill>
-            <a:schemeClr val="accent1"/>
-          </a:solidFill>
-          <a:ln w="12700">
-            <a:solidFill>
-              <a:schemeClr val="accent1"/>
-            </a:solidFill>
-            <a:prstDash val="solid"/>
-          </a:ln>
-        </p:spPr>
-      </p:sp>
-      <p:sp>
-        <p:nvSpPr>
-          <p:cNvPr id="15" name="Text 13"/>
-          <p:cNvSpPr txBox="1"/>
-          <p:nvPr/>
-        </p:nvSpPr>
-        <p:spPr>
-          <a:xfrm>
-            <a:off x="4736592" y="1252728"/>
-            <a:ext cx="365760" cy="365760"/>
-          </a:xfrm>
-          <a:prstGeom prst="rect">
-            <a:avLst/>
-          </a:prstGeom>
-          <a:noFill/>
-          <a:ln/>
-        </p:spPr>
-        <p:txBody>
-          <a:bodyPr wrap="square" lIns="0" tIns="0" rIns="0" bIns="0" rtlCol="0" anchor="ctr"/>
-          <a:lstStyle/>
-          <a:p>
-            <a:pPr algn="ctr" indent="0" marL="0">
-              <a:buNone/>
-            </a:pPr>
-            <a:r>
-              <a:rPr lang="en-US" sz="1400" b="1" dirty="0">
-                <a:solidFill>
-                  <a:schemeClr val="bg1"/>
-                </a:solidFill>
-                <a:latin typeface="Calibri" pitchFamily="34" charset="0"/>
-                <a:ea typeface="Calibri" pitchFamily="34" charset="-122"/>
-                <a:cs typeface="Calibri" pitchFamily="34" charset="-120"/>
-              </a:rPr>
-              <a:t>3</a:t>
-            </a:r>
-            <a:endParaRPr lang="en-US" sz="1400" dirty="0"/>
-          </a:p>
-        </p:txBody>
-      </p:sp>
-      <p:sp>
-        <p:nvSpPr>
-          <p:cNvPr id="16" name="Text 14"/>
-          <p:cNvSpPr txBox="1"/>
-          <p:nvPr/>
-        </p:nvSpPr>
-        <p:spPr>
-          <a:xfrm>
-            <a:off x="5175504" y="1252728"/>
-            <a:ext cx="1325880" cy="365760"/>
-          </a:xfrm>
-          <a:prstGeom prst="rect">
-            <a:avLst/>
-          </a:prstGeom>
-          <a:noFill/>
-          <a:ln/>
-        </p:spPr>
-        <p:txBody>
-          <a:bodyPr wrap="square" lIns="0" tIns="0" rIns="0" bIns="0" rtlCol="0" anchor="ctr"/>
-          <a:lstStyle/>
-          <a:p>
-            <a:pPr indent="0" marL="0">
-              <a:buNone/>
-            </a:pPr>
-            <a:r>
-              <a:rPr lang="en-US" sz="1500" b="1" dirty="0">
-                <a:solidFill>
-                  <a:schemeClr val="tx1"/>
-                </a:solidFill>
-                <a:latin typeface="Calibri" pitchFamily="34" charset="0"/>
-                <a:ea typeface="Calibri" pitchFamily="34" charset="-122"/>
-                <a:cs typeface="Calibri" pitchFamily="34" charset="-120"/>
-              </a:rPr>
-              <a:t>Compare</a:t>
-            </a:r>
-            <a:endParaRPr lang="en-US" sz="1500" dirty="0"/>
-          </a:p>
-        </p:txBody>
-      </p:sp>
-      <p:sp>
-        <p:nvSpPr>
-          <p:cNvPr id="17" name="Text 15"/>
-          <p:cNvSpPr txBox="1"/>
-          <p:nvPr/>
-        </p:nvSpPr>
-        <p:spPr>
-          <a:xfrm>
-            <a:off x="4736592" y="1709928"/>
-            <a:ext cx="1737360" cy="868680"/>
-          </a:xfrm>
-          <a:prstGeom prst="rect">
-            <a:avLst/>
-          </a:prstGeom>
-          <a:noFill/>
-          <a:ln/>
-        </p:spPr>
-        <p:txBody>
-          <a:bodyPr wrap="square" lIns="0" tIns="0" rIns="0" bIns="0" rtlCol="0" anchor="t"/>
-          <a:lstStyle/>
-          <a:p>
-            <a:pPr indent="0" marL="0">
-              <a:buNone/>
-            </a:pPr>
-            <a:r>
-              <a:rPr lang="en-US" sz="1300" dirty="0">
-                <a:solidFill>
-                  <a:schemeClr val="tx2"/>
-                </a:solidFill>
-                <a:latin typeface="Calibri" pitchFamily="34" charset="0"/>
-                <a:ea typeface="Calibri" pitchFamily="34" charset="-122"/>
-                <a:cs typeface="Calibri" pitchFamily="34" charset="-120"/>
-              </a:rPr>
-              <a:t>the same multi-tenant workload through all four policies</a:t>
-            </a:r>
-            <a:endParaRPr lang="en-US" sz="1300" dirty="0"/>
-          </a:p>
-        </p:txBody>
-      </p:sp>
-      <p:sp>
-        <p:nvSpPr>
-          <p:cNvPr id="18" name="Demo step 4"/>
-          <p:cNvSpPr/>
-          <p:nvPr/>
-        </p:nvSpPr>
-        <p:spPr>
-          <a:xfrm>
-            <a:off x="6711696" y="1143000"/>
-            <a:ext cx="1920240" cy="1463040"/>
-          </a:xfrm>
-          <a:prstGeom prst="roundRect">
-            <a:avLst>
-              <a:gd name="adj" fmla="val 5000"/>
-            </a:avLst>
-          </a:prstGeom>
-          <a:solidFill>
-            <a:schemeClr val="bg2"/>
-          </a:solidFill>
-          <a:ln w="12700">
-            <a:solidFill>
-              <a:schemeClr val="bg2"/>
-            </a:solidFill>
-            <a:prstDash val="solid"/>
-          </a:ln>
-          <a:effectLst>
-            <a:outerShdw sx="100000" sy="100000" kx="0" ky="0" algn="bl" rotWithShape="0" blurRad="101600" dist="25400" dir="5400000">
-              <a:srgbClr val="000000">
-                <a:alpha val="12000"/>
-              </a:srgbClr>
-            </a:outerShdw>
-          </a:effectLst>
-        </p:spPr>
-      </p:sp>
-      <p:sp>
-        <p:nvSpPr>
-          <p:cNvPr id="19" name="Demo step 4 number"/>
-          <p:cNvSpPr/>
-          <p:nvPr/>
-        </p:nvSpPr>
-        <p:spPr>
-          <a:xfrm>
-            <a:off x="6821424" y="1252728"/>
-            <a:ext cx="365760" cy="365760"/>
-          </a:xfrm>
-          <a:prstGeom prst="ellipse">
-            <a:avLst/>
-          </a:prstGeom>
-          <a:solidFill>
-            <a:schemeClr val="accent1"/>
-          </a:solidFill>
-          <a:ln w="12700">
-            <a:solidFill>
-              <a:schemeClr val="accent1"/>
-            </a:solidFill>
-            <a:prstDash val="solid"/>
-          </a:ln>
-        </p:spPr>
-      </p:sp>
-      <p:sp>
-        <p:nvSpPr>
-          <p:cNvPr id="20" name="Text 18"/>
-          <p:cNvSpPr txBox="1"/>
-          <p:nvPr/>
-        </p:nvSpPr>
-        <p:spPr>
-          <a:xfrm>
-            <a:off x="6821424" y="1252728"/>
-            <a:ext cx="365760" cy="365760"/>
-          </a:xfrm>
-          <a:prstGeom prst="rect">
-            <a:avLst/>
-          </a:prstGeom>
-          <a:noFill/>
-          <a:ln/>
-        </p:spPr>
-        <p:txBody>
-          <a:bodyPr wrap="square" lIns="0" tIns="0" rIns="0" bIns="0" rtlCol="0" anchor="ctr"/>
-          <a:lstStyle/>
-          <a:p>
-            <a:pPr algn="ctr" indent="0" marL="0">
-              <a:buNone/>
-            </a:pPr>
-            <a:r>
-              <a:rPr lang="en-US" sz="1400" b="1" dirty="0">
-                <a:solidFill>
-                  <a:schemeClr val="bg1"/>
-                </a:solidFill>
-                <a:latin typeface="Calibri" pitchFamily="34" charset="0"/>
-                <a:ea typeface="Calibri" pitchFamily="34" charset="-122"/>
-                <a:cs typeface="Calibri" pitchFamily="34" charset="-120"/>
-              </a:rPr>
-              <a:t>4</a:t>
-            </a:r>
-            <a:endParaRPr lang="en-US" sz="1400" dirty="0"/>
-          </a:p>
-        </p:txBody>
-      </p:sp>
-      <p:sp>
-        <p:nvSpPr>
-          <p:cNvPr id="21" name="Text 19"/>
-          <p:cNvSpPr txBox="1"/>
-          <p:nvPr/>
-        </p:nvSpPr>
-        <p:spPr>
-          <a:xfrm>
-            <a:off x="7260336" y="1252728"/>
-            <a:ext cx="1325880" cy="365760"/>
-          </a:xfrm>
-          <a:prstGeom prst="rect">
-            <a:avLst/>
-          </a:prstGeom>
-          <a:noFill/>
-          <a:ln/>
-        </p:spPr>
-        <p:txBody>
-          <a:bodyPr wrap="square" lIns="0" tIns="0" rIns="0" bIns="0" rtlCol="0" anchor="ctr"/>
-          <a:lstStyle/>
-          <a:p>
-            <a:pPr indent="0" marL="0">
-              <a:buNone/>
-            </a:pPr>
-            <a:r>
-              <a:rPr lang="en-US" sz="1500" b="1" dirty="0">
-                <a:solidFill>
-                  <a:schemeClr val="tx1"/>
-                </a:solidFill>
-                <a:latin typeface="Calibri" pitchFamily="34" charset="0"/>
-                <a:ea typeface="Calibri" pitchFamily="34" charset="-122"/>
-                <a:cs typeface="Calibri" pitchFamily="34" charset="-120"/>
-              </a:rPr>
-              <a:t>Live routing</a:t>
-            </a:r>
-            <a:endParaRPr lang="en-US" sz="1500" dirty="0"/>
-          </a:p>
-        </p:txBody>
-      </p:sp>
-      <p:sp>
-        <p:nvSpPr>
-          <p:cNvPr id="22" name="Text 20"/>
-          <p:cNvSpPr txBox="1"/>
-          <p:nvPr/>
-        </p:nvSpPr>
-        <p:spPr>
-          <a:xfrm>
-            <a:off x="6821424" y="1709928"/>
-            <a:ext cx="1737360" cy="868680"/>
-          </a:xfrm>
-          <a:prstGeom prst="rect">
-            <a:avLst/>
-          </a:prstGeom>
-          <a:noFill/>
-          <a:ln/>
-        </p:spPr>
-        <p:txBody>
-          <a:bodyPr wrap="square" lIns="0" tIns="0" rIns="0" bIns="0" rtlCol="0" anchor="t"/>
-          <a:lstStyle/>
-          <a:p>
-            <a:pPr indent="0" marL="0">
-              <a:buNone/>
-            </a:pPr>
-            <a:r>
-              <a:rPr lang="en-US" sz="1300" dirty="0">
-                <a:solidFill>
-                  <a:schemeClr val="tx2"/>
-                </a:solidFill>
-                <a:latin typeface="Calibri" pitchFamily="34" charset="0"/>
-                <a:ea typeface="Calibri" pitchFamily="34" charset="-122"/>
-                <a:cs typeface="Calibri" pitchFamily="34" charset="-120"/>
-              </a:rPr>
-              <a:t>requests spreading across the replicas as they run</a:t>
-            </a:r>
-            <a:endParaRPr lang="en-US" sz="1300" dirty="0"/>
-          </a:p>
-        </p:txBody>
-      </p:sp>
-      <p:pic>
-        <p:nvPicPr>
-          <p:cNvPr id="23" name="Dashboard screenshot" descr="Dashboard screenshot">    </p:cNvPr>
-          <p:cNvPicPr>
-            <a:picLocks noChangeAspect="1"/>
-          </p:cNvPicPr>
-          <p:nvPr/>
-        </p:nvPicPr>
-        <p:blipFill>
-          <a:blip r:embed="rId1"/>
-          <a:stretch>
-            <a:fillRect/>
-          </a:stretch>
-        </p:blipFill>
-        <p:spPr>
-          <a:xfrm>
-            <a:off x="457200" y="2895438"/>
-            <a:ext cx="8229600" cy="1707204"/>
-          </a:xfrm>
-          <a:prstGeom prst="rect">
-            <a:avLst/>
-          </a:prstGeom>
-          <a:effectLst>
-            <a:outerShdw sx="100000" sy="100000" kx="0" ky="0" algn="bl" rotWithShape="0" blurRad="101600" dist="25400" dir="5400000">
-              <a:srgbClr val="000000">
-                <a:alpha val="12000"/>
-              </a:srgbClr>
-            </a:outerShdw>
-          </a:effectLst>
-        </p:spPr>
-      </p:pic>
       <p:sp>
         <p:nvSpPr>
           <p:cNvPr id="25" name="Slide Number Placeholder 0"/>
@@ -9008,7 +9835,7 @@
                 <a:ea typeface="Cambria" pitchFamily="34" charset="-122"/>
                 <a:cs typeface="Cambria" pitchFamily="34" charset="-120"/>
               </a:rPr>
-              <a:t>Limits and next steps</a:t>
+              <a:t>Live demonstration</a:t>
             </a:r>
             <a:endParaRPr lang="en-US" sz="3200" dirty="0"/>
           </a:p>
@@ -9016,18 +9843,18 @@
       </p:sp>
       <p:sp>
         <p:nvSpPr>
-          <p:cNvPr id="3" name="Current limits panel"/>
+          <p:cNvPr id="3" name="Demo step 1"/>
           <p:cNvSpPr/>
           <p:nvPr/>
         </p:nvSpPr>
         <p:spPr>
           <a:xfrm>
-            <a:off x="457200" y="1188720"/>
-            <a:ext cx="4023360" cy="3520440"/>
+            <a:off x="457200" y="1143000"/>
+            <a:ext cx="1920240" cy="1463040"/>
           </a:xfrm>
           <a:prstGeom prst="roundRect">
             <a:avLst>
-              <a:gd name="adj" fmla="val 2078"/>
+              <a:gd name="adj" fmla="val 5000"/>
             </a:avLst>
           </a:prstGeom>
           <a:solidFill>
@@ -9050,14 +9877,39 @@
       </p:sp>
       <p:sp>
         <p:nvSpPr>
-          <p:cNvPr id="4" name="Text 2"/>
+          <p:cNvPr id="4" name="Demo step 1 number"/>
+          <p:cNvSpPr/>
+          <p:nvPr/>
+        </p:nvSpPr>
+        <p:spPr>
+          <a:xfrm>
+            <a:off x="566928" y="1252728"/>
+            <a:ext cx="365760" cy="365760"/>
+          </a:xfrm>
+          <a:prstGeom prst="ellipse">
+            <a:avLst/>
+          </a:prstGeom>
+          <a:solidFill>
+            <a:schemeClr val="accent1"/>
+          </a:solidFill>
+          <a:ln w="12700">
+            <a:solidFill>
+              <a:schemeClr val="accent1"/>
+            </a:solidFill>
+            <a:prstDash val="solid"/>
+          </a:ln>
+        </p:spPr>
+      </p:sp>
+      <p:sp>
+        <p:nvSpPr>
+          <p:cNvPr id="5" name="Text 3"/>
           <p:cNvSpPr txBox="1"/>
           <p:nvPr/>
         </p:nvSpPr>
         <p:spPr>
           <a:xfrm>
-            <a:off x="685800" y="1325880"/>
-            <a:ext cx="3566160" cy="365760"/>
+            <a:off x="566928" y="1252728"/>
+            <a:ext cx="365760" cy="365760"/>
           </a:xfrm>
           <a:prstGeom prst="rect">
             <a:avLst/>
@@ -9066,78 +9918,53 @@
           <a:ln/>
         </p:spPr>
         <p:txBody>
-          <a:bodyPr wrap="square" lIns="0" tIns="0" rIns="0" bIns="0" rtlCol="0" anchor="t"/>
+          <a:bodyPr wrap="square" lIns="0" tIns="0" rIns="0" bIns="0" rtlCol="0" anchor="ctr"/>
           <a:lstStyle/>
           <a:p>
-            <a:pPr indent="0" marL="0">
+            <a:pPr algn="ctr" indent="0" marL="0">
               <a:buNone/>
             </a:pPr>
             <a:r>
-              <a:rPr lang="en-US" sz="2000" b="1" dirty="0">
-                <a:solidFill>
-                  <a:schemeClr val="accent5"/>
-                </a:solidFill>
-                <a:latin typeface="Cambria" pitchFamily="34" charset="0"/>
-                <a:ea typeface="Cambria" pitchFamily="34" charset="-122"/>
-                <a:cs typeface="Cambria" pitchFamily="34" charset="-120"/>
-              </a:rPr>
-              <a:t>Current limits</a:t>
-            </a:r>
-            <a:endParaRPr lang="en-US" sz="2000" dirty="0"/>
-          </a:p>
-        </p:txBody>
-      </p:sp>
-      <p:sp>
-        <p:nvSpPr>
-          <p:cNvPr id="5" name="Text 3"/>
-          <p:cNvSpPr txBox="1"/>
-          <p:nvPr/>
-        </p:nvSpPr>
-        <p:spPr>
-          <a:xfrm>
-            <a:off x="685800" y="1828800"/>
-            <a:ext cx="3566160" cy="2743200"/>
-          </a:xfrm>
-          <a:prstGeom prst="rect">
-            <a:avLst/>
-          </a:prstGeom>
-          <a:noFill/>
-          <a:ln/>
-        </p:spPr>
-        <p:txBody>
-          <a:bodyPr wrap="square" lIns="0" tIns="0" rIns="0" bIns="0" rtlCol="0" anchor="t"/>
-          <a:lstStyle/>
-          <a:p>
-            <a:pPr marL="342900" indent="-342900">
-              <a:spcAft>
-                <a:spcPts val="800"/>
-              </a:spcAft>
-              <a:buSzPct val="100000"/>
-              <a:buChar char="•"/>
-            </a:pPr>
-            <a:r>
-              <a:rPr lang="en-US" sz="1400" dirty="0">
-                <a:solidFill>
-                  <a:schemeClr val="tx1"/>
+              <a:rPr lang="en-US" sz="1400" b="1" dirty="0">
+                <a:solidFill>
+                  <a:schemeClr val="bg1"/>
                 </a:solidFill>
                 <a:latin typeface="Calibri" pitchFamily="34" charset="0"/>
                 <a:ea typeface="Calibri" pitchFamily="34" charset="-122"/>
                 <a:cs typeface="Calibri" pitchFamily="34" charset="-120"/>
               </a:rPr>
-              <a:t>The router's index is a belief. A failed request can leave a stale entry, and the index does not see engine evictions.</a:t>
+              <a:t>1</a:t>
             </a:r>
             <a:endParaRPr lang="en-US" sz="1400" dirty="0"/>
           </a:p>
-          <a:p>
-            <a:pPr marL="342900" indent="-342900">
-              <a:spcAft>
-                <a:spcPts val="800"/>
-              </a:spcAft>
-              <a:buSzPct val="100000"/>
-              <a:buChar char="•"/>
+        </p:txBody>
+      </p:sp>
+      <p:sp>
+        <p:nvSpPr>
+          <p:cNvPr id="6" name="Text 4"/>
+          <p:cNvSpPr txBox="1"/>
+          <p:nvPr/>
+        </p:nvSpPr>
+        <p:spPr>
+          <a:xfrm>
+            <a:off x="1005840" y="1252728"/>
+            <a:ext cx="1325880" cy="365760"/>
+          </a:xfrm>
+          <a:prstGeom prst="rect">
+            <a:avLst/>
+          </a:prstGeom>
+          <a:noFill/>
+          <a:ln/>
+        </p:spPr>
+        <p:txBody>
+          <a:bodyPr wrap="square" lIns="0" tIns="0" rIns="0" bIns="0" rtlCol="0" anchor="ctr"/>
+          <a:lstStyle/>
+          <a:p>
+            <a:pPr indent="0" marL="0">
+              <a:buNone/>
             </a:pPr>
             <a:r>
-              <a:rPr lang="en-US" sz="1400" dirty="0">
+              <a:rPr lang="en-US" sz="1500" b="1" dirty="0">
                 <a:solidFill>
                   <a:schemeClr val="tx1"/>
                 </a:solidFill>
@@ -9145,68 +9972,65 @@
                 <a:ea typeface="Calibri" pitchFamily="34" charset="-122"/>
                 <a:cs typeface="Calibri" pitchFamily="34" charset="-120"/>
               </a:rPr>
-              <a:t>Connection errors retry the same replica; there is no failover to another one.</a:t>
-            </a:r>
-            <a:endParaRPr lang="en-US" sz="1400" dirty="0"/>
-          </a:p>
-          <a:p>
-            <a:pPr marL="342900" indent="-342900">
-              <a:spcAft>
-                <a:spcPts val="800"/>
-              </a:spcAft>
-              <a:buSzPct val="100000"/>
-              <a:buChar char="•"/>
+              <a:t>Dashboard</a:t>
+            </a:r>
+            <a:endParaRPr lang="en-US" sz="1500" dirty="0"/>
+          </a:p>
+        </p:txBody>
+      </p:sp>
+      <p:sp>
+        <p:nvSpPr>
+          <p:cNvPr id="7" name="Text 5"/>
+          <p:cNvSpPr txBox="1"/>
+          <p:nvPr/>
+        </p:nvSpPr>
+        <p:spPr>
+          <a:xfrm>
+            <a:off x="566928" y="1709928"/>
+            <a:ext cx="1737360" cy="868680"/>
+          </a:xfrm>
+          <a:prstGeom prst="rect">
+            <a:avLst/>
+          </a:prstGeom>
+          <a:noFill/>
+          <a:ln/>
+        </p:spPr>
+        <p:txBody>
+          <a:bodyPr wrap="square" lIns="0" tIns="0" rIns="0" bIns="0" rtlCol="0" anchor="t"/>
+          <a:lstStyle/>
+          <a:p>
+            <a:pPr indent="0" marL="0">
+              <a:buNone/>
             </a:pPr>
             <a:r>
-              <a:rPr lang="en-US" sz="1400" dirty="0">
-                <a:solidFill>
-                  <a:schemeClr val="tx1"/>
+              <a:rPr lang="en-US" sz="1300" dirty="0">
+                <a:solidFill>
+                  <a:schemeClr val="tx2"/>
                 </a:solidFill>
                 <a:latin typeface="Calibri" pitchFamily="34" charset="0"/>
                 <a:ea typeface="Calibri" pitchFamily="34" charset="-122"/>
                 <a:cs typeface="Calibri" pitchFamily="34" charset="-120"/>
               </a:rPr>
-              <a:t>Latency through tunnels includes network delay.</a:t>
-            </a:r>
-            <a:endParaRPr lang="en-US" sz="1400" dirty="0"/>
-          </a:p>
-          <a:p>
-            <a:pPr marL="342900" indent="-342900">
-              <a:spcAft>
-                <a:spcPts val="800"/>
-              </a:spcAft>
-              <a:buSzPct val="100000"/>
-              <a:buChar char="•"/>
-            </a:pPr>
-            <a:r>
-              <a:rPr lang="en-US" sz="1400" dirty="0">
-                <a:solidFill>
-                  <a:schemeClr val="tx1"/>
-                </a:solidFill>
-                <a:latin typeface="Calibri" pitchFamily="34" charset="0"/>
-                <a:ea typeface="Calibri" pitchFamily="34" charset="-122"/>
-                <a:cs typeface="Calibri" pitchFamily="34" charset="-120"/>
-              </a:rPr>
-              <a:t>Policies are compared one after another on one model, so results are a controlled demonstration.</a:t>
-            </a:r>
-            <a:endParaRPr lang="en-US" sz="1400" dirty="0"/>
-          </a:p>
-        </p:txBody>
-      </p:sp>
-      <p:sp>
-        <p:nvSpPr>
-          <p:cNvPr id="6" name="Next steps panel"/>
+              <a:t>four GPUs with memory and temperature reported by each node</a:t>
+            </a:r>
+            <a:endParaRPr lang="en-US" sz="1300" dirty="0"/>
+          </a:p>
+        </p:txBody>
+      </p:sp>
+      <p:sp>
+        <p:nvSpPr>
+          <p:cNvPr id="8" name="Demo step 2"/>
           <p:cNvSpPr/>
           <p:nvPr/>
         </p:nvSpPr>
         <p:spPr>
           <a:xfrm>
-            <a:off x="4663440" y="1188720"/>
-            <a:ext cx="4023360" cy="3520440"/>
+            <a:off x="2542032" y="1143000"/>
+            <a:ext cx="1920240" cy="1463040"/>
           </a:xfrm>
           <a:prstGeom prst="roundRect">
             <a:avLst>
-              <a:gd name="adj" fmla="val 2078"/>
+              <a:gd name="adj" fmla="val 5000"/>
             </a:avLst>
           </a:prstGeom>
           <a:solidFill>
@@ -9229,14 +10053,39 @@
       </p:sp>
       <p:sp>
         <p:nvSpPr>
-          <p:cNvPr id="7" name="Text 5"/>
+          <p:cNvPr id="9" name="Demo step 2 number"/>
+          <p:cNvSpPr/>
+          <p:nvPr/>
+        </p:nvSpPr>
+        <p:spPr>
+          <a:xfrm>
+            <a:off x="2651760" y="1252728"/>
+            <a:ext cx="365760" cy="365760"/>
+          </a:xfrm>
+          <a:prstGeom prst="ellipse">
+            <a:avLst/>
+          </a:prstGeom>
+          <a:solidFill>
+            <a:schemeClr val="accent1"/>
+          </a:solidFill>
+          <a:ln w="12700">
+            <a:solidFill>
+              <a:schemeClr val="accent1"/>
+            </a:solidFill>
+            <a:prstDash val="solid"/>
+          </a:ln>
+        </p:spPr>
+      </p:sp>
+      <p:sp>
+        <p:nvSpPr>
+          <p:cNvPr id="10" name="Text 8"/>
           <p:cNvSpPr txBox="1"/>
           <p:nvPr/>
         </p:nvSpPr>
         <p:spPr>
           <a:xfrm>
-            <a:off x="4892040" y="1325880"/>
-            <a:ext cx="3566160" cy="365760"/>
+            <a:off x="2651760" y="1252728"/>
+            <a:ext cx="365760" cy="365760"/>
           </a:xfrm>
           <a:prstGeom prst="rect">
             <a:avLst/>
@@ -9245,78 +10094,53 @@
           <a:ln/>
         </p:spPr>
         <p:txBody>
-          <a:bodyPr wrap="square" lIns="0" tIns="0" rIns="0" bIns="0" rtlCol="0" anchor="t"/>
+          <a:bodyPr wrap="square" lIns="0" tIns="0" rIns="0" bIns="0" rtlCol="0" anchor="ctr"/>
           <a:lstStyle/>
           <a:p>
-            <a:pPr indent="0" marL="0">
+            <a:pPr algn="ctr" indent="0" marL="0">
               <a:buNone/>
             </a:pPr>
             <a:r>
-              <a:rPr lang="en-US" sz="2000" b="1" dirty="0">
-                <a:solidFill>
-                  <a:schemeClr val="accent1"/>
-                </a:solidFill>
-                <a:latin typeface="Cambria" pitchFamily="34" charset="0"/>
-                <a:ea typeface="Cambria" pitchFamily="34" charset="-122"/>
-                <a:cs typeface="Cambria" pitchFamily="34" charset="-120"/>
-              </a:rPr>
-              <a:t>Next steps</a:t>
-            </a:r>
-            <a:endParaRPr lang="en-US" sz="2000" dirty="0"/>
-          </a:p>
-        </p:txBody>
-      </p:sp>
-      <p:sp>
-        <p:nvSpPr>
-          <p:cNvPr id="8" name="Text 6"/>
-          <p:cNvSpPr txBox="1"/>
-          <p:nvPr/>
-        </p:nvSpPr>
-        <p:spPr>
-          <a:xfrm>
-            <a:off x="4892040" y="1828800"/>
-            <a:ext cx="3566160" cy="2743200"/>
-          </a:xfrm>
-          <a:prstGeom prst="rect">
-            <a:avLst/>
-          </a:prstGeom>
-          <a:noFill/>
-          <a:ln/>
-        </p:spPr>
-        <p:txBody>
-          <a:bodyPr wrap="square" lIns="0" tIns="0" rIns="0" bIns="0" rtlCol="0" anchor="t"/>
-          <a:lstStyle/>
-          <a:p>
-            <a:pPr marL="342900" indent="-342900">
-              <a:spcAft>
-                <a:spcPts val="800"/>
-              </a:spcAft>
-              <a:buSzPct val="100000"/>
-              <a:buChar char="•"/>
-            </a:pPr>
-            <a:r>
-              <a:rPr lang="en-US" sz="1400" dirty="0">
-                <a:solidFill>
-                  <a:schemeClr val="tx1"/>
+              <a:rPr lang="en-US" sz="1400" b="1" dirty="0">
+                <a:solidFill>
+                  <a:schemeClr val="bg1"/>
                 </a:solidFill>
                 <a:latin typeface="Calibri" pitchFamily="34" charset="0"/>
                 <a:ea typeface="Calibri" pitchFamily="34" charset="-122"/>
                 <a:cs typeface="Calibri" pitchFamily="34" charset="-120"/>
               </a:rPr>
-              <a:t>Repeat the comparison with several seeds and report the spread.</a:t>
+              <a:t>2</a:t>
             </a:r>
             <a:endParaRPr lang="en-US" sz="1400" dirty="0"/>
           </a:p>
-          <a:p>
-            <a:pPr marL="342900" indent="-342900">
-              <a:spcAft>
-                <a:spcPts val="800"/>
-              </a:spcAft>
-              <a:buSzPct val="100000"/>
-              <a:buChar char="•"/>
+        </p:txBody>
+      </p:sp>
+      <p:sp>
+        <p:nvSpPr>
+          <p:cNvPr id="11" name="Text 9"/>
+          <p:cNvSpPr txBox="1"/>
+          <p:nvPr/>
+        </p:nvSpPr>
+        <p:spPr>
+          <a:xfrm>
+            <a:off x="3090672" y="1252728"/>
+            <a:ext cx="1325880" cy="365760"/>
+          </a:xfrm>
+          <a:prstGeom prst="rect">
+            <a:avLst/>
+          </a:prstGeom>
+          <a:noFill/>
+          <a:ln/>
+        </p:spPr>
+        <p:txBody>
+          <a:bodyPr wrap="square" lIns="0" tIns="0" rIns="0" bIns="0" rtlCol="0" anchor="ctr"/>
+          <a:lstStyle/>
+          <a:p>
+            <a:pPr indent="0" marL="0">
+              <a:buNone/>
             </a:pPr>
             <a:r>
-              <a:rPr lang="en-US" sz="1400" dirty="0">
+              <a:rPr lang="en-US" sz="1500" b="1" dirty="0">
                 <a:solidFill>
                   <a:schemeClr val="tx1"/>
                 </a:solidFill>
@@ -9324,54 +10148,434 @@
                 <a:ea typeface="Calibri" pitchFamily="34" charset="-122"/>
                 <a:cs typeface="Calibri" pitchFamily="34" charset="-120"/>
               </a:rPr>
-              <a:t>Rebuild the index from the engine's cache events instead of predictions.</a:t>
-            </a:r>
-            <a:endParaRPr lang="en-US" sz="1400" dirty="0"/>
-          </a:p>
-          <a:p>
-            <a:pPr marL="342900" indent="-342900">
-              <a:spcAft>
-                <a:spcPts val="800"/>
-              </a:spcAft>
-              <a:buSzPct val="100000"/>
-              <a:buChar char="•"/>
+              <a:t>Playground</a:t>
+            </a:r>
+            <a:endParaRPr lang="en-US" sz="1500" dirty="0"/>
+          </a:p>
+        </p:txBody>
+      </p:sp>
+      <p:sp>
+        <p:nvSpPr>
+          <p:cNvPr id="12" name="Text 10"/>
+          <p:cNvSpPr txBox="1"/>
+          <p:nvPr/>
+        </p:nvSpPr>
+        <p:spPr>
+          <a:xfrm>
+            <a:off x="2651760" y="1709928"/>
+            <a:ext cx="1737360" cy="868680"/>
+          </a:xfrm>
+          <a:prstGeom prst="rect">
+            <a:avLst/>
+          </a:prstGeom>
+          <a:noFill/>
+          <a:ln/>
+        </p:spPr>
+        <p:txBody>
+          <a:bodyPr wrap="square" lIns="0" tIns="0" rIns="0" bIns="0" rtlCol="0" anchor="t"/>
+          <a:lstStyle/>
+          <a:p>
+            <a:pPr indent="0" marL="0">
+              <a:buNone/>
             </a:pPr>
             <a:r>
-              <a:rPr lang="en-US" sz="1400" dirty="0">
-                <a:solidFill>
-                  <a:schemeClr val="tx1"/>
+              <a:rPr lang="en-US" sz="1300" dirty="0">
+                <a:solidFill>
+                  <a:schemeClr val="tx2"/>
                 </a:solidFill>
                 <a:latin typeface="Calibri" pitchFamily="34" charset="0"/>
                 <a:ea typeface="Calibri" pitchFamily="34" charset="-122"/>
                 <a:cs typeface="Calibri" pitchFamily="34" charset="-120"/>
               </a:rPr>
-              <a:t>Fail over to another replica on connection errors.</a:t>
-            </a:r>
-            <a:endParaRPr lang="en-US" sz="1400" dirty="0"/>
-          </a:p>
-          <a:p>
-            <a:pPr marL="342900" indent="-342900">
-              <a:spcAft>
-                <a:spcPts val="800"/>
-              </a:spcAft>
-              <a:buSzPct val="100000"/>
-              <a:buChar char="•"/>
+              <a:t>one request twice: cold, then with the prefix cached</a:t>
+            </a:r>
+            <a:endParaRPr lang="en-US" sz="1300" dirty="0"/>
+          </a:p>
+        </p:txBody>
+      </p:sp>
+      <p:sp>
+        <p:nvSpPr>
+          <p:cNvPr id="13" name="Demo step 3"/>
+          <p:cNvSpPr/>
+          <p:nvPr/>
+        </p:nvSpPr>
+        <p:spPr>
+          <a:xfrm>
+            <a:off x="4626864" y="1143000"/>
+            <a:ext cx="1920240" cy="1463040"/>
+          </a:xfrm>
+          <a:prstGeom prst="roundRect">
+            <a:avLst>
+              <a:gd name="adj" fmla="val 5000"/>
+            </a:avLst>
+          </a:prstGeom>
+          <a:solidFill>
+            <a:schemeClr val="bg2"/>
+          </a:solidFill>
+          <a:ln w="12700">
+            <a:solidFill>
+              <a:schemeClr val="bg2"/>
+            </a:solidFill>
+            <a:prstDash val="solid"/>
+          </a:ln>
+          <a:effectLst>
+            <a:outerShdw sx="100000" sy="100000" kx="0" ky="0" algn="bl" rotWithShape="0" blurRad="101600" dist="25400" dir="5400000">
+              <a:srgbClr val="000000">
+                <a:alpha val="12000"/>
+              </a:srgbClr>
+            </a:outerShdw>
+          </a:effectLst>
+        </p:spPr>
+      </p:sp>
+      <p:sp>
+        <p:nvSpPr>
+          <p:cNvPr id="14" name="Demo step 3 number"/>
+          <p:cNvSpPr/>
+          <p:nvPr/>
+        </p:nvSpPr>
+        <p:spPr>
+          <a:xfrm>
+            <a:off x="4736592" y="1252728"/>
+            <a:ext cx="365760" cy="365760"/>
+          </a:xfrm>
+          <a:prstGeom prst="ellipse">
+            <a:avLst/>
+          </a:prstGeom>
+          <a:solidFill>
+            <a:schemeClr val="accent1"/>
+          </a:solidFill>
+          <a:ln w="12700">
+            <a:solidFill>
+              <a:schemeClr val="accent1"/>
+            </a:solidFill>
+            <a:prstDash val="solid"/>
+          </a:ln>
+        </p:spPr>
+      </p:sp>
+      <p:sp>
+        <p:nvSpPr>
+          <p:cNvPr id="15" name="Text 13"/>
+          <p:cNvSpPr txBox="1"/>
+          <p:nvPr/>
+        </p:nvSpPr>
+        <p:spPr>
+          <a:xfrm>
+            <a:off x="4736592" y="1252728"/>
+            <a:ext cx="365760" cy="365760"/>
+          </a:xfrm>
+          <a:prstGeom prst="rect">
+            <a:avLst/>
+          </a:prstGeom>
+          <a:noFill/>
+          <a:ln/>
+        </p:spPr>
+        <p:txBody>
+          <a:bodyPr wrap="square" lIns="0" tIns="0" rIns="0" bIns="0" rtlCol="0" anchor="ctr"/>
+          <a:lstStyle/>
+          <a:p>
+            <a:pPr algn="ctr" indent="0" marL="0">
+              <a:buNone/>
             </a:pPr>
             <a:r>
-              <a:rPr lang="en-US" sz="1400" dirty="0">
-                <a:solidFill>
-                  <a:schemeClr val="tx1"/>
+              <a:rPr lang="en-US" sz="1400" b="1" dirty="0">
+                <a:solidFill>
+                  <a:schemeClr val="bg1"/>
                 </a:solidFill>
                 <a:latin typeface="Calibri" pitchFamily="34" charset="0"/>
                 <a:ea typeface="Calibri" pitchFamily="34" charset="-122"/>
                 <a:cs typeface="Calibri" pitchFamily="34" charset="-120"/>
               </a:rPr>
-              <a:t>Keep the index across router restarts.</a:t>
+              <a:t>3</a:t>
             </a:r>
             <a:endParaRPr lang="en-US" sz="1400" dirty="0"/>
           </a:p>
         </p:txBody>
       </p:sp>
+      <p:sp>
+        <p:nvSpPr>
+          <p:cNvPr id="16" name="Text 14"/>
+          <p:cNvSpPr txBox="1"/>
+          <p:nvPr/>
+        </p:nvSpPr>
+        <p:spPr>
+          <a:xfrm>
+            <a:off x="5175504" y="1252728"/>
+            <a:ext cx="1325880" cy="365760"/>
+          </a:xfrm>
+          <a:prstGeom prst="rect">
+            <a:avLst/>
+          </a:prstGeom>
+          <a:noFill/>
+          <a:ln/>
+        </p:spPr>
+        <p:txBody>
+          <a:bodyPr wrap="square" lIns="0" tIns="0" rIns="0" bIns="0" rtlCol="0" anchor="ctr"/>
+          <a:lstStyle/>
+          <a:p>
+            <a:pPr indent="0" marL="0">
+              <a:buNone/>
+            </a:pPr>
+            <a:r>
+              <a:rPr lang="en-US" sz="1500" b="1" dirty="0">
+                <a:solidFill>
+                  <a:schemeClr val="tx1"/>
+                </a:solidFill>
+                <a:latin typeface="Calibri" pitchFamily="34" charset="0"/>
+                <a:ea typeface="Calibri" pitchFamily="34" charset="-122"/>
+                <a:cs typeface="Calibri" pitchFamily="34" charset="-120"/>
+              </a:rPr>
+              <a:t>Compare</a:t>
+            </a:r>
+            <a:endParaRPr lang="en-US" sz="1500" dirty="0"/>
+          </a:p>
+        </p:txBody>
+      </p:sp>
+      <p:sp>
+        <p:nvSpPr>
+          <p:cNvPr id="17" name="Text 15"/>
+          <p:cNvSpPr txBox="1"/>
+          <p:nvPr/>
+        </p:nvSpPr>
+        <p:spPr>
+          <a:xfrm>
+            <a:off x="4736592" y="1709928"/>
+            <a:ext cx="1737360" cy="868680"/>
+          </a:xfrm>
+          <a:prstGeom prst="rect">
+            <a:avLst/>
+          </a:prstGeom>
+          <a:noFill/>
+          <a:ln/>
+        </p:spPr>
+        <p:txBody>
+          <a:bodyPr wrap="square" lIns="0" tIns="0" rIns="0" bIns="0" rtlCol="0" anchor="t"/>
+          <a:lstStyle/>
+          <a:p>
+            <a:pPr indent="0" marL="0">
+              <a:buNone/>
+            </a:pPr>
+            <a:r>
+              <a:rPr lang="en-US" sz="1300" dirty="0">
+                <a:solidFill>
+                  <a:schemeClr val="tx2"/>
+                </a:solidFill>
+                <a:latin typeface="Calibri" pitchFamily="34" charset="0"/>
+                <a:ea typeface="Calibri" pitchFamily="34" charset="-122"/>
+                <a:cs typeface="Calibri" pitchFamily="34" charset="-120"/>
+              </a:rPr>
+              <a:t>the same multi-tenant workload through all four policies</a:t>
+            </a:r>
+            <a:endParaRPr lang="en-US" sz="1300" dirty="0"/>
+          </a:p>
+        </p:txBody>
+      </p:sp>
+      <p:sp>
+        <p:nvSpPr>
+          <p:cNvPr id="18" name="Demo step 4"/>
+          <p:cNvSpPr/>
+          <p:nvPr/>
+        </p:nvSpPr>
+        <p:spPr>
+          <a:xfrm>
+            <a:off x="6711696" y="1143000"/>
+            <a:ext cx="1920240" cy="1463040"/>
+          </a:xfrm>
+          <a:prstGeom prst="roundRect">
+            <a:avLst>
+              <a:gd name="adj" fmla="val 5000"/>
+            </a:avLst>
+          </a:prstGeom>
+          <a:solidFill>
+            <a:schemeClr val="bg2"/>
+          </a:solidFill>
+          <a:ln w="12700">
+            <a:solidFill>
+              <a:schemeClr val="bg2"/>
+            </a:solidFill>
+            <a:prstDash val="solid"/>
+          </a:ln>
+          <a:effectLst>
+            <a:outerShdw sx="100000" sy="100000" kx="0" ky="0" algn="bl" rotWithShape="0" blurRad="101600" dist="25400" dir="5400000">
+              <a:srgbClr val="000000">
+                <a:alpha val="12000"/>
+              </a:srgbClr>
+            </a:outerShdw>
+          </a:effectLst>
+        </p:spPr>
+      </p:sp>
+      <p:sp>
+        <p:nvSpPr>
+          <p:cNvPr id="19" name="Demo step 4 number"/>
+          <p:cNvSpPr/>
+          <p:nvPr/>
+        </p:nvSpPr>
+        <p:spPr>
+          <a:xfrm>
+            <a:off x="6821424" y="1252728"/>
+            <a:ext cx="365760" cy="365760"/>
+          </a:xfrm>
+          <a:prstGeom prst="ellipse">
+            <a:avLst/>
+          </a:prstGeom>
+          <a:solidFill>
+            <a:schemeClr val="accent1"/>
+          </a:solidFill>
+          <a:ln w="12700">
+            <a:solidFill>
+              <a:schemeClr val="accent1"/>
+            </a:solidFill>
+            <a:prstDash val="solid"/>
+          </a:ln>
+        </p:spPr>
+      </p:sp>
+      <p:sp>
+        <p:nvSpPr>
+          <p:cNvPr id="20" name="Text 18"/>
+          <p:cNvSpPr txBox="1"/>
+          <p:nvPr/>
+        </p:nvSpPr>
+        <p:spPr>
+          <a:xfrm>
+            <a:off x="6821424" y="1252728"/>
+            <a:ext cx="365760" cy="365760"/>
+          </a:xfrm>
+          <a:prstGeom prst="rect">
+            <a:avLst/>
+          </a:prstGeom>
+          <a:noFill/>
+          <a:ln/>
+        </p:spPr>
+        <p:txBody>
+          <a:bodyPr wrap="square" lIns="0" tIns="0" rIns="0" bIns="0" rtlCol="0" anchor="ctr"/>
+          <a:lstStyle/>
+          <a:p>
+            <a:pPr algn="ctr" indent="0" marL="0">
+              <a:buNone/>
+            </a:pPr>
+            <a:r>
+              <a:rPr lang="en-US" sz="1400" b="1" dirty="0">
+                <a:solidFill>
+                  <a:schemeClr val="bg1"/>
+                </a:solidFill>
+                <a:latin typeface="Calibri" pitchFamily="34" charset="0"/>
+                <a:ea typeface="Calibri" pitchFamily="34" charset="-122"/>
+                <a:cs typeface="Calibri" pitchFamily="34" charset="-120"/>
+              </a:rPr>
+              <a:t>4</a:t>
+            </a:r>
+            <a:endParaRPr lang="en-US" sz="1400" dirty="0"/>
+          </a:p>
+        </p:txBody>
+      </p:sp>
+      <p:sp>
+        <p:nvSpPr>
+          <p:cNvPr id="21" name="Text 19"/>
+          <p:cNvSpPr txBox="1"/>
+          <p:nvPr/>
+        </p:nvSpPr>
+        <p:spPr>
+          <a:xfrm>
+            <a:off x="7260336" y="1252728"/>
+            <a:ext cx="1325880" cy="365760"/>
+          </a:xfrm>
+          <a:prstGeom prst="rect">
+            <a:avLst/>
+          </a:prstGeom>
+          <a:noFill/>
+          <a:ln/>
+        </p:spPr>
+        <p:txBody>
+          <a:bodyPr wrap="square" lIns="0" tIns="0" rIns="0" bIns="0" rtlCol="0" anchor="ctr"/>
+          <a:lstStyle/>
+          <a:p>
+            <a:pPr indent="0" marL="0">
+              <a:buNone/>
+            </a:pPr>
+            <a:r>
+              <a:rPr lang="en-US" sz="1500" b="1" dirty="0">
+                <a:solidFill>
+                  <a:schemeClr val="tx1"/>
+                </a:solidFill>
+                <a:latin typeface="Calibri" pitchFamily="34" charset="0"/>
+                <a:ea typeface="Calibri" pitchFamily="34" charset="-122"/>
+                <a:cs typeface="Calibri" pitchFamily="34" charset="-120"/>
+              </a:rPr>
+              <a:t>Live routing</a:t>
+            </a:r>
+            <a:endParaRPr lang="en-US" sz="1500" dirty="0"/>
+          </a:p>
+        </p:txBody>
+      </p:sp>
+      <p:sp>
+        <p:nvSpPr>
+          <p:cNvPr id="22" name="Text 20"/>
+          <p:cNvSpPr txBox="1"/>
+          <p:nvPr/>
+        </p:nvSpPr>
+        <p:spPr>
+          <a:xfrm>
+            <a:off x="6821424" y="1709928"/>
+            <a:ext cx="1737360" cy="868680"/>
+          </a:xfrm>
+          <a:prstGeom prst="rect">
+            <a:avLst/>
+          </a:prstGeom>
+          <a:noFill/>
+          <a:ln/>
+        </p:spPr>
+        <p:txBody>
+          <a:bodyPr wrap="square" lIns="0" tIns="0" rIns="0" bIns="0" rtlCol="0" anchor="t"/>
+          <a:lstStyle/>
+          <a:p>
+            <a:pPr indent="0" marL="0">
+              <a:buNone/>
+            </a:pPr>
+            <a:r>
+              <a:rPr lang="en-US" sz="1300" dirty="0">
+                <a:solidFill>
+                  <a:schemeClr val="tx2"/>
+                </a:solidFill>
+                <a:latin typeface="Calibri" pitchFamily="34" charset="0"/>
+                <a:ea typeface="Calibri" pitchFamily="34" charset="-122"/>
+                <a:cs typeface="Calibri" pitchFamily="34" charset="-120"/>
+              </a:rPr>
+              <a:t>requests spreading across the replicas as they run</a:t>
+            </a:r>
+            <a:endParaRPr lang="en-US" sz="1300" dirty="0"/>
+          </a:p>
+        </p:txBody>
+      </p:sp>
+      <p:pic>
+        <p:nvPicPr>
+          <p:cNvPr id="23" name="Dashboard screenshot" descr="Dashboard screenshot">    </p:cNvPr>
+          <p:cNvPicPr>
+            <a:picLocks noChangeAspect="1"/>
+          </p:cNvPicPr>
+          <p:nvPr/>
+        </p:nvPicPr>
+        <p:blipFill>
+          <a:blip r:embed="rId1"/>
+          <a:stretch>
+            <a:fillRect/>
+          </a:stretch>
+        </p:blipFill>
+        <p:spPr>
+          <a:xfrm>
+            <a:off x="457200" y="2895438"/>
+            <a:ext cx="8229600" cy="1707204"/>
+          </a:xfrm>
+          <a:prstGeom prst="rect">
+            <a:avLst/>
+          </a:prstGeom>
+          <a:effectLst>
+            <a:outerShdw sx="100000" sy="100000" kx="0" ky="0" algn="bl" rotWithShape="0" blurRad="101600" dist="25400" dir="5400000">
+              <a:srgbClr val="000000">
+                <a:alpha val="12000"/>
+              </a:srgbClr>
+            </a:outerShdw>
+          </a:effectLst>
+        </p:spPr>
+      </p:pic>
       <p:sp>
         <p:nvSpPr>
           <p:cNvPr id="25" name="Slide Number Placeholder 0"/>
@@ -9431,6 +10635,478 @@
 <file path=ppt/slides/slide17.xml><?xml version="1.0" encoding="utf-8"?>
 <p:sld xmlns:a="http://schemas.openxmlformats.org/drawingml/2006/main" xmlns:r="http://schemas.openxmlformats.org/officeDocument/2006/relationships" xmlns:p="http://schemas.openxmlformats.org/presentationml/2006/main">
   <p:cSld name="Slide 17">
+    <p:spTree>
+      <p:nvGrpSpPr>
+        <p:cNvPr id="1" name=""/>
+        <p:cNvGrpSpPr/>
+        <p:nvPr/>
+      </p:nvGrpSpPr>
+      <p:grpSpPr>
+        <a:xfrm>
+          <a:off x="0" y="0"/>
+          <a:ext cx="0" cy="0"/>
+          <a:chOff x="0" y="0"/>
+          <a:chExt cx="0" cy="0"/>
+        </a:xfrm>
+      </p:grpSpPr>
+      <p:sp>
+        <p:nvSpPr>
+          <p:cNvPr id="2" name="Text 0"/>
+          <p:cNvSpPr/>
+          <p:nvPr>
+            <p:ph idx="100" type="title" hasCustomPrompt="1"/>
+          </p:nvPr>
+        </p:nvSpPr>
+        <p:spPr>
+          <a:xfrm>
+            <a:off x="457200" y="274320"/>
+            <a:ext cx="8229600" cy="731520"/>
+          </a:xfrm>
+          <a:prstGeom prst="rect">
+            <a:avLst/>
+          </a:prstGeom>
+          <a:noFill/>
+          <a:ln/>
+        </p:spPr>
+        <p:txBody>
+          <a:bodyPr wrap="square" lIns="0" tIns="0" rIns="0" bIns="0" rtlCol="0" anchor="ctr"/>
+          <a:lstStyle/>
+          <a:p>
+            <a:pPr algn="l" indent="0" marL="0">
+              <a:buNone/>
+            </a:pPr>
+            <a:r>
+              <a:rPr lang="en-US" sz="3200" b="1" dirty="0">
+                <a:solidFill>
+                  <a:schemeClr val="tx1"/>
+                </a:solidFill>
+                <a:latin typeface="Cambria" pitchFamily="34" charset="0"/>
+                <a:ea typeface="Cambria" pitchFamily="34" charset="-122"/>
+                <a:cs typeface="Cambria" pitchFamily="34" charset="-120"/>
+              </a:rPr>
+              <a:t>Limits and next steps</a:t>
+            </a:r>
+            <a:endParaRPr lang="en-US" sz="3200" dirty="0"/>
+          </a:p>
+        </p:txBody>
+      </p:sp>
+      <p:sp>
+        <p:nvSpPr>
+          <p:cNvPr id="3" name="Current limits panel"/>
+          <p:cNvSpPr/>
+          <p:nvPr/>
+        </p:nvSpPr>
+        <p:spPr>
+          <a:xfrm>
+            <a:off x="457200" y="1188720"/>
+            <a:ext cx="4023360" cy="3520440"/>
+          </a:xfrm>
+          <a:prstGeom prst="roundRect">
+            <a:avLst>
+              <a:gd name="adj" fmla="val 2078"/>
+            </a:avLst>
+          </a:prstGeom>
+          <a:solidFill>
+            <a:schemeClr val="bg2"/>
+          </a:solidFill>
+          <a:ln w="12700">
+            <a:solidFill>
+              <a:schemeClr val="bg2"/>
+            </a:solidFill>
+            <a:prstDash val="solid"/>
+          </a:ln>
+          <a:effectLst>
+            <a:outerShdw sx="100000" sy="100000" kx="0" ky="0" algn="bl" rotWithShape="0" blurRad="101600" dist="25400" dir="5400000">
+              <a:srgbClr val="000000">
+                <a:alpha val="12000"/>
+              </a:srgbClr>
+            </a:outerShdw>
+          </a:effectLst>
+        </p:spPr>
+      </p:sp>
+      <p:sp>
+        <p:nvSpPr>
+          <p:cNvPr id="4" name="Text 2"/>
+          <p:cNvSpPr txBox="1"/>
+          <p:nvPr/>
+        </p:nvSpPr>
+        <p:spPr>
+          <a:xfrm>
+            <a:off x="685800" y="1325880"/>
+            <a:ext cx="3566160" cy="365760"/>
+          </a:xfrm>
+          <a:prstGeom prst="rect">
+            <a:avLst/>
+          </a:prstGeom>
+          <a:noFill/>
+          <a:ln/>
+        </p:spPr>
+        <p:txBody>
+          <a:bodyPr wrap="square" lIns="0" tIns="0" rIns="0" bIns="0" rtlCol="0" anchor="t"/>
+          <a:lstStyle/>
+          <a:p>
+            <a:pPr indent="0" marL="0">
+              <a:buNone/>
+            </a:pPr>
+            <a:r>
+              <a:rPr lang="en-US" sz="2000" b="1" dirty="0">
+                <a:solidFill>
+                  <a:schemeClr val="accent5"/>
+                </a:solidFill>
+                <a:latin typeface="Cambria" pitchFamily="34" charset="0"/>
+                <a:ea typeface="Cambria" pitchFamily="34" charset="-122"/>
+                <a:cs typeface="Cambria" pitchFamily="34" charset="-120"/>
+              </a:rPr>
+              <a:t>Current limits</a:t>
+            </a:r>
+            <a:endParaRPr lang="en-US" sz="2000" dirty="0"/>
+          </a:p>
+        </p:txBody>
+      </p:sp>
+      <p:sp>
+        <p:nvSpPr>
+          <p:cNvPr id="5" name="Text 3"/>
+          <p:cNvSpPr txBox="1"/>
+          <p:nvPr/>
+        </p:nvSpPr>
+        <p:spPr>
+          <a:xfrm>
+            <a:off x="685800" y="1828800"/>
+            <a:ext cx="3566160" cy="2743200"/>
+          </a:xfrm>
+          <a:prstGeom prst="rect">
+            <a:avLst/>
+          </a:prstGeom>
+          <a:noFill/>
+          <a:ln/>
+        </p:spPr>
+        <p:txBody>
+          <a:bodyPr wrap="square" lIns="0" tIns="0" rIns="0" bIns="0" rtlCol="0" anchor="t"/>
+          <a:lstStyle/>
+          <a:p>
+            <a:pPr marL="342900" indent="-342900">
+              <a:spcAft>
+                <a:spcPts val="800"/>
+              </a:spcAft>
+              <a:buSzPct val="100000"/>
+              <a:buChar char="•"/>
+            </a:pPr>
+            <a:r>
+              <a:rPr lang="en-US" sz="1400" dirty="0">
+                <a:solidFill>
+                  <a:schemeClr val="tx1"/>
+                </a:solidFill>
+                <a:latin typeface="Calibri" pitchFamily="34" charset="0"/>
+                <a:ea typeface="Calibri" pitchFamily="34" charset="-122"/>
+                <a:cs typeface="Calibri" pitchFamily="34" charset="-120"/>
+              </a:rPr>
+              <a:t>The router's index is a belief. A failed request can leave a stale entry, and the index does not see engine evictions.</a:t>
+            </a:r>
+            <a:endParaRPr lang="en-US" sz="1400" dirty="0"/>
+          </a:p>
+          <a:p>
+            <a:pPr marL="342900" indent="-342900">
+              <a:spcAft>
+                <a:spcPts val="800"/>
+              </a:spcAft>
+              <a:buSzPct val="100000"/>
+              <a:buChar char="•"/>
+            </a:pPr>
+            <a:r>
+              <a:rPr lang="en-US" sz="1400" dirty="0">
+                <a:solidFill>
+                  <a:schemeClr val="tx1"/>
+                </a:solidFill>
+                <a:latin typeface="Calibri" pitchFamily="34" charset="0"/>
+                <a:ea typeface="Calibri" pitchFamily="34" charset="-122"/>
+                <a:cs typeface="Calibri" pitchFamily="34" charset="-120"/>
+              </a:rPr>
+              <a:t>Connection errors retry the same replica; there is no failover to another one.</a:t>
+            </a:r>
+            <a:endParaRPr lang="en-US" sz="1400" dirty="0"/>
+          </a:p>
+          <a:p>
+            <a:pPr marL="342900" indent="-342900">
+              <a:spcAft>
+                <a:spcPts val="800"/>
+              </a:spcAft>
+              <a:buSzPct val="100000"/>
+              <a:buChar char="•"/>
+            </a:pPr>
+            <a:r>
+              <a:rPr lang="en-US" sz="1400" dirty="0">
+                <a:solidFill>
+                  <a:schemeClr val="tx1"/>
+                </a:solidFill>
+                <a:latin typeface="Calibri" pitchFamily="34" charset="0"/>
+                <a:ea typeface="Calibri" pitchFamily="34" charset="-122"/>
+                <a:cs typeface="Calibri" pitchFamily="34" charset="-120"/>
+              </a:rPr>
+              <a:t>Latency through tunnels includes network delay.</a:t>
+            </a:r>
+            <a:endParaRPr lang="en-US" sz="1400" dirty="0"/>
+          </a:p>
+          <a:p>
+            <a:pPr marL="342900" indent="-342900">
+              <a:spcAft>
+                <a:spcPts val="800"/>
+              </a:spcAft>
+              <a:buSzPct val="100000"/>
+              <a:buChar char="•"/>
+            </a:pPr>
+            <a:r>
+              <a:rPr lang="en-US" sz="1400" dirty="0">
+                <a:solidFill>
+                  <a:schemeClr val="tx1"/>
+                </a:solidFill>
+                <a:latin typeface="Calibri" pitchFamily="34" charset="0"/>
+                <a:ea typeface="Calibri" pitchFamily="34" charset="-122"/>
+                <a:cs typeface="Calibri" pitchFamily="34" charset="-120"/>
+              </a:rPr>
+              <a:t>Policies are compared one after another on one model, so results are a controlled demonstration.</a:t>
+            </a:r>
+            <a:endParaRPr lang="en-US" sz="1400" dirty="0"/>
+          </a:p>
+        </p:txBody>
+      </p:sp>
+      <p:sp>
+        <p:nvSpPr>
+          <p:cNvPr id="6" name="Next steps panel"/>
+          <p:cNvSpPr/>
+          <p:nvPr/>
+        </p:nvSpPr>
+        <p:spPr>
+          <a:xfrm>
+            <a:off x="4663440" y="1188720"/>
+            <a:ext cx="4023360" cy="3520440"/>
+          </a:xfrm>
+          <a:prstGeom prst="roundRect">
+            <a:avLst>
+              <a:gd name="adj" fmla="val 2078"/>
+            </a:avLst>
+          </a:prstGeom>
+          <a:solidFill>
+            <a:schemeClr val="bg2"/>
+          </a:solidFill>
+          <a:ln w="12700">
+            <a:solidFill>
+              <a:schemeClr val="bg2"/>
+            </a:solidFill>
+            <a:prstDash val="solid"/>
+          </a:ln>
+          <a:effectLst>
+            <a:outerShdw sx="100000" sy="100000" kx="0" ky="0" algn="bl" rotWithShape="0" blurRad="101600" dist="25400" dir="5400000">
+              <a:srgbClr val="000000">
+                <a:alpha val="12000"/>
+              </a:srgbClr>
+            </a:outerShdw>
+          </a:effectLst>
+        </p:spPr>
+      </p:sp>
+      <p:sp>
+        <p:nvSpPr>
+          <p:cNvPr id="7" name="Text 5"/>
+          <p:cNvSpPr txBox="1"/>
+          <p:nvPr/>
+        </p:nvSpPr>
+        <p:spPr>
+          <a:xfrm>
+            <a:off x="4892040" y="1325880"/>
+            <a:ext cx="3566160" cy="365760"/>
+          </a:xfrm>
+          <a:prstGeom prst="rect">
+            <a:avLst/>
+          </a:prstGeom>
+          <a:noFill/>
+          <a:ln/>
+        </p:spPr>
+        <p:txBody>
+          <a:bodyPr wrap="square" lIns="0" tIns="0" rIns="0" bIns="0" rtlCol="0" anchor="t"/>
+          <a:lstStyle/>
+          <a:p>
+            <a:pPr indent="0" marL="0">
+              <a:buNone/>
+            </a:pPr>
+            <a:r>
+              <a:rPr lang="en-US" sz="2000" b="1" dirty="0">
+                <a:solidFill>
+                  <a:schemeClr val="accent1"/>
+                </a:solidFill>
+                <a:latin typeface="Cambria" pitchFamily="34" charset="0"/>
+                <a:ea typeface="Cambria" pitchFamily="34" charset="-122"/>
+                <a:cs typeface="Cambria" pitchFamily="34" charset="-120"/>
+              </a:rPr>
+              <a:t>Next steps</a:t>
+            </a:r>
+            <a:endParaRPr lang="en-US" sz="2000" dirty="0"/>
+          </a:p>
+        </p:txBody>
+      </p:sp>
+      <p:sp>
+        <p:nvSpPr>
+          <p:cNvPr id="8" name="Text 6"/>
+          <p:cNvSpPr txBox="1"/>
+          <p:nvPr/>
+        </p:nvSpPr>
+        <p:spPr>
+          <a:xfrm>
+            <a:off x="4892040" y="1828800"/>
+            <a:ext cx="3566160" cy="2743200"/>
+          </a:xfrm>
+          <a:prstGeom prst="rect">
+            <a:avLst/>
+          </a:prstGeom>
+          <a:noFill/>
+          <a:ln/>
+        </p:spPr>
+        <p:txBody>
+          <a:bodyPr wrap="square" lIns="0" tIns="0" rIns="0" bIns="0" rtlCol="0" anchor="t"/>
+          <a:lstStyle/>
+          <a:p>
+            <a:pPr marL="342900" indent="-342900">
+              <a:spcAft>
+                <a:spcPts val="800"/>
+              </a:spcAft>
+              <a:buSzPct val="100000"/>
+              <a:buChar char="•"/>
+            </a:pPr>
+            <a:r>
+              <a:rPr lang="en-US" sz="1400" dirty="0">
+                <a:solidFill>
+                  <a:schemeClr val="tx1"/>
+                </a:solidFill>
+                <a:latin typeface="Calibri" pitchFamily="34" charset="0"/>
+                <a:ea typeface="Calibri" pitchFamily="34" charset="-122"/>
+                <a:cs typeface="Calibri" pitchFamily="34" charset="-120"/>
+              </a:rPr>
+              <a:t>Repeat the comparison with several seeds and report the spread.</a:t>
+            </a:r>
+            <a:endParaRPr lang="en-US" sz="1400" dirty="0"/>
+          </a:p>
+          <a:p>
+            <a:pPr marL="342900" indent="-342900">
+              <a:spcAft>
+                <a:spcPts val="800"/>
+              </a:spcAft>
+              <a:buSzPct val="100000"/>
+              <a:buChar char="•"/>
+            </a:pPr>
+            <a:r>
+              <a:rPr lang="en-US" sz="1400" dirty="0">
+                <a:solidFill>
+                  <a:schemeClr val="tx1"/>
+                </a:solidFill>
+                <a:latin typeface="Calibri" pitchFamily="34" charset="0"/>
+                <a:ea typeface="Calibri" pitchFamily="34" charset="-122"/>
+                <a:cs typeface="Calibri" pitchFamily="34" charset="-120"/>
+              </a:rPr>
+              <a:t>Rebuild the index from the engine's cache events instead of predictions.</a:t>
+            </a:r>
+            <a:endParaRPr lang="en-US" sz="1400" dirty="0"/>
+          </a:p>
+          <a:p>
+            <a:pPr marL="342900" indent="-342900">
+              <a:spcAft>
+                <a:spcPts val="800"/>
+              </a:spcAft>
+              <a:buSzPct val="100000"/>
+              <a:buChar char="•"/>
+            </a:pPr>
+            <a:r>
+              <a:rPr lang="en-US" sz="1400" dirty="0">
+                <a:solidFill>
+                  <a:schemeClr val="tx1"/>
+                </a:solidFill>
+                <a:latin typeface="Calibri" pitchFamily="34" charset="0"/>
+                <a:ea typeface="Calibri" pitchFamily="34" charset="-122"/>
+                <a:cs typeface="Calibri" pitchFamily="34" charset="-120"/>
+              </a:rPr>
+              <a:t>Fail over to another replica on connection errors.</a:t>
+            </a:r>
+            <a:endParaRPr lang="en-US" sz="1400" dirty="0"/>
+          </a:p>
+          <a:p>
+            <a:pPr marL="342900" indent="-342900">
+              <a:spcAft>
+                <a:spcPts val="800"/>
+              </a:spcAft>
+              <a:buSzPct val="100000"/>
+              <a:buChar char="•"/>
+            </a:pPr>
+            <a:r>
+              <a:rPr lang="en-US" sz="1400" dirty="0">
+                <a:solidFill>
+                  <a:schemeClr val="tx1"/>
+                </a:solidFill>
+                <a:latin typeface="Calibri" pitchFamily="34" charset="0"/>
+                <a:ea typeface="Calibri" pitchFamily="34" charset="-122"/>
+                <a:cs typeface="Calibri" pitchFamily="34" charset="-120"/>
+              </a:rPr>
+              <a:t>Keep the index across router restarts.</a:t>
+            </a:r>
+            <a:endParaRPr lang="en-US" sz="1400" dirty="0"/>
+          </a:p>
+        </p:txBody>
+      </p:sp>
+      <p:sp>
+        <p:nvSpPr>
+          <p:cNvPr id="25" name="Slide Number Placeholder 0"/>
+          <p:cNvSpPr>
+            <a:spLocks noGrp="1"/>
+          </p:cNvSpPr>
+          <p:nvPr>
+            <p:ph type="sldNum" sz="quarter" idx="4294967295"/>
+          </p:nvPr>
+        </p:nvSpPr>
+        <p:spPr>
+          <a:xfrm>
+            <a:off x="8321040" y="4754880"/>
+            <a:ext cx="457200" cy="274320"/>
+          </a:xfrm>
+          <a:prstGeom prst="rect">
+            <a:avLst/>
+          </a:prstGeom>
+          <a:extLst>
+            <a:ext uri="{C572A759-6A51-4108-AA02-DFA0A04FC94B}">
+              <ma14:wrappingTextBoxFlag xmlns:ma14="http://schemas.microsoft.com/office/mac/drawingml/2011/main" val="0"/>
+            </a:ext>
+          </a:extLst>
+        </p:spPr>
+        <p:txBody>
+          <a:bodyPr/>
+          <a:lstStyle>
+            <a:lvl1pPr>
+              <a:defRPr sz="1000">
+                <a:solidFill>
+                  <a:schemeClr val="accent4"/>
+                </a:solidFill>
+                <a:latin typeface="Calibri"/>
+                <a:ea typeface="Calibri"/>
+                <a:cs typeface="Calibri"/>
+              </a:defRPr>
+            </a:lvl1pPr>
+          </a:lstStyle>
+          <a:p>
+            <a:pPr algn="l"/>
+            <a:fld id="{F7021451-1387-4CA6-816F-3879F97B5CBC}" type="slidenum">
+              <a:rPr b="0" lang="en-US"/>
+              <a:t>17</a:t>
+            </a:fld>
+            <a:endParaRPr lang="en-US"/>
+          </a:p>
+        </p:txBody>
+      </p:sp>
+    </p:spTree>
+  </p:cSld>
+  <p:clrMapOvr>
+    <a:masterClrMapping/>
+  </p:clrMapOvr>
+</p:sld>
+</file>
+
+<file path=ppt/slides/slide18.xml><?xml version="1.0" encoding="utf-8"?>
+<p:sld xmlns:a="http://schemas.openxmlformats.org/drawingml/2006/main" xmlns:r="http://schemas.openxmlformats.org/officeDocument/2006/relationships" xmlns:p="http://schemas.openxmlformats.org/presentationml/2006/main">
+  <p:cSld name="Slide 18">
     <p:spTree>
       <p:nvGrpSpPr>
         <p:cNvPr id="1" name=""/>

</xml_diff>

<commit_message>
Record three real comparison runs; deck aggregates every run in docs/presentation/runs
Co-Authored-By: Claude Sonnet 5.5 <noreply@anthropic.com>
Claude-Session: https://claude.ai/code/session_01MpvnYWzvWhixwcFeFULcu6
</commit_message>
<xml_diff>
--- a/docs/presentation/SwiftServe_Presentation.pptx
+++ b/docs/presentation/SwiftServe_Presentation.pptx
@@ -124,14 +124,14 @@
   <p:extLst>
     <p:ext uri="{521415D9-36F7-43E2-AB2F-B90AF26B5E84}">
       <p14:sectionLst xmlns:p14="http://schemas.microsoft.com/office/powerpoint/2010/main">
-        <p14:section name="Context" id="{f15dc4b4-2cd2-5a49-9c3f-dbbbcef8eb52}">
+        <p14:section name="Context" id="{2e75a553-9e6d-64df-be6d-b08287080b46}">
           <p14:sldIdLst>
             <p14:sldId id="256"/>
             <p14:sldId id="257"/>
             <p14:sldId id="258"/>
           </p14:sldIdLst>
         </p14:section>
-        <p14:section name="Approach" id="{d9ac31fb-8c7d-b11a-7984-4f979a278d38}">
+        <p14:section name="Approach" id="{ae03ae80-a8a9-ee25-3ae9-1e2d9c583f19}">
           <p14:sldIdLst>
             <p14:sldId id="259"/>
             <p14:sldId id="260"/>
@@ -142,7 +142,7 @@
             <p14:sldId id="265"/>
           </p14:sldIdLst>
         </p14:section>
-        <p14:section name="Evidence" id="{2501a7d5-2567-18fe-d5a6-95622064186f}">
+        <p14:section name="Evidence" id="{940d9901-b148-9f10-c4c8-dcae4898ecbc}">
           <p14:sldIdLst>
             <p14:sldId id="266"/>
             <p14:sldId id="267"/>
@@ -152,7 +152,7 @@
             <p14:sldId id="271"/>
           </p14:sldIdLst>
         </p14:section>
-        <p14:section name="Close" id="{3ccbea69-4e26-bbca-5c1d-78b5924e6cf9}">
+        <p14:section name="Close" id="{5135f991-e1db-ca79-bb04-87b68f068dbb}">
           <p14:sldIdLst>
             <p14:sldId id="272"/>
             <p14:sldId id="273"/>
@@ -529,16 +529,16 @@
                 <c:formatCode>General</c:formatCode>
                 <c:ptCount val="4"/>
                 <c:pt idx="0">
-                  <c:v>1033</c:v>
+                  <c:v>966</c:v>
                 </c:pt>
                 <c:pt idx="1">
-                  <c:v>1063</c:v>
+                  <c:v>993</c:v>
                 </c:pt>
                 <c:pt idx="2">
-                  <c:v>537</c:v>
+                  <c:v>765</c:v>
                 </c:pt>
                 <c:pt idx="3">
-                  <c:v>464</c:v>
+                  <c:v>451</c:v>
                 </c:pt>
               </c:numCache>
             </c:numRef>
@@ -618,16 +618,16 @@
                 <c:formatCode>General</c:formatCode>
                 <c:ptCount val="4"/>
                 <c:pt idx="0">
-                  <c:v>1887</c:v>
+                  <c:v>1844</c:v>
                 </c:pt>
                 <c:pt idx="1">
-                  <c:v>1921</c:v>
+                  <c:v>1932</c:v>
                 </c:pt>
                 <c:pt idx="2">
-                  <c:v>1690</c:v>
+                  <c:v>1719</c:v>
                 </c:pt>
                 <c:pt idx="3">
-                  <c:v>2671</c:v>
+                  <c:v>2006</c:v>
                 </c:pt>
               </c:numCache>
             </c:numRef>
@@ -1722,7 +1722,7 @@
           <a:p>
             <a:r>
               <a:rPr lang="en-US" dirty="0"/>
-              <a:t>All policies ran the same workload on the same replicas, one after another, each in its own prompt namespace so that none benefited from a cache warmed by an earlier run. Read time to first token first, because that is where prefill savings show up. Cache reuse is the share of prompt tokens the engines reported as cached. Goodput is the share of requests that met both the time-to-first-token and per-token targets. Max-to-mean load shows how evenly requests spread: 1.0 is perfectly even, higher means one replica took more than its share. Compare the median and the 95th percentile separately: a policy can have the best median and a worse tail, because concentrating requests on the replicas that hold a cache can also concentrate queueing. The policies ran one after another in a single run, so this is a controlled demonstration; repeating it with another seed and the order reversed checks that the ranking holds.</a:t>
+              <a:t>All policies ran the same seeded workload on the same four GPUs, one after another, each in its own prompt namespace so none benefited from a cache warmed by an earlier policy, and the router's learned latency state was reset between policies. The experiment was repeated with different seeds, and one run used the reverse policy order, so a policy that is simply lucky in its position would not win every time. Read the median first: that is where prefill savings show up, and the prefix-aware policy had the lowest median in every run. Cache reuse is the share of prompt tokens the engines reported as cached, and it ranked the policies the same way in every run. The tail is different: the 95th percentile rank of the prefix-aware policy varied between runs, so no firm claim about the tail is supported. It also had the most uneven load, since it sends a tenant back to the replica holding its cache. The swiftserve policy beat both load-based baselines on median in two runs and lost to both in the third, so its advantage over them is not established. Run 1 values were read from the console screenshot and are rounded; runs 2 and 3 are the exported files.</a:t>
             </a:r>
             <a:endParaRPr lang="en-US" dirty="0"/>
           </a:p>
@@ -8605,7 +8605,7 @@
                 <a:ea typeface="Cambria" pitchFamily="34" charset="-122"/>
                 <a:cs typeface="Cambria" pitchFamily="34" charset="-120"/>
               </a:rPr>
-              <a:t>Measured policy comparison</a:t>
+              <a:t>Measured policy comparison, 3 runs</a:t>
             </a:r>
             <a:endParaRPr lang="en-US" sz="3200" dirty="0"/>
           </a:p>
@@ -8619,7 +8619,7 @@
         </p:nvGraphicFramePr>
         <p:xfrm>
           <a:off x="457200" y="1097280"/>
-          <a:ext cx="4572000" cy="2926080"/>
+          <a:ext cx="4297680" cy="2926080"/>
         </p:xfrm>
         <a:graphic xmlns:a="http://schemas.openxmlformats.org/drawingml/2006/main">
           <a:graphicData uri="http://schemas.openxmlformats.org/drawingml/2006/chart">
@@ -8642,17 +8642,18 @@
           </p:nvPr>
         </p:nvGraphicFramePr>
         <p:xfrm>
-          <a:off x="5212080" y="1188720"/>
-          <a:ext cx="3474720" cy="914400"/>
+          <a:off x="4937760" y="1188720"/>
+          <a:ext cx="3749040" cy="914400"/>
         </p:xfrm>
         <a:graphic>
           <a:graphicData uri="http://schemas.openxmlformats.org/drawingml/2006/table">
             <a:tbl>
               <a:tblPr/>
               <a:tblGrid>
-                <a:gridCol w="1645920"/>
-                <a:gridCol w="914400"/>
-                <a:gridCol w="914400"/>
+                <a:gridCol w="1325880"/>
+                <a:gridCol w="1097280"/>
+                <a:gridCol w="640080"/>
+                <a:gridCol w="685800"/>
               </a:tblGrid>
               <a:tr h="0">
                 <a:tc>
@@ -8673,6 +8674,74 @@
                           <a:cs typeface="Calibri" pitchFamily="34" charset="-120"/>
                         </a:rPr>
                         <a:t>Policy</a:t>
+                      </a:r>
+                      <a:endParaRPr lang="en-US" sz="1200" dirty="0">
+                        <a:latin typeface="Calibri" charset="0"/>
+                        <a:ea typeface="Calibri" charset="0"/>
+                        <a:cs typeface="Calibri" charset="0"/>
+                      </a:endParaRPr>
+                    </a:p>
+                  </a:txBody>
+                  <a:tcPr marL="54864" marR="54864" marT="45720" marB="45720">
+                    <a:lnL w="6350" cap="flat" cmpd="sng" algn="ctr">
+                      <a:solidFill>
+                        <a:schemeClr val="accent4"/>
+                      </a:solidFill>
+                      <a:prstDash val="solid"/>
+                      <a:round/>
+                      <a:headEnd type="none" w="med" len="med"/>
+                      <a:tailEnd type="none" w="med" len="med"/>
+                    </a:lnL>
+                    <a:lnR w="6350" cap="flat" cmpd="sng" algn="ctr">
+                      <a:solidFill>
+                        <a:schemeClr val="accent4"/>
+                      </a:solidFill>
+                      <a:prstDash val="solid"/>
+                      <a:round/>
+                      <a:headEnd type="none" w="med" len="med"/>
+                      <a:tailEnd type="none" w="med" len="med"/>
+                    </a:lnR>
+                    <a:lnT w="6350" cap="flat" cmpd="sng" algn="ctr">
+                      <a:solidFill>
+                        <a:schemeClr val="accent4"/>
+                      </a:solidFill>
+                      <a:prstDash val="solid"/>
+                      <a:round/>
+                      <a:headEnd type="none" w="med" len="med"/>
+                      <a:tailEnd type="none" w="med" len="med"/>
+                    </a:lnT>
+                    <a:lnB w="6350" cap="flat" cmpd="sng" algn="ctr">
+                      <a:solidFill>
+                        <a:schemeClr val="accent4"/>
+                      </a:solidFill>
+                      <a:prstDash val="solid"/>
+                      <a:round/>
+                      <a:headEnd type="none" w="med" len="med"/>
+                      <a:tailEnd type="none" w="med" len="med"/>
+                    </a:lnB>
+                    <a:solidFill>
+                      <a:schemeClr val="tx1"/>
+                    </a:solidFill>
+                  </a:tcPr>
+                </a:tc>
+                <a:tc>
+                  <a:txBody>
+                    <a:bodyPr/>
+                    <a:lstStyle/>
+                    <a:p>
+                      <a:pPr indent="0" marL="0">
+                        <a:buNone/>
+                      </a:pPr>
+                      <a:r>
+                        <a:rPr lang="en-US" sz="1200" b="1" dirty="0">
+                          <a:solidFill>
+                            <a:schemeClr val="bg1"/>
+                          </a:solidFill>
+                          <a:latin typeface="Calibri" pitchFamily="34" charset="0"/>
+                          <a:ea typeface="Calibri" pitchFamily="34" charset="-122"/>
+                          <a:cs typeface="Calibri" pitchFamily="34" charset="-120"/>
+                        </a:rPr>
+                        <a:t>Median TTFT, ms: mean (range)</a:t>
                       </a:r>
                       <a:endParaRPr lang="en-US" sz="1200" dirty="0">
                         <a:latin typeface="Calibri" charset="0"/>
@@ -8808,7 +8877,7 @@
                           <a:ea typeface="Calibri" pitchFamily="34" charset="-122"/>
                           <a:cs typeface="Calibri" pitchFamily="34" charset="-120"/>
                         </a:rPr>
-                        <a:t>Max : mean load</a:t>
+                        <a:t>Busiest ÷ mean load</a:t>
                       </a:r>
                       <a:endParaRPr lang="en-US" sz="1200" dirty="0">
                         <a:latin typeface="Calibri" charset="0"/>
@@ -8946,7 +9015,75 @@
                           <a:ea typeface="Calibri" pitchFamily="34" charset="-122"/>
                           <a:cs typeface="Calibri" pitchFamily="34" charset="-120"/>
                         </a:rPr>
-                        <a:t>55 %</a:t>
+                        <a:t>966 (798-1066)</a:t>
+                      </a:r>
+                      <a:endParaRPr lang="en-US" sz="1200" dirty="0">
+                        <a:latin typeface="Calibri" charset="0"/>
+                        <a:ea typeface="Calibri" charset="0"/>
+                        <a:cs typeface="Calibri" charset="0"/>
+                      </a:endParaRPr>
+                    </a:p>
+                  </a:txBody>
+                  <a:tcPr marL="54864" marR="54864" marT="45720" marB="45720">
+                    <a:lnL w="6350" cap="flat" cmpd="sng" algn="ctr">
+                      <a:solidFill>
+                        <a:schemeClr val="accent4"/>
+                      </a:solidFill>
+                      <a:prstDash val="solid"/>
+                      <a:round/>
+                      <a:headEnd type="none" w="med" len="med"/>
+                      <a:tailEnd type="none" w="med" len="med"/>
+                    </a:lnL>
+                    <a:lnR w="6350" cap="flat" cmpd="sng" algn="ctr">
+                      <a:solidFill>
+                        <a:schemeClr val="accent4"/>
+                      </a:solidFill>
+                      <a:prstDash val="solid"/>
+                      <a:round/>
+                      <a:headEnd type="none" w="med" len="med"/>
+                      <a:tailEnd type="none" w="med" len="med"/>
+                    </a:lnR>
+                    <a:lnT w="6350" cap="flat" cmpd="sng" algn="ctr">
+                      <a:solidFill>
+                        <a:schemeClr val="accent4"/>
+                      </a:solidFill>
+                      <a:prstDash val="solid"/>
+                      <a:round/>
+                      <a:headEnd type="none" w="med" len="med"/>
+                      <a:tailEnd type="none" w="med" len="med"/>
+                    </a:lnT>
+                    <a:lnB w="6350" cap="flat" cmpd="sng" algn="ctr">
+                      <a:solidFill>
+                        <a:schemeClr val="accent4"/>
+                      </a:solidFill>
+                      <a:prstDash val="solid"/>
+                      <a:round/>
+                      <a:headEnd type="none" w="med" len="med"/>
+                      <a:tailEnd type="none" w="med" len="med"/>
+                    </a:lnB>
+                    <a:solidFill>
+                      <a:schemeClr val="bg2"/>
+                    </a:solidFill>
+                  </a:tcPr>
+                </a:tc>
+                <a:tc>
+                  <a:txBody>
+                    <a:bodyPr/>
+                    <a:lstStyle/>
+                    <a:p>
+                      <a:pPr indent="0" marL="0">
+                        <a:buNone/>
+                      </a:pPr>
+                      <a:r>
+                        <a:rPr lang="en-US" sz="1200" dirty="0">
+                          <a:solidFill>
+                            <a:schemeClr val="tx1"/>
+                          </a:solidFill>
+                          <a:latin typeface="Calibri" pitchFamily="34" charset="0"/>
+                          <a:ea typeface="Calibri" pitchFamily="34" charset="-122"/>
+                          <a:cs typeface="Calibri" pitchFamily="34" charset="-120"/>
+                        </a:rPr>
+                        <a:t>53 %</a:t>
                       </a:r>
                       <a:endParaRPr lang="en-US" sz="1200" dirty="0">
                         <a:latin typeface="Calibri" charset="0"/>
@@ -9152,7 +9289,7 @@
                           <a:ea typeface="Calibri" pitchFamily="34" charset="-122"/>
                           <a:cs typeface="Calibri" pitchFamily="34" charset="-120"/>
                         </a:rPr>
-                        <a:t>48 %</a:t>
+                        <a:t>993 (868-1063)</a:t>
                       </a:r>
                       <a:endParaRPr lang="en-US" sz="1200" dirty="0">
                         <a:latin typeface="Calibri" charset="0"/>
@@ -9220,7 +9357,75 @@
                           <a:ea typeface="Calibri" pitchFamily="34" charset="-122"/>
                           <a:cs typeface="Calibri" pitchFamily="34" charset="-120"/>
                         </a:rPr>
-                        <a:t>1.53</a:t>
+                        <a:t>52 %</a:t>
+                      </a:r>
+                      <a:endParaRPr lang="en-US" sz="1200" dirty="0">
+                        <a:latin typeface="Calibri" charset="0"/>
+                        <a:ea typeface="Calibri" charset="0"/>
+                        <a:cs typeface="Calibri" charset="0"/>
+                      </a:endParaRPr>
+                    </a:p>
+                  </a:txBody>
+                  <a:tcPr marL="54864" marR="54864" marT="45720" marB="45720">
+                    <a:lnL w="6350" cap="flat" cmpd="sng" algn="ctr">
+                      <a:solidFill>
+                        <a:schemeClr val="accent4"/>
+                      </a:solidFill>
+                      <a:prstDash val="solid"/>
+                      <a:round/>
+                      <a:headEnd type="none" w="med" len="med"/>
+                      <a:tailEnd type="none" w="med" len="med"/>
+                    </a:lnL>
+                    <a:lnR w="6350" cap="flat" cmpd="sng" algn="ctr">
+                      <a:solidFill>
+                        <a:schemeClr val="accent4"/>
+                      </a:solidFill>
+                      <a:prstDash val="solid"/>
+                      <a:round/>
+                      <a:headEnd type="none" w="med" len="med"/>
+                      <a:tailEnd type="none" w="med" len="med"/>
+                    </a:lnR>
+                    <a:lnT w="6350" cap="flat" cmpd="sng" algn="ctr">
+                      <a:solidFill>
+                        <a:schemeClr val="accent4"/>
+                      </a:solidFill>
+                      <a:prstDash val="solid"/>
+                      <a:round/>
+                      <a:headEnd type="none" w="med" len="med"/>
+                      <a:tailEnd type="none" w="med" len="med"/>
+                    </a:lnT>
+                    <a:lnB w="6350" cap="flat" cmpd="sng" algn="ctr">
+                      <a:solidFill>
+                        <a:schemeClr val="accent4"/>
+                      </a:solidFill>
+                      <a:prstDash val="solid"/>
+                      <a:round/>
+                      <a:headEnd type="none" w="med" len="med"/>
+                      <a:tailEnd type="none" w="med" len="med"/>
+                    </a:lnB>
+                    <a:solidFill>
+                      <a:schemeClr val="bg1"/>
+                    </a:solidFill>
+                  </a:tcPr>
+                </a:tc>
+                <a:tc>
+                  <a:txBody>
+                    <a:bodyPr/>
+                    <a:lstStyle/>
+                    <a:p>
+                      <a:pPr indent="0" marL="0">
+                        <a:buNone/>
+                      </a:pPr>
+                      <a:r>
+                        <a:rPr lang="en-US" sz="1200" dirty="0">
+                          <a:solidFill>
+                            <a:schemeClr val="tx1"/>
+                          </a:solidFill>
+                          <a:latin typeface="Calibri" pitchFamily="34" charset="0"/>
+                          <a:ea typeface="Calibri" pitchFamily="34" charset="-122"/>
+                          <a:cs typeface="Calibri" pitchFamily="34" charset="-120"/>
+                        </a:rPr>
+                        <a:t>1.35</a:t>
                       </a:r>
                       <a:endParaRPr lang="en-US" sz="1200" dirty="0">
                         <a:latin typeface="Calibri" charset="0"/>
@@ -9358,7 +9563,7 @@
                           <a:ea typeface="Calibri" pitchFamily="34" charset="-122"/>
                           <a:cs typeface="Calibri" pitchFamily="34" charset="-120"/>
                         </a:rPr>
-                        <a:t>69 %</a:t>
+                        <a:t>765 (537-927)</a:t>
                       </a:r>
                       <a:endParaRPr lang="en-US" sz="1200" dirty="0">
                         <a:latin typeface="Calibri" charset="0"/>
@@ -9426,7 +9631,75 @@
                           <a:ea typeface="Calibri" pitchFamily="34" charset="-122"/>
                           <a:cs typeface="Calibri" pitchFamily="34" charset="-120"/>
                         </a:rPr>
-                        <a:t>1.33</a:t>
+                        <a:t>66 %</a:t>
+                      </a:r>
+                      <a:endParaRPr lang="en-US" sz="1200" dirty="0">
+                        <a:latin typeface="Calibri" charset="0"/>
+                        <a:ea typeface="Calibri" charset="0"/>
+                        <a:cs typeface="Calibri" charset="0"/>
+                      </a:endParaRPr>
+                    </a:p>
+                  </a:txBody>
+                  <a:tcPr marL="54864" marR="54864" marT="45720" marB="45720">
+                    <a:lnL w="6350" cap="flat" cmpd="sng" algn="ctr">
+                      <a:solidFill>
+                        <a:schemeClr val="accent4"/>
+                      </a:solidFill>
+                      <a:prstDash val="solid"/>
+                      <a:round/>
+                      <a:headEnd type="none" w="med" len="med"/>
+                      <a:tailEnd type="none" w="med" len="med"/>
+                    </a:lnL>
+                    <a:lnR w="6350" cap="flat" cmpd="sng" algn="ctr">
+                      <a:solidFill>
+                        <a:schemeClr val="accent4"/>
+                      </a:solidFill>
+                      <a:prstDash val="solid"/>
+                      <a:round/>
+                      <a:headEnd type="none" w="med" len="med"/>
+                      <a:tailEnd type="none" w="med" len="med"/>
+                    </a:lnR>
+                    <a:lnT w="6350" cap="flat" cmpd="sng" algn="ctr">
+                      <a:solidFill>
+                        <a:schemeClr val="accent4"/>
+                      </a:solidFill>
+                      <a:prstDash val="solid"/>
+                      <a:round/>
+                      <a:headEnd type="none" w="med" len="med"/>
+                      <a:tailEnd type="none" w="med" len="med"/>
+                    </a:lnT>
+                    <a:lnB w="6350" cap="flat" cmpd="sng" algn="ctr">
+                      <a:solidFill>
+                        <a:schemeClr val="accent4"/>
+                      </a:solidFill>
+                      <a:prstDash val="solid"/>
+                      <a:round/>
+                      <a:headEnd type="none" w="med" len="med"/>
+                      <a:tailEnd type="none" w="med" len="med"/>
+                    </a:lnB>
+                    <a:solidFill>
+                      <a:schemeClr val="bg2"/>
+                    </a:solidFill>
+                  </a:tcPr>
+                </a:tc>
+                <a:tc>
+                  <a:txBody>
+                    <a:bodyPr/>
+                    <a:lstStyle/>
+                    <a:p>
+                      <a:pPr indent="0" marL="0">
+                        <a:buNone/>
+                      </a:pPr>
+                      <a:r>
+                        <a:rPr lang="en-US" sz="1200" dirty="0">
+                          <a:solidFill>
+                            <a:schemeClr val="tx1"/>
+                          </a:solidFill>
+                          <a:latin typeface="Calibri" pitchFamily="34" charset="0"/>
+                          <a:ea typeface="Calibri" pitchFamily="34" charset="-122"/>
+                          <a:cs typeface="Calibri" pitchFamily="34" charset="-120"/>
+                        </a:rPr>
+                        <a:t>1.27</a:t>
                       </a:r>
                       <a:endParaRPr lang="en-US" sz="1200" dirty="0">
                         <a:latin typeface="Calibri" charset="0"/>
@@ -9564,7 +9837,7 @@
                           <a:ea typeface="Calibri" pitchFamily="34" charset="-122"/>
                           <a:cs typeface="Calibri" pitchFamily="34" charset="-120"/>
                         </a:rPr>
-                        <a:t>87 %</a:t>
+                        <a:t>451 (420-471)</a:t>
                       </a:r>
                       <a:endParaRPr lang="en-US" sz="1200" dirty="0">
                         <a:latin typeface="Calibri" charset="0"/>
@@ -9632,7 +9905,75 @@
                           <a:ea typeface="Calibri" pitchFamily="34" charset="-122"/>
                           <a:cs typeface="Calibri" pitchFamily="34" charset="-120"/>
                         </a:rPr>
-                        <a:t>1.47</a:t>
+                        <a:t>86 %</a:t>
+                      </a:r>
+                      <a:endParaRPr lang="en-US" sz="1200" dirty="0">
+                        <a:latin typeface="Calibri" charset="0"/>
+                        <a:ea typeface="Calibri" charset="0"/>
+                        <a:cs typeface="Calibri" charset="0"/>
+                      </a:endParaRPr>
+                    </a:p>
+                  </a:txBody>
+                  <a:tcPr marL="54864" marR="54864" marT="45720" marB="45720">
+                    <a:lnL w="6350" cap="flat" cmpd="sng" algn="ctr">
+                      <a:solidFill>
+                        <a:schemeClr val="accent4"/>
+                      </a:solidFill>
+                      <a:prstDash val="solid"/>
+                      <a:round/>
+                      <a:headEnd type="none" w="med" len="med"/>
+                      <a:tailEnd type="none" w="med" len="med"/>
+                    </a:lnL>
+                    <a:lnR w="6350" cap="flat" cmpd="sng" algn="ctr">
+                      <a:solidFill>
+                        <a:schemeClr val="accent4"/>
+                      </a:solidFill>
+                      <a:prstDash val="solid"/>
+                      <a:round/>
+                      <a:headEnd type="none" w="med" len="med"/>
+                      <a:tailEnd type="none" w="med" len="med"/>
+                    </a:lnR>
+                    <a:lnT w="6350" cap="flat" cmpd="sng" algn="ctr">
+                      <a:solidFill>
+                        <a:schemeClr val="accent4"/>
+                      </a:solidFill>
+                      <a:prstDash val="solid"/>
+                      <a:round/>
+                      <a:headEnd type="none" w="med" len="med"/>
+                      <a:tailEnd type="none" w="med" len="med"/>
+                    </a:lnT>
+                    <a:lnB w="6350" cap="flat" cmpd="sng" algn="ctr">
+                      <a:solidFill>
+                        <a:schemeClr val="accent4"/>
+                      </a:solidFill>
+                      <a:prstDash val="solid"/>
+                      <a:round/>
+                      <a:headEnd type="none" w="med" len="med"/>
+                      <a:tailEnd type="none" w="med" len="med"/>
+                    </a:lnB>
+                    <a:solidFill>
+                      <a:schemeClr val="bg1"/>
+                    </a:solidFill>
+                  </a:tcPr>
+                </a:tc>
+                <a:tc>
+                  <a:txBody>
+                    <a:bodyPr/>
+                    <a:lstStyle/>
+                    <a:p>
+                      <a:pPr indent="0" marL="0">
+                        <a:buNone/>
+                      </a:pPr>
+                      <a:r>
+                        <a:rPr lang="en-US" sz="1200" dirty="0">
+                          <a:solidFill>
+                            <a:schemeClr val="tx1"/>
+                          </a:solidFill>
+                          <a:latin typeface="Calibri" pitchFamily="34" charset="0"/>
+                          <a:ea typeface="Calibri" pitchFamily="34" charset="-122"/>
+                          <a:cs typeface="Calibri" pitchFamily="34" charset="-120"/>
+                        </a:rPr>
+                        <a:t>1.58</a:t>
                       </a:r>
                       <a:endParaRPr lang="en-US" sz="1200" dirty="0">
                         <a:latin typeface="Calibri" charset="0"/>
@@ -9696,8 +10037,8 @@
         </p:nvSpPr>
         <p:spPr>
           <a:xfrm>
-            <a:off x="457200" y="4160520"/>
-            <a:ext cx="8229600" cy="640080"/>
+            <a:off x="457200" y="4114800"/>
+            <a:ext cx="8229600" cy="685800"/>
           </a:xfrm>
           <a:prstGeom prst="rect">
             <a:avLst/>
@@ -9721,7 +10062,7 @@
                 <a:ea typeface="Calibri" pitchFamily="34" charset="-122"/>
                 <a:cs typeface="Calibri" pitchFamily="34" charset="-120"/>
               </a:rPr>
-              <a:t>prefix_aware had the lowest median TTFT, 2.3x lower than least_connections. Its 95th percentile was 2671 ms, against 1690 ms for swiftserve. Single run: 60 requests per policy, 6 tenants with system prompts of about 1500 tokens, concurrency 8, 4 replicas, policies run one after another.</a:t>
+              <a:t>prefix_aware had the lowest median TTFT in 3 of 3 runs (mean 451 ms; 1.7x lower than swiftserve, 2.2x lower than least_connections). Its 95th-percentile rank across the runs was 4, 2, 2 of 4 (1 is best), so the tail was mixed. Seeds 1, 2, 3, one run in reverse policy order; 60 requests per policy, 6 tenants with system prompts of about 1500 tokens, concurrency 8, 4 replicas.</a:t>
             </a:r>
             <a:endParaRPr lang="en-US" sz="1300" dirty="0"/>
           </a:p>

</xml_diff>